<commit_message>
Update project briefing deck
Co-Authored-By: Claude Opus 5 <noreply@anthropic.com>
</commit_message>
<xml_diff>
--- a/Reference/briefing project.pptx
+++ b/Reference/briefing project.pptx
@@ -5,16 +5,17 @@
     <p:sldMasterId id="2147483648" r:id="rId1"/>
   </p:sldMasterIdLst>
   <p:notesMasterIdLst>
-    <p:notesMasterId r:id="rId9"/>
+    <p:notesMasterId r:id="rId10"/>
   </p:notesMasterIdLst>
   <p:sldIdLst>
     <p:sldId id="256" r:id="rId2"/>
     <p:sldId id="257" r:id="rId3"/>
     <p:sldId id="261" r:id="rId4"/>
-    <p:sldId id="262" r:id="rId5"/>
-    <p:sldId id="258" r:id="rId6"/>
-    <p:sldId id="259" r:id="rId7"/>
-    <p:sldId id="260" r:id="rId8"/>
+    <p:sldId id="263" r:id="rId5"/>
+    <p:sldId id="262" r:id="rId6"/>
+    <p:sldId id="258" r:id="rId7"/>
+    <p:sldId id="259" r:id="rId8"/>
+    <p:sldId id="260" r:id="rId9"/>
   </p:sldIdLst>
   <p:sldSz cx="12192000" cy="6858000"/>
   <p:notesSz cx="6858000" cy="9144000"/>
@@ -113,6 +114,11 @@
       </a:defRPr>
     </a:lvl9pPr>
   </p:defaultTextStyle>
+  <p:extLst>
+    <p:ext uri="{EFAFB233-063F-42B5-8137-9DF3F51BA10A}">
+      <p15:sldGuideLst xmlns:p15="http://schemas.microsoft.com/office/powerpoint/2012/main"/>
+    </p:ext>
+  </p:extLst>
 </p:presentation>
 </file>
 
@@ -198,7 +204,7 @@
           <a:p>
             <a:fld id="{53B61C8E-81CB-4032-8EA4-7F2345ECEA2B}" type="datetimeFigureOut">
               <a:rPr lang="en-MY" smtClean="0"/>
-              <a:t>24/9/2026</a:t>
+              <a:t>25/9/2026</a:t>
             </a:fld>
             <a:endParaRPr lang="en-MY"/>
           </a:p>
@@ -531,7 +537,7 @@
           <a:p>
             <a:fld id="{92A2204B-A329-4F89-8275-BDC46B5FE054}" type="slidenum">
               <a:rPr lang="en-MY" smtClean="0"/>
-              <a:t>4</a:t>
+              <a:t>5</a:t>
             </a:fld>
             <a:endParaRPr lang="en-MY"/>
           </a:p>
@@ -699,7 +705,7 @@
           <a:p>
             <a:fld id="{4449257F-037A-47B5-A07B-A73CC606E6AA}" type="datetimeFigureOut">
               <a:rPr lang="en-MY" smtClean="0"/>
-              <a:t>24/9/2026</a:t>
+              <a:t>25/9/2026</a:t>
             </a:fld>
             <a:endParaRPr lang="en-MY"/>
           </a:p>
@@ -899,7 +905,7 @@
           <a:p>
             <a:fld id="{4449257F-037A-47B5-A07B-A73CC606E6AA}" type="datetimeFigureOut">
               <a:rPr lang="en-MY" smtClean="0"/>
-              <a:t>24/9/2026</a:t>
+              <a:t>25/9/2026</a:t>
             </a:fld>
             <a:endParaRPr lang="en-MY"/>
           </a:p>
@@ -1109,7 +1115,7 @@
           <a:p>
             <a:fld id="{4449257F-037A-47B5-A07B-A73CC606E6AA}" type="datetimeFigureOut">
               <a:rPr lang="en-MY" smtClean="0"/>
-              <a:t>24/9/2026</a:t>
+              <a:t>25/9/2026</a:t>
             </a:fld>
             <a:endParaRPr lang="en-MY"/>
           </a:p>
@@ -1309,7 +1315,7 @@
           <a:p>
             <a:fld id="{4449257F-037A-47B5-A07B-A73CC606E6AA}" type="datetimeFigureOut">
               <a:rPr lang="en-MY" smtClean="0"/>
-              <a:t>24/9/2026</a:t>
+              <a:t>25/9/2026</a:t>
             </a:fld>
             <a:endParaRPr lang="en-MY"/>
           </a:p>
@@ -1585,7 +1591,7 @@
           <a:p>
             <a:fld id="{4449257F-037A-47B5-A07B-A73CC606E6AA}" type="datetimeFigureOut">
               <a:rPr lang="en-MY" smtClean="0"/>
-              <a:t>24/9/2026</a:t>
+              <a:t>25/9/2026</a:t>
             </a:fld>
             <a:endParaRPr lang="en-MY"/>
           </a:p>
@@ -1853,7 +1859,7 @@
           <a:p>
             <a:fld id="{4449257F-037A-47B5-A07B-A73CC606E6AA}" type="datetimeFigureOut">
               <a:rPr lang="en-MY" smtClean="0"/>
-              <a:t>24/9/2026</a:t>
+              <a:t>25/9/2026</a:t>
             </a:fld>
             <a:endParaRPr lang="en-MY"/>
           </a:p>
@@ -2268,7 +2274,7 @@
           <a:p>
             <a:fld id="{4449257F-037A-47B5-A07B-A73CC606E6AA}" type="datetimeFigureOut">
               <a:rPr lang="en-MY" smtClean="0"/>
-              <a:t>24/9/2026</a:t>
+              <a:t>25/9/2026</a:t>
             </a:fld>
             <a:endParaRPr lang="en-MY"/>
           </a:p>
@@ -2410,7 +2416,7 @@
           <a:p>
             <a:fld id="{4449257F-037A-47B5-A07B-A73CC606E6AA}" type="datetimeFigureOut">
               <a:rPr lang="en-MY" smtClean="0"/>
-              <a:t>24/9/2026</a:t>
+              <a:t>25/9/2026</a:t>
             </a:fld>
             <a:endParaRPr lang="en-MY"/>
           </a:p>
@@ -2523,7 +2529,7 @@
           <a:p>
             <a:fld id="{4449257F-037A-47B5-A07B-A73CC606E6AA}" type="datetimeFigureOut">
               <a:rPr lang="en-MY" smtClean="0"/>
-              <a:t>24/9/2026</a:t>
+              <a:t>25/9/2026</a:t>
             </a:fld>
             <a:endParaRPr lang="en-MY"/>
           </a:p>
@@ -2836,7 +2842,7 @@
           <a:p>
             <a:fld id="{4449257F-037A-47B5-A07B-A73CC606E6AA}" type="datetimeFigureOut">
               <a:rPr lang="en-MY" smtClean="0"/>
-              <a:t>24/9/2026</a:t>
+              <a:t>25/9/2026</a:t>
             </a:fld>
             <a:endParaRPr lang="en-MY"/>
           </a:p>
@@ -3125,7 +3131,7 @@
           <a:p>
             <a:fld id="{4449257F-037A-47B5-A07B-A73CC606E6AA}" type="datetimeFigureOut">
               <a:rPr lang="en-MY" smtClean="0"/>
-              <a:t>24/9/2026</a:t>
+              <a:t>25/9/2026</a:t>
             </a:fld>
             <a:endParaRPr lang="en-MY"/>
           </a:p>
@@ -3368,7 +3374,7 @@
           <a:p>
             <a:fld id="{4449257F-037A-47B5-A07B-A73CC606E6AA}" type="datetimeFigureOut">
               <a:rPr lang="en-MY" smtClean="0"/>
-              <a:t>24/9/2026</a:t>
+              <a:t>25/9/2026</a:t>
             </a:fld>
             <a:endParaRPr lang="en-MY"/>
           </a:p>
@@ -4073,6 +4079,116 @@
           <a:chExt cx="0" cy="0"/>
         </a:xfrm>
       </p:grpSpPr>
+      <p:sp>
+        <p:nvSpPr>
+          <p:cNvPr id="2" name="Title 1">
+            <a:extLst>
+              <a:ext uri="{FF2B5EF4-FFF2-40B4-BE49-F238E27FC236}">
+                <a16:creationId xmlns:a16="http://schemas.microsoft.com/office/drawing/2014/main" id="{6AB102DB-84CB-EBC0-04DC-6196642082A5}"/>
+              </a:ext>
+            </a:extLst>
+          </p:cNvPr>
+          <p:cNvSpPr>
+            <a:spLocks noGrp="1"/>
+          </p:cNvSpPr>
+          <p:nvPr>
+            <p:ph type="title"/>
+          </p:nvPr>
+        </p:nvSpPr>
+        <p:spPr/>
+        <p:txBody>
+          <a:bodyPr/>
+          <a:lstStyle/>
+          <a:p>
+            <a:endParaRPr lang="en-MY"/>
+          </a:p>
+        </p:txBody>
+      </p:sp>
+      <p:sp>
+        <p:nvSpPr>
+          <p:cNvPr id="3" name="Content Placeholder 2">
+            <a:extLst>
+              <a:ext uri="{FF2B5EF4-FFF2-40B4-BE49-F238E27FC236}">
+                <a16:creationId xmlns:a16="http://schemas.microsoft.com/office/drawing/2014/main" id="{DE1B2A23-FDBE-B9F6-4E17-39A499D085A5}"/>
+              </a:ext>
+            </a:extLst>
+          </p:cNvPr>
+          <p:cNvSpPr>
+            <a:spLocks noGrp="1"/>
+          </p:cNvSpPr>
+          <p:nvPr>
+            <p:ph idx="1"/>
+          </p:nvPr>
+        </p:nvSpPr>
+        <p:spPr/>
+        <p:txBody>
+          <a:bodyPr/>
+          <a:lstStyle/>
+          <a:p>
+            <a:endParaRPr lang="en-MY"/>
+          </a:p>
+        </p:txBody>
+      </p:sp>
+      <p:pic>
+        <p:nvPicPr>
+          <p:cNvPr id="5" name="Picture 4">
+            <a:extLst>
+              <a:ext uri="{FF2B5EF4-FFF2-40B4-BE49-F238E27FC236}">
+                <a16:creationId xmlns:a16="http://schemas.microsoft.com/office/drawing/2014/main" id="{727148DF-A696-D930-3040-1214516EA426}"/>
+              </a:ext>
+            </a:extLst>
+          </p:cNvPr>
+          <p:cNvPicPr>
+            <a:picLocks noChangeAspect="1"/>
+          </p:cNvPicPr>
+          <p:nvPr/>
+        </p:nvPicPr>
+        <p:blipFill>
+          <a:blip r:embed="rId2"/>
+          <a:stretch>
+            <a:fillRect/>
+          </a:stretch>
+        </p:blipFill>
+        <p:spPr>
+          <a:xfrm>
+            <a:off x="0" y="135448"/>
+            <a:ext cx="12192000" cy="6587104"/>
+          </a:xfrm>
+          <a:prstGeom prst="rect">
+            <a:avLst/>
+          </a:prstGeom>
+        </p:spPr>
+      </p:pic>
+    </p:spTree>
+    <p:extLst>
+      <p:ext uri="{BB962C8B-B14F-4D97-AF65-F5344CB8AC3E}">
+        <p14:creationId xmlns:p14="http://schemas.microsoft.com/office/powerpoint/2010/main" val="3974596999"/>
+      </p:ext>
+    </p:extLst>
+  </p:cSld>
+  <p:clrMapOvr>
+    <a:masterClrMapping/>
+  </p:clrMapOvr>
+</p:sld>
+</file>
+
+<file path=ppt/slides/slide5.xml><?xml version="1.0" encoding="utf-8"?>
+<p:sld xmlns:a="http://schemas.openxmlformats.org/drawingml/2006/main" xmlns:r="http://schemas.openxmlformats.org/officeDocument/2006/relationships" xmlns:p="http://schemas.openxmlformats.org/presentationml/2006/main">
+  <p:cSld>
+    <p:spTree>
+      <p:nvGrpSpPr>
+        <p:cNvPr id="1" name=""/>
+        <p:cNvGrpSpPr/>
+        <p:nvPr/>
+      </p:nvGrpSpPr>
+      <p:grpSpPr>
+        <a:xfrm>
+          <a:off x="0" y="0"/>
+          <a:ext cx="0" cy="0"/>
+          <a:chOff x="0" y="0"/>
+          <a:chExt cx="0" cy="0"/>
+        </a:xfrm>
+      </p:grpSpPr>
       <p:pic>
         <p:nvPicPr>
           <p:cNvPr id="3" name="Picture 2">
@@ -4212,7 +4328,7 @@
 </p:sld>
 </file>
 
-<file path=ppt/slides/slide5.xml><?xml version="1.0" encoding="utf-8"?>
+<file path=ppt/slides/slide6.xml><?xml version="1.0" encoding="utf-8"?>
 <p:sld xmlns:a="http://schemas.openxmlformats.org/drawingml/2006/main" xmlns:r="http://schemas.openxmlformats.org/officeDocument/2006/relationships" xmlns:p="http://schemas.openxmlformats.org/presentationml/2006/main">
   <p:cSld>
     <p:spTree>
@@ -4235,56 +4351,418 @@
           <a:chExt cx="0" cy="0"/>
         </a:xfrm>
       </p:grpSpPr>
-      <p:sp>
-        <p:nvSpPr>
-          <p:cNvPr id="2" name="Title 1">
-            <a:extLst>
-              <a:ext uri="{FF2B5EF4-FFF2-40B4-BE49-F238E27FC236}">
-                <a16:creationId xmlns:a16="http://schemas.microsoft.com/office/drawing/2014/main" id="{3CBA1851-5741-41BF-5D6D-F27E93EAA930}"/>
-              </a:ext>
-            </a:extLst>
-          </p:cNvPr>
-          <p:cNvSpPr>
-            <a:spLocks noGrp="1"/>
-          </p:cNvSpPr>
-          <p:nvPr>
-            <p:ph type="ctrTitle"/>
-          </p:nvPr>
-        </p:nvSpPr>
-        <p:spPr/>
-        <p:txBody>
-          <a:bodyPr/>
-          <a:lstStyle/>
-          <a:p>
-            <a:endParaRPr lang="en-MY"/>
-          </a:p>
-        </p:txBody>
-      </p:sp>
-      <p:sp>
-        <p:nvSpPr>
-          <p:cNvPr id="3" name="Subtitle 2">
-            <a:extLst>
-              <a:ext uri="{FF2B5EF4-FFF2-40B4-BE49-F238E27FC236}">
-                <a16:creationId xmlns:a16="http://schemas.microsoft.com/office/drawing/2014/main" id="{3FE69BCE-3BB5-6E7B-1C48-0E5992A85CCF}"/>
-              </a:ext>
-            </a:extLst>
-          </p:cNvPr>
-          <p:cNvSpPr>
-            <a:spLocks noGrp="1"/>
-          </p:cNvSpPr>
-          <p:nvPr>
-            <p:ph type="subTitle" idx="1"/>
-          </p:nvPr>
-        </p:nvSpPr>
-        <p:spPr/>
-        <p:txBody>
-          <a:bodyPr/>
-          <a:lstStyle/>
-          <a:p>
-            <a:endParaRPr lang="en-MY"/>
-          </a:p>
-        </p:txBody>
-      </p:sp>
+      <p:graphicFrame>
+        <p:nvGraphicFramePr>
+          <p:cNvPr id="4" name="Table 3">
+            <a:extLst>
+              <a:ext uri="{FF2B5EF4-FFF2-40B4-BE49-F238E27FC236}">
+                <a16:creationId xmlns:a16="http://schemas.microsoft.com/office/drawing/2014/main" id="{73168720-CD8E-1528-9B84-CD8D3ED60D34}"/>
+              </a:ext>
+            </a:extLst>
+          </p:cNvPr>
+          <p:cNvGraphicFramePr>
+            <a:graphicFrameLocks noGrp="1"/>
+          </p:cNvGraphicFramePr>
+          <p:nvPr>
+            <p:extLst>
+              <p:ext uri="{D42A27DB-BD31-4B8C-83A1-F6EECF244321}">
+                <p14:modId xmlns:p14="http://schemas.microsoft.com/office/powerpoint/2010/main" val="2178567685"/>
+              </p:ext>
+            </p:extLst>
+          </p:nvPr>
+        </p:nvGraphicFramePr>
+        <p:xfrm>
+          <a:off x="622299" y="824441"/>
+          <a:ext cx="10683876" cy="2392680"/>
+        </p:xfrm>
+        <a:graphic>
+          <a:graphicData uri="http://schemas.openxmlformats.org/drawingml/2006/table">
+            <a:tbl>
+              <a:tblPr firstRow="1" bandRow="1">
+                <a:tableStyleId>{5C22544A-7EE6-4342-B048-85BDC9FD1C3A}</a:tableStyleId>
+              </a:tblPr>
+              <a:tblGrid>
+                <a:gridCol w="1339851">
+                  <a:extLst>
+                    <a:ext uri="{9D8B030D-6E8A-4147-A177-3AD203B41FA5}">
+                      <a16:colId xmlns:a16="http://schemas.microsoft.com/office/drawing/2014/main" val="2248621125"/>
+                    </a:ext>
+                  </a:extLst>
+                </a:gridCol>
+                <a:gridCol w="1638300">
+                  <a:extLst>
+                    <a:ext uri="{9D8B030D-6E8A-4147-A177-3AD203B41FA5}">
+                      <a16:colId xmlns:a16="http://schemas.microsoft.com/office/drawing/2014/main" val="3636599589"/>
+                    </a:ext>
+                  </a:extLst>
+                </a:gridCol>
+                <a:gridCol w="2266950">
+                  <a:extLst>
+                    <a:ext uri="{9D8B030D-6E8A-4147-A177-3AD203B41FA5}">
+                      <a16:colId xmlns:a16="http://schemas.microsoft.com/office/drawing/2014/main" val="4132384581"/>
+                    </a:ext>
+                  </a:extLst>
+                </a:gridCol>
+                <a:gridCol w="5438775">
+                  <a:extLst>
+                    <a:ext uri="{9D8B030D-6E8A-4147-A177-3AD203B41FA5}">
+                      <a16:colId xmlns:a16="http://schemas.microsoft.com/office/drawing/2014/main" val="1897485437"/>
+                    </a:ext>
+                  </a:extLst>
+                </a:gridCol>
+              </a:tblGrid>
+              <a:tr h="370840">
+                <a:tc>
+                  <a:txBody>
+                    <a:bodyPr/>
+                    <a:lstStyle/>
+                    <a:p>
+                      <a:r>
+                        <a:rPr lang="en-US" dirty="0"/>
+                        <a:t>MODEL</a:t>
+                      </a:r>
+                      <a:endParaRPr lang="en-MY" dirty="0"/>
+                    </a:p>
+                  </a:txBody>
+                  <a:tcPr/>
+                </a:tc>
+                <a:tc>
+                  <a:txBody>
+                    <a:bodyPr/>
+                    <a:lstStyle/>
+                    <a:p>
+                      <a:r>
+                        <a:rPr lang="en-US" dirty="0"/>
+                        <a:t>CURRENT VERISON</a:t>
+                      </a:r>
+                      <a:endParaRPr lang="en-MY" dirty="0"/>
+                    </a:p>
+                  </a:txBody>
+                  <a:tcPr/>
+                </a:tc>
+                <a:tc>
+                  <a:txBody>
+                    <a:bodyPr/>
+                    <a:lstStyle/>
+                    <a:p>
+                      <a:r>
+                        <a:rPr lang="en-US" dirty="0"/>
+                        <a:t>ACCESIBLE VERSION</a:t>
+                      </a:r>
+                      <a:endParaRPr lang="en-MY" dirty="0"/>
+                    </a:p>
+                  </a:txBody>
+                  <a:tcPr/>
+                </a:tc>
+                <a:tc>
+                  <a:txBody>
+                    <a:bodyPr/>
+                    <a:lstStyle/>
+                    <a:p>
+                      <a:r>
+                        <a:rPr lang="en-US" dirty="0"/>
+                        <a:t>SOURCE</a:t>
+                      </a:r>
+                      <a:endParaRPr lang="en-MY" dirty="0"/>
+                    </a:p>
+                  </a:txBody>
+                  <a:tcPr/>
+                </a:tc>
+                <a:extLst>
+                  <a:ext uri="{0D108BD9-81ED-4DB2-BD59-A6C34878D82A}">
+                    <a16:rowId xmlns:a16="http://schemas.microsoft.com/office/drawing/2014/main" val="1207422866"/>
+                  </a:ext>
+                </a:extLst>
+              </a:tr>
+              <a:tr h="370840">
+                <a:tc>
+                  <a:txBody>
+                    <a:bodyPr/>
+                    <a:lstStyle/>
+                    <a:p>
+                      <a:r>
+                        <a:rPr lang="en-US" dirty="0"/>
+                        <a:t>QWEN</a:t>
+                      </a:r>
+                      <a:endParaRPr lang="en-MY" dirty="0"/>
+                    </a:p>
+                  </a:txBody>
+                  <a:tcPr/>
+                </a:tc>
+                <a:tc>
+                  <a:txBody>
+                    <a:bodyPr/>
+                    <a:lstStyle/>
+                    <a:p>
+                      <a:r>
+                        <a:rPr lang="en-MY" sz="1800" b="0" i="0" kern="1200" dirty="0">
+                          <a:solidFill>
+                            <a:schemeClr val="dk1"/>
+                          </a:solidFill>
+                          <a:effectLst/>
+                          <a:latin typeface="+mn-lt"/>
+                          <a:ea typeface="+mn-ea"/>
+                          <a:cs typeface="+mn-cs"/>
+                        </a:rPr>
+                        <a:t>Qwen3.7-Plus</a:t>
+                      </a:r>
+                      <a:endParaRPr lang="en-MY" dirty="0"/>
+                    </a:p>
+                  </a:txBody>
+                  <a:tcPr/>
+                </a:tc>
+                <a:tc>
+                  <a:txBody>
+                    <a:bodyPr/>
+                    <a:lstStyle/>
+                    <a:p>
+                      <a:r>
+                        <a:rPr lang="en-MY" sz="1800" b="0" i="0" kern="1200" dirty="0">
+                          <a:solidFill>
+                            <a:schemeClr val="dk1"/>
+                          </a:solidFill>
+                          <a:effectLst/>
+                          <a:latin typeface="+mn-lt"/>
+                          <a:ea typeface="+mn-ea"/>
+                          <a:cs typeface="+mn-cs"/>
+                        </a:rPr>
+                        <a:t>Qwen3.8-Max</a:t>
+                      </a:r>
+                      <a:endParaRPr lang="en-MY" dirty="0"/>
+                    </a:p>
+                  </a:txBody>
+                  <a:tcPr/>
+                </a:tc>
+                <a:tc>
+                  <a:txBody>
+                    <a:bodyPr/>
+                    <a:lstStyle/>
+                    <a:p>
+                      <a:pPr marL="285750" indent="-285750">
+                        <a:buFont typeface="Arial" panose="020B0604020202020204" pitchFamily="34" charset="0"/>
+                        <a:buChar char="•"/>
+                      </a:pPr>
+                      <a:r>
+                        <a:rPr lang="en-US" dirty="0" err="1"/>
+                        <a:t>OpenRouter</a:t>
+                      </a:r>
+                      <a:endParaRPr lang="en-US" dirty="0"/>
+                    </a:p>
+                    <a:p>
+                      <a:pPr marL="285750" indent="-285750">
+                        <a:buFont typeface="Arial" panose="020B0604020202020204" pitchFamily="34" charset="0"/>
+                        <a:buChar char="•"/>
+                      </a:pPr>
+                      <a:r>
+                        <a:rPr lang="en-US" dirty="0"/>
+                        <a:t>Alibaba Cloud – hanging in sign up</a:t>
+                      </a:r>
+                      <a:endParaRPr lang="en-MY" dirty="0"/>
+                    </a:p>
+                  </a:txBody>
+                  <a:tcPr/>
+                </a:tc>
+                <a:extLst>
+                  <a:ext uri="{0D108BD9-81ED-4DB2-BD59-A6C34878D82A}">
+                    <a16:rowId xmlns:a16="http://schemas.microsoft.com/office/drawing/2014/main" val="2693724503"/>
+                  </a:ext>
+                </a:extLst>
+              </a:tr>
+              <a:tr h="370840">
+                <a:tc>
+                  <a:txBody>
+                    <a:bodyPr/>
+                    <a:lstStyle/>
+                    <a:p>
+                      <a:r>
+                        <a:rPr lang="en-US" dirty="0"/>
+                        <a:t>GEMINI</a:t>
+                      </a:r>
+                    </a:p>
+                  </a:txBody>
+                  <a:tcPr/>
+                </a:tc>
+                <a:tc>
+                  <a:txBody>
+                    <a:bodyPr/>
+                    <a:lstStyle/>
+                    <a:p>
+                      <a:r>
+                        <a:rPr lang="en-US" dirty="0"/>
+                        <a:t>3.6 Flash</a:t>
+                      </a:r>
+                      <a:endParaRPr lang="en-MY" dirty="0"/>
+                    </a:p>
+                  </a:txBody>
+                  <a:tcPr/>
+                </a:tc>
+                <a:tc>
+                  <a:txBody>
+                    <a:bodyPr/>
+                    <a:lstStyle/>
+                    <a:p>
+                      <a:pPr marL="0" marR="0" lvl="0" indent="0" algn="l" defTabSz="914400" rtl="0" eaLnBrk="1" fontAlgn="auto" latinLnBrk="0" hangingPunct="1">
+                        <a:lnSpc>
+                          <a:spcPct val="100000"/>
+                        </a:lnSpc>
+                        <a:spcBef>
+                          <a:spcPts val="0"/>
+                        </a:spcBef>
+                        <a:spcAft>
+                          <a:spcPts val="0"/>
+                        </a:spcAft>
+                        <a:buClrTx/>
+                        <a:buSzTx/>
+                        <a:buFontTx/>
+                        <a:buNone/>
+                        <a:tabLst/>
+                        <a:defRPr/>
+                      </a:pPr>
+                      <a:r>
+                        <a:rPr lang="en-US" dirty="0"/>
+                        <a:t>3.6 Flash</a:t>
+                      </a:r>
+                      <a:endParaRPr lang="en-MY" dirty="0"/>
+                    </a:p>
+                  </a:txBody>
+                  <a:tcPr/>
+                </a:tc>
+                <a:tc>
+                  <a:txBody>
+                    <a:bodyPr/>
+                    <a:lstStyle/>
+                    <a:p>
+                      <a:endParaRPr lang="en-MY" dirty="0"/>
+                    </a:p>
+                  </a:txBody>
+                  <a:tcPr/>
+                </a:tc>
+                <a:extLst>
+                  <a:ext uri="{0D108BD9-81ED-4DB2-BD59-A6C34878D82A}">
+                    <a16:rowId xmlns:a16="http://schemas.microsoft.com/office/drawing/2014/main" val="2802612630"/>
+                  </a:ext>
+                </a:extLst>
+              </a:tr>
+              <a:tr h="370840">
+                <a:tc>
+                  <a:txBody>
+                    <a:bodyPr/>
+                    <a:lstStyle/>
+                    <a:p>
+                      <a:r>
+                        <a:rPr lang="en-US" dirty="0"/>
+                        <a:t>CHATGPT</a:t>
+                      </a:r>
+                      <a:endParaRPr lang="en-MY" dirty="0"/>
+                    </a:p>
+                  </a:txBody>
+                  <a:tcPr/>
+                </a:tc>
+                <a:tc>
+                  <a:txBody>
+                    <a:bodyPr/>
+                    <a:lstStyle/>
+                    <a:p>
+                      <a:r>
+                        <a:rPr lang="en-MY" dirty="0"/>
+                        <a:t>GPT-6-astra</a:t>
+                      </a:r>
+                    </a:p>
+                  </a:txBody>
+                  <a:tcPr/>
+                </a:tc>
+                <a:tc>
+                  <a:txBody>
+                    <a:bodyPr/>
+                    <a:lstStyle/>
+                    <a:p>
+                      <a:r>
+                        <a:rPr lang="en-MY" b="0" dirty="0"/>
+                        <a:t>GPT-5.6 Luna.</a:t>
+                      </a:r>
+                    </a:p>
+                  </a:txBody>
+                  <a:tcPr/>
+                </a:tc>
+                <a:tc>
+                  <a:txBody>
+                    <a:bodyPr/>
+                    <a:lstStyle/>
+                    <a:p>
+                      <a:endParaRPr lang="en-MY" dirty="0"/>
+                    </a:p>
+                  </a:txBody>
+                  <a:tcPr/>
+                </a:tc>
+                <a:extLst>
+                  <a:ext uri="{0D108BD9-81ED-4DB2-BD59-A6C34878D82A}">
+                    <a16:rowId xmlns:a16="http://schemas.microsoft.com/office/drawing/2014/main" val="4086284599"/>
+                  </a:ext>
+                </a:extLst>
+              </a:tr>
+              <a:tr h="370840">
+                <a:tc>
+                  <a:txBody>
+                    <a:bodyPr/>
+                    <a:lstStyle/>
+                    <a:p>
+                      <a:r>
+                        <a:rPr lang="en-US" dirty="0"/>
+                        <a:t>CLAUDE</a:t>
+                      </a:r>
+                      <a:endParaRPr lang="en-MY" dirty="0"/>
+                    </a:p>
+                  </a:txBody>
+                  <a:tcPr/>
+                </a:tc>
+                <a:tc>
+                  <a:txBody>
+                    <a:bodyPr/>
+                    <a:lstStyle/>
+                    <a:p>
+                      <a:r>
+                        <a:rPr lang="en-US" dirty="0"/>
+                        <a:t>Opus 5</a:t>
+                      </a:r>
+                      <a:endParaRPr lang="en-MY" dirty="0"/>
+                    </a:p>
+                  </a:txBody>
+                  <a:tcPr/>
+                </a:tc>
+                <a:tc>
+                  <a:txBody>
+                    <a:bodyPr/>
+                    <a:lstStyle/>
+                    <a:p>
+                      <a:r>
+                        <a:rPr lang="en-US" dirty="0"/>
+                        <a:t>Opus 5.5</a:t>
+                      </a:r>
+                      <a:endParaRPr lang="en-MY" dirty="0"/>
+                    </a:p>
+                  </a:txBody>
+                  <a:tcPr/>
+                </a:tc>
+                <a:tc>
+                  <a:txBody>
+                    <a:bodyPr/>
+                    <a:lstStyle/>
+                    <a:p>
+                      <a:endParaRPr lang="en-MY" dirty="0"/>
+                    </a:p>
+                  </a:txBody>
+                  <a:tcPr/>
+                </a:tc>
+                <a:extLst>
+                  <a:ext uri="{0D108BD9-81ED-4DB2-BD59-A6C34878D82A}">
+                    <a16:rowId xmlns:a16="http://schemas.microsoft.com/office/drawing/2014/main" val="1379532360"/>
+                  </a:ext>
+                </a:extLst>
+              </a:tr>
+            </a:tbl>
+          </a:graphicData>
+        </a:graphic>
+      </p:graphicFrame>
     </p:spTree>
     <p:extLst>
       <p:ext uri="{BB962C8B-B14F-4D97-AF65-F5344CB8AC3E}">
@@ -4298,7 +4776,7 @@
 </p:sld>
 </file>
 
-<file path=ppt/slides/slide6.xml><?xml version="1.0" encoding="utf-8"?>
+<file path=ppt/slides/slide7.xml><?xml version="1.0" encoding="utf-8"?>
 <p:sld xmlns:a="http://schemas.openxmlformats.org/drawingml/2006/main" xmlns:r="http://schemas.openxmlformats.org/officeDocument/2006/relationships" xmlns:p="http://schemas.openxmlformats.org/presentationml/2006/main">
   <p:cSld>
     <p:spTree>
@@ -4384,7 +4862,7 @@
 </p:sld>
 </file>
 
-<file path=ppt/slides/slide7.xml><?xml version="1.0" encoding="utf-8"?>
+<file path=ppt/slides/slide8.xml><?xml version="1.0" encoding="utf-8"?>
 <p:sld xmlns:a="http://schemas.openxmlformats.org/drawingml/2006/main" xmlns:r="http://schemas.openxmlformats.org/officeDocument/2006/relationships" xmlns:p="http://schemas.openxmlformats.org/presentationml/2006/main">
   <p:cSld>
     <p:spTree>

</xml_diff>

<commit_message>
Insert UI Merge Table
</commit_message>
<xml_diff>
--- a/Reference/briefing project.pptx
+++ b/Reference/briefing project.pptx
@@ -204,7 +204,7 @@
           <a:p>
             <a:fld id="{53B61C8E-81CB-4032-8EA4-7F2345ECEA2B}" type="datetimeFigureOut">
               <a:rPr lang="en-MY" smtClean="0"/>
-              <a:t>25/9/2026</a:t>
+              <a:t>30/9/2026</a:t>
             </a:fld>
             <a:endParaRPr lang="en-MY"/>
           </a:p>
@@ -705,7 +705,7 @@
           <a:p>
             <a:fld id="{4449257F-037A-47B5-A07B-A73CC606E6AA}" type="datetimeFigureOut">
               <a:rPr lang="en-MY" smtClean="0"/>
-              <a:t>25/9/2026</a:t>
+              <a:t>30/9/2026</a:t>
             </a:fld>
             <a:endParaRPr lang="en-MY"/>
           </a:p>
@@ -905,7 +905,7 @@
           <a:p>
             <a:fld id="{4449257F-037A-47B5-A07B-A73CC606E6AA}" type="datetimeFigureOut">
               <a:rPr lang="en-MY" smtClean="0"/>
-              <a:t>25/9/2026</a:t>
+              <a:t>30/9/2026</a:t>
             </a:fld>
             <a:endParaRPr lang="en-MY"/>
           </a:p>
@@ -1115,7 +1115,7 @@
           <a:p>
             <a:fld id="{4449257F-037A-47B5-A07B-A73CC606E6AA}" type="datetimeFigureOut">
               <a:rPr lang="en-MY" smtClean="0"/>
-              <a:t>25/9/2026</a:t>
+              <a:t>30/9/2026</a:t>
             </a:fld>
             <a:endParaRPr lang="en-MY"/>
           </a:p>
@@ -1315,7 +1315,7 @@
           <a:p>
             <a:fld id="{4449257F-037A-47B5-A07B-A73CC606E6AA}" type="datetimeFigureOut">
               <a:rPr lang="en-MY" smtClean="0"/>
-              <a:t>25/9/2026</a:t>
+              <a:t>30/9/2026</a:t>
             </a:fld>
             <a:endParaRPr lang="en-MY"/>
           </a:p>
@@ -1591,7 +1591,7 @@
           <a:p>
             <a:fld id="{4449257F-037A-47B5-A07B-A73CC606E6AA}" type="datetimeFigureOut">
               <a:rPr lang="en-MY" smtClean="0"/>
-              <a:t>25/9/2026</a:t>
+              <a:t>30/9/2026</a:t>
             </a:fld>
             <a:endParaRPr lang="en-MY"/>
           </a:p>
@@ -1859,7 +1859,7 @@
           <a:p>
             <a:fld id="{4449257F-037A-47B5-A07B-A73CC606E6AA}" type="datetimeFigureOut">
               <a:rPr lang="en-MY" smtClean="0"/>
-              <a:t>25/9/2026</a:t>
+              <a:t>30/9/2026</a:t>
             </a:fld>
             <a:endParaRPr lang="en-MY"/>
           </a:p>
@@ -2274,7 +2274,7 @@
           <a:p>
             <a:fld id="{4449257F-037A-47B5-A07B-A73CC606E6AA}" type="datetimeFigureOut">
               <a:rPr lang="en-MY" smtClean="0"/>
-              <a:t>25/9/2026</a:t>
+              <a:t>30/9/2026</a:t>
             </a:fld>
             <a:endParaRPr lang="en-MY"/>
           </a:p>
@@ -2416,7 +2416,7 @@
           <a:p>
             <a:fld id="{4449257F-037A-47B5-A07B-A73CC606E6AA}" type="datetimeFigureOut">
               <a:rPr lang="en-MY" smtClean="0"/>
-              <a:t>25/9/2026</a:t>
+              <a:t>30/9/2026</a:t>
             </a:fld>
             <a:endParaRPr lang="en-MY"/>
           </a:p>
@@ -2529,7 +2529,7 @@
           <a:p>
             <a:fld id="{4449257F-037A-47B5-A07B-A73CC606E6AA}" type="datetimeFigureOut">
               <a:rPr lang="en-MY" smtClean="0"/>
-              <a:t>25/9/2026</a:t>
+              <a:t>30/9/2026</a:t>
             </a:fld>
             <a:endParaRPr lang="en-MY"/>
           </a:p>
@@ -2842,7 +2842,7 @@
           <a:p>
             <a:fld id="{4449257F-037A-47B5-A07B-A73CC606E6AA}" type="datetimeFigureOut">
               <a:rPr lang="en-MY" smtClean="0"/>
-              <a:t>25/9/2026</a:t>
+              <a:t>30/9/2026</a:t>
             </a:fld>
             <a:endParaRPr lang="en-MY"/>
           </a:p>
@@ -3131,7 +3131,7 @@
           <a:p>
             <a:fld id="{4449257F-037A-47B5-A07B-A73CC606E6AA}" type="datetimeFigureOut">
               <a:rPr lang="en-MY" smtClean="0"/>
-              <a:t>25/9/2026</a:t>
+              <a:t>30/9/2026</a:t>
             </a:fld>
             <a:endParaRPr lang="en-MY"/>
           </a:p>
@@ -3374,7 +3374,7 @@
           <a:p>
             <a:fld id="{4449257F-037A-47B5-A07B-A73CC606E6AA}" type="datetimeFigureOut">
               <a:rPr lang="en-MY" smtClean="0"/>
-              <a:t>25/9/2026</a:t>
+              <a:t>30/9/2026</a:t>
             </a:fld>
             <a:endParaRPr lang="en-MY"/>
           </a:p>
@@ -4799,52 +4799,91 @@
           <a:chExt cx="0" cy="0"/>
         </a:xfrm>
       </p:grpSpPr>
-      <p:sp>
-        <p:nvSpPr>
-          <p:cNvPr id="2" name="Title 1">
-            <a:extLst>
-              <a:ext uri="{FF2B5EF4-FFF2-40B4-BE49-F238E27FC236}">
-                <a16:creationId xmlns:a16="http://schemas.microsoft.com/office/drawing/2014/main" id="{05F33231-0FD4-BB4D-A2BD-9B3D3D91DFC6}"/>
-              </a:ext>
-            </a:extLst>
-          </p:cNvPr>
-          <p:cNvSpPr>
-            <a:spLocks noGrp="1"/>
-          </p:cNvSpPr>
-          <p:nvPr>
-            <p:ph type="ctrTitle"/>
-          </p:nvPr>
-        </p:nvSpPr>
-        <p:spPr/>
-        <p:txBody>
-          <a:bodyPr/>
-          <a:lstStyle/>
-          <a:p>
-            <a:endParaRPr lang="en-MY"/>
-          </a:p>
-        </p:txBody>
-      </p:sp>
-      <p:sp>
-        <p:nvSpPr>
-          <p:cNvPr id="3" name="Subtitle 2">
-            <a:extLst>
-              <a:ext uri="{FF2B5EF4-FFF2-40B4-BE49-F238E27FC236}">
-                <a16:creationId xmlns:a16="http://schemas.microsoft.com/office/drawing/2014/main" id="{2711388E-385E-C565-7D83-17262A553C66}"/>
-              </a:ext>
-            </a:extLst>
-          </p:cNvPr>
-          <p:cNvSpPr>
-            <a:spLocks noGrp="1"/>
-          </p:cNvSpPr>
-          <p:nvPr>
-            <p:ph type="subTitle" idx="1"/>
-          </p:nvPr>
-        </p:nvSpPr>
-        <p:spPr/>
-        <p:txBody>
-          <a:bodyPr/>
-          <a:lstStyle/>
-          <a:p>
+      <p:pic>
+        <p:nvPicPr>
+          <p:cNvPr id="4" name="Picture 3">
+            <a:extLst>
+              <a:ext uri="{FF2B5EF4-FFF2-40B4-BE49-F238E27FC236}">
+                <a16:creationId xmlns:a16="http://schemas.microsoft.com/office/drawing/2014/main" id="{77D91245-E5C6-D447-245C-69D3709435F4}"/>
+              </a:ext>
+              <a:ext uri="{C183D7F6-B498-43B3-948B-1728B52AA6E4}">
+                <adec:decorative xmlns:adec="http://schemas.microsoft.com/office/drawing/2017/decorative" val="1"/>
+              </a:ext>
+            </a:extLst>
+          </p:cNvPr>
+          <p:cNvPicPr>
+            <a:picLocks noChangeAspect="1"/>
+          </p:cNvPicPr>
+          <p:nvPr/>
+        </p:nvPicPr>
+        <p:blipFill>
+          <a:blip r:embed="rId2"/>
+          <a:stretch>
+            <a:fillRect/>
+          </a:stretch>
+        </p:blipFill>
+        <p:spPr>
+          <a:xfrm>
+            <a:off x="200024" y="1455366"/>
+            <a:ext cx="11744325" cy="3014513"/>
+          </a:xfrm>
+          <a:prstGeom prst="rect">
+            <a:avLst/>
+          </a:prstGeom>
+        </p:spPr>
+      </p:pic>
+      <p:sp>
+        <p:nvSpPr>
+          <p:cNvPr id="5" name="Rectangle 4">
+            <a:extLst>
+              <a:ext uri="{FF2B5EF4-FFF2-40B4-BE49-F238E27FC236}">
+                <a16:creationId xmlns:a16="http://schemas.microsoft.com/office/drawing/2014/main" id="{0BD4AD33-1CDF-A3D1-127B-EEB983C0C9D8}"/>
+              </a:ext>
+            </a:extLst>
+          </p:cNvPr>
+          <p:cNvSpPr/>
+          <p:nvPr/>
+        </p:nvSpPr>
+        <p:spPr>
+          <a:xfrm>
+            <a:off x="457200" y="3429000"/>
+            <a:ext cx="609600" cy="586740"/>
+          </a:xfrm>
+          <a:prstGeom prst="rect">
+            <a:avLst/>
+          </a:prstGeom>
+          <a:solidFill>
+            <a:schemeClr val="bg1"/>
+          </a:solidFill>
+          <a:ln>
+            <a:solidFill>
+              <a:schemeClr val="bg1">
+                <a:lumMod val="95000"/>
+              </a:schemeClr>
+            </a:solidFill>
+          </a:ln>
+        </p:spPr>
+        <p:style>
+          <a:lnRef idx="2">
+            <a:schemeClr val="accent1">
+              <a:shade val="15000"/>
+            </a:schemeClr>
+          </a:lnRef>
+          <a:fillRef idx="1">
+            <a:schemeClr val="accent1"/>
+          </a:fillRef>
+          <a:effectRef idx="0">
+            <a:schemeClr val="accent1"/>
+          </a:effectRef>
+          <a:fontRef idx="minor">
+            <a:schemeClr val="lt1"/>
+          </a:fontRef>
+        </p:style>
+        <p:txBody>
+          <a:bodyPr rtlCol="0" anchor="ctr"/>
+          <a:lstStyle/>
+          <a:p>
+            <a:pPr algn="ctr"/>
             <a:endParaRPr lang="en-MY"/>
           </a:p>
         </p:txBody>

</xml_diff>

<commit_message>
Updated UI and model Gen AI
</commit_message>
<xml_diff>
--- a/Reference/briefing project.pptx
+++ b/Reference/briefing project.pptx
@@ -5,7 +5,7 @@
     <p:sldMasterId id="2147483648" r:id="rId1"/>
   </p:sldMasterIdLst>
   <p:notesMasterIdLst>
-    <p:notesMasterId r:id="rId10"/>
+    <p:notesMasterId r:id="rId11"/>
   </p:notesMasterIdLst>
   <p:sldIdLst>
     <p:sldId id="256" r:id="rId2"/>
@@ -15,7 +15,8 @@
     <p:sldId id="262" r:id="rId6"/>
     <p:sldId id="258" r:id="rId7"/>
     <p:sldId id="259" r:id="rId8"/>
-    <p:sldId id="260" r:id="rId9"/>
+    <p:sldId id="264" r:id="rId9"/>
+    <p:sldId id="260" r:id="rId10"/>
   </p:sldIdLst>
   <p:sldSz cx="12192000" cy="6858000"/>
   <p:notesSz cx="6858000" cy="9144000"/>
@@ -204,7 +205,7 @@
           <a:p>
             <a:fld id="{53B61C8E-81CB-4032-8EA4-7F2345ECEA2B}" type="datetimeFigureOut">
               <a:rPr lang="en-MY" smtClean="0"/>
-              <a:t>30/9/2026</a:t>
+              <a:t>1/10/2026</a:t>
             </a:fld>
             <a:endParaRPr lang="en-MY"/>
           </a:p>
@@ -705,7 +706,7 @@
           <a:p>
             <a:fld id="{4449257F-037A-47B5-A07B-A73CC606E6AA}" type="datetimeFigureOut">
               <a:rPr lang="en-MY" smtClean="0"/>
-              <a:t>30/9/2026</a:t>
+              <a:t>1/10/2026</a:t>
             </a:fld>
             <a:endParaRPr lang="en-MY"/>
           </a:p>
@@ -905,7 +906,7 @@
           <a:p>
             <a:fld id="{4449257F-037A-47B5-A07B-A73CC606E6AA}" type="datetimeFigureOut">
               <a:rPr lang="en-MY" smtClean="0"/>
-              <a:t>30/9/2026</a:t>
+              <a:t>1/10/2026</a:t>
             </a:fld>
             <a:endParaRPr lang="en-MY"/>
           </a:p>
@@ -1115,7 +1116,7 @@
           <a:p>
             <a:fld id="{4449257F-037A-47B5-A07B-A73CC606E6AA}" type="datetimeFigureOut">
               <a:rPr lang="en-MY" smtClean="0"/>
-              <a:t>30/9/2026</a:t>
+              <a:t>1/10/2026</a:t>
             </a:fld>
             <a:endParaRPr lang="en-MY"/>
           </a:p>
@@ -1315,7 +1316,7 @@
           <a:p>
             <a:fld id="{4449257F-037A-47B5-A07B-A73CC606E6AA}" type="datetimeFigureOut">
               <a:rPr lang="en-MY" smtClean="0"/>
-              <a:t>30/9/2026</a:t>
+              <a:t>1/10/2026</a:t>
             </a:fld>
             <a:endParaRPr lang="en-MY"/>
           </a:p>
@@ -1591,7 +1592,7 @@
           <a:p>
             <a:fld id="{4449257F-037A-47B5-A07B-A73CC606E6AA}" type="datetimeFigureOut">
               <a:rPr lang="en-MY" smtClean="0"/>
-              <a:t>30/9/2026</a:t>
+              <a:t>1/10/2026</a:t>
             </a:fld>
             <a:endParaRPr lang="en-MY"/>
           </a:p>
@@ -1859,7 +1860,7 @@
           <a:p>
             <a:fld id="{4449257F-037A-47B5-A07B-A73CC606E6AA}" type="datetimeFigureOut">
               <a:rPr lang="en-MY" smtClean="0"/>
-              <a:t>30/9/2026</a:t>
+              <a:t>1/10/2026</a:t>
             </a:fld>
             <a:endParaRPr lang="en-MY"/>
           </a:p>
@@ -2274,7 +2275,7 @@
           <a:p>
             <a:fld id="{4449257F-037A-47B5-A07B-A73CC606E6AA}" type="datetimeFigureOut">
               <a:rPr lang="en-MY" smtClean="0"/>
-              <a:t>30/9/2026</a:t>
+              <a:t>1/10/2026</a:t>
             </a:fld>
             <a:endParaRPr lang="en-MY"/>
           </a:p>
@@ -2416,7 +2417,7 @@
           <a:p>
             <a:fld id="{4449257F-037A-47B5-A07B-A73CC606E6AA}" type="datetimeFigureOut">
               <a:rPr lang="en-MY" smtClean="0"/>
-              <a:t>30/9/2026</a:t>
+              <a:t>1/10/2026</a:t>
             </a:fld>
             <a:endParaRPr lang="en-MY"/>
           </a:p>
@@ -2529,7 +2530,7 @@
           <a:p>
             <a:fld id="{4449257F-037A-47B5-A07B-A73CC606E6AA}" type="datetimeFigureOut">
               <a:rPr lang="en-MY" smtClean="0"/>
-              <a:t>30/9/2026</a:t>
+              <a:t>1/10/2026</a:t>
             </a:fld>
             <a:endParaRPr lang="en-MY"/>
           </a:p>
@@ -2842,7 +2843,7 @@
           <a:p>
             <a:fld id="{4449257F-037A-47B5-A07B-A73CC606E6AA}" type="datetimeFigureOut">
               <a:rPr lang="en-MY" smtClean="0"/>
-              <a:t>30/9/2026</a:t>
+              <a:t>1/10/2026</a:t>
             </a:fld>
             <a:endParaRPr lang="en-MY"/>
           </a:p>
@@ -3131,7 +3132,7 @@
           <a:p>
             <a:fld id="{4449257F-037A-47B5-A07B-A73CC606E6AA}" type="datetimeFigureOut">
               <a:rPr lang="en-MY" smtClean="0"/>
-              <a:t>30/9/2026</a:t>
+              <a:t>1/10/2026</a:t>
             </a:fld>
             <a:endParaRPr lang="en-MY"/>
           </a:p>
@@ -3374,7 +3375,7 @@
           <a:p>
             <a:fld id="{4449257F-037A-47B5-A07B-A73CC606E6AA}" type="datetimeFigureOut">
               <a:rPr lang="en-MY" smtClean="0"/>
-              <a:t>30/9/2026</a:t>
+              <a:t>1/10/2026</a:t>
             </a:fld>
             <a:endParaRPr lang="en-MY"/>
           </a:p>
@@ -4909,6 +4910,131 @@
         <p:cNvPr id="1" name="">
           <a:extLst>
             <a:ext uri="{FF2B5EF4-FFF2-40B4-BE49-F238E27FC236}">
+              <a16:creationId xmlns:a16="http://schemas.microsoft.com/office/drawing/2014/main" id="{D3FDFF93-8F9C-9945-0605-D960B71FEDE4}"/>
+            </a:ext>
+          </a:extLst>
+        </p:cNvPr>
+        <p:cNvGrpSpPr/>
+        <p:nvPr/>
+      </p:nvGrpSpPr>
+      <p:grpSpPr>
+        <a:xfrm>
+          <a:off x="0" y="0"/>
+          <a:ext cx="0" cy="0"/>
+          <a:chOff x="0" y="0"/>
+          <a:chExt cx="0" cy="0"/>
+        </a:xfrm>
+      </p:grpSpPr>
+      <p:sp>
+        <p:nvSpPr>
+          <p:cNvPr id="5" name="Rectangle 4">
+            <a:extLst>
+              <a:ext uri="{FF2B5EF4-FFF2-40B4-BE49-F238E27FC236}">
+                <a16:creationId xmlns:a16="http://schemas.microsoft.com/office/drawing/2014/main" id="{6D56EE7D-8DA0-36B8-ED99-B0613A929CF9}"/>
+              </a:ext>
+            </a:extLst>
+          </p:cNvPr>
+          <p:cNvSpPr/>
+          <p:nvPr/>
+        </p:nvSpPr>
+        <p:spPr>
+          <a:xfrm>
+            <a:off x="457200" y="3429000"/>
+            <a:ext cx="609600" cy="586740"/>
+          </a:xfrm>
+          <a:prstGeom prst="rect">
+            <a:avLst/>
+          </a:prstGeom>
+          <a:solidFill>
+            <a:schemeClr val="bg1"/>
+          </a:solidFill>
+          <a:ln>
+            <a:solidFill>
+              <a:schemeClr val="bg1">
+                <a:lumMod val="95000"/>
+              </a:schemeClr>
+            </a:solidFill>
+          </a:ln>
+        </p:spPr>
+        <p:style>
+          <a:lnRef idx="2">
+            <a:schemeClr val="accent1">
+              <a:shade val="15000"/>
+            </a:schemeClr>
+          </a:lnRef>
+          <a:fillRef idx="1">
+            <a:schemeClr val="accent1"/>
+          </a:fillRef>
+          <a:effectRef idx="0">
+            <a:schemeClr val="accent1"/>
+          </a:effectRef>
+          <a:fontRef idx="minor">
+            <a:schemeClr val="lt1"/>
+          </a:fontRef>
+        </p:style>
+        <p:txBody>
+          <a:bodyPr rtlCol="0" anchor="ctr"/>
+          <a:lstStyle/>
+          <a:p>
+            <a:pPr algn="ctr"/>
+            <a:endParaRPr lang="en-MY"/>
+          </a:p>
+        </p:txBody>
+      </p:sp>
+      <p:pic>
+        <p:nvPicPr>
+          <p:cNvPr id="2" name="Picture 1">
+            <a:extLst>
+              <a:ext uri="{FF2B5EF4-FFF2-40B4-BE49-F238E27FC236}">
+                <a16:creationId xmlns:a16="http://schemas.microsoft.com/office/drawing/2014/main" id="{CCD9954F-2A7E-9589-0DC3-CF923F0FDA33}"/>
+              </a:ext>
+              <a:ext uri="{C183D7F6-B498-43B3-948B-1728B52AA6E4}">
+                <adec:decorative xmlns:adec="http://schemas.microsoft.com/office/drawing/2017/decorative" val="1"/>
+              </a:ext>
+            </a:extLst>
+          </p:cNvPr>
+          <p:cNvPicPr>
+            <a:picLocks noChangeAspect="1"/>
+          </p:cNvPicPr>
+          <p:nvPr/>
+        </p:nvPicPr>
+        <p:blipFill>
+          <a:blip r:embed="rId2"/>
+          <a:stretch>
+            <a:fillRect/>
+          </a:stretch>
+        </p:blipFill>
+        <p:spPr>
+          <a:xfrm>
+            <a:off x="761999" y="886389"/>
+            <a:ext cx="10825879" cy="3825311"/>
+          </a:xfrm>
+          <a:prstGeom prst="rect">
+            <a:avLst/>
+          </a:prstGeom>
+        </p:spPr>
+      </p:pic>
+    </p:spTree>
+    <p:extLst>
+      <p:ext uri="{BB962C8B-B14F-4D97-AF65-F5344CB8AC3E}">
+        <p14:creationId xmlns:p14="http://schemas.microsoft.com/office/powerpoint/2010/main" val="227469368"/>
+      </p:ext>
+    </p:extLst>
+  </p:cSld>
+  <p:clrMapOvr>
+    <a:masterClrMapping/>
+  </p:clrMapOvr>
+</p:sld>
+</file>
+
+<file path=ppt/slides/slide9.xml><?xml version="1.0" encoding="utf-8"?>
+<p:sld xmlns:a="http://schemas.openxmlformats.org/drawingml/2006/main" xmlns:r="http://schemas.openxmlformats.org/officeDocument/2006/relationships" xmlns:p="http://schemas.openxmlformats.org/presentationml/2006/main">
+  <p:cSld>
+    <p:spTree>
+      <p:nvGrpSpPr>
+        <p:cNvPr id="1" name="">
+          <a:extLst>
+            <a:ext uri="{FF2B5EF4-FFF2-40B4-BE49-F238E27FC236}">
               <a16:creationId xmlns:a16="http://schemas.microsoft.com/office/drawing/2014/main" id="{E1D75DBC-198B-47D8-936C-45B002D434DD}"/>
             </a:ext>
           </a:extLst>
@@ -4974,6 +5100,39 @@
           </a:p>
         </p:txBody>
       </p:sp>
+      <p:pic>
+        <p:nvPicPr>
+          <p:cNvPr id="4" name="Picture 3">
+            <a:extLst>
+              <a:ext uri="{FF2B5EF4-FFF2-40B4-BE49-F238E27FC236}">
+                <a16:creationId xmlns:a16="http://schemas.microsoft.com/office/drawing/2014/main" id="{0546B129-0176-0F9C-EF47-6756B5CDAD7E}"/>
+              </a:ext>
+              <a:ext uri="{C183D7F6-B498-43B3-948B-1728B52AA6E4}">
+                <adec:decorative xmlns:adec="http://schemas.microsoft.com/office/drawing/2017/decorative" val="1"/>
+              </a:ext>
+            </a:extLst>
+          </p:cNvPr>
+          <p:cNvPicPr>
+            <a:picLocks noChangeAspect="1"/>
+          </p:cNvPicPr>
+          <p:nvPr/>
+        </p:nvPicPr>
+        <p:blipFill>
+          <a:blip r:embed="rId2"/>
+          <a:stretch>
+            <a:fillRect/>
+          </a:stretch>
+        </p:blipFill>
+        <p:spPr>
+          <a:xfrm>
+            <a:off x="660399" y="1129867"/>
+            <a:ext cx="11032067" cy="4760192"/>
+          </a:xfrm>
+          <a:prstGeom prst="rect">
+            <a:avLst/>
+          </a:prstGeom>
+        </p:spPr>
+      </p:pic>
     </p:spTree>
     <p:extLst>
       <p:ext uri="{BB962C8B-B14F-4D97-AF65-F5344CB8AC3E}">

</xml_diff>

<commit_message>
Refine SCL translation result and warning handling
</commit_message>
<xml_diff>
--- a/Reference/briefing project.pptx
+++ b/Reference/briefing project.pptx
@@ -205,7 +205,7 @@
           <a:p>
             <a:fld id="{53B61C8E-81CB-4032-8EA4-7F2345ECEA2B}" type="datetimeFigureOut">
               <a:rPr lang="en-MY" smtClean="0"/>
-              <a:t>1/10/2026</a:t>
+              <a:t>5/10/2026</a:t>
             </a:fld>
             <a:endParaRPr lang="en-MY"/>
           </a:p>
@@ -706,7 +706,7 @@
           <a:p>
             <a:fld id="{4449257F-037A-47B5-A07B-A73CC606E6AA}" type="datetimeFigureOut">
               <a:rPr lang="en-MY" smtClean="0"/>
-              <a:t>1/10/2026</a:t>
+              <a:t>5/10/2026</a:t>
             </a:fld>
             <a:endParaRPr lang="en-MY"/>
           </a:p>
@@ -906,7 +906,7 @@
           <a:p>
             <a:fld id="{4449257F-037A-47B5-A07B-A73CC606E6AA}" type="datetimeFigureOut">
               <a:rPr lang="en-MY" smtClean="0"/>
-              <a:t>1/10/2026</a:t>
+              <a:t>5/10/2026</a:t>
             </a:fld>
             <a:endParaRPr lang="en-MY"/>
           </a:p>
@@ -1116,7 +1116,7 @@
           <a:p>
             <a:fld id="{4449257F-037A-47B5-A07B-A73CC606E6AA}" type="datetimeFigureOut">
               <a:rPr lang="en-MY" smtClean="0"/>
-              <a:t>1/10/2026</a:t>
+              <a:t>5/10/2026</a:t>
             </a:fld>
             <a:endParaRPr lang="en-MY"/>
           </a:p>
@@ -1316,7 +1316,7 @@
           <a:p>
             <a:fld id="{4449257F-037A-47B5-A07B-A73CC606E6AA}" type="datetimeFigureOut">
               <a:rPr lang="en-MY" smtClean="0"/>
-              <a:t>1/10/2026</a:t>
+              <a:t>5/10/2026</a:t>
             </a:fld>
             <a:endParaRPr lang="en-MY"/>
           </a:p>
@@ -1592,7 +1592,7 @@
           <a:p>
             <a:fld id="{4449257F-037A-47B5-A07B-A73CC606E6AA}" type="datetimeFigureOut">
               <a:rPr lang="en-MY" smtClean="0"/>
-              <a:t>1/10/2026</a:t>
+              <a:t>5/10/2026</a:t>
             </a:fld>
             <a:endParaRPr lang="en-MY"/>
           </a:p>
@@ -1860,7 +1860,7 @@
           <a:p>
             <a:fld id="{4449257F-037A-47B5-A07B-A73CC606E6AA}" type="datetimeFigureOut">
               <a:rPr lang="en-MY" smtClean="0"/>
-              <a:t>1/10/2026</a:t>
+              <a:t>5/10/2026</a:t>
             </a:fld>
             <a:endParaRPr lang="en-MY"/>
           </a:p>
@@ -2275,7 +2275,7 @@
           <a:p>
             <a:fld id="{4449257F-037A-47B5-A07B-A73CC606E6AA}" type="datetimeFigureOut">
               <a:rPr lang="en-MY" smtClean="0"/>
-              <a:t>1/10/2026</a:t>
+              <a:t>5/10/2026</a:t>
             </a:fld>
             <a:endParaRPr lang="en-MY"/>
           </a:p>
@@ -2417,7 +2417,7 @@
           <a:p>
             <a:fld id="{4449257F-037A-47B5-A07B-A73CC606E6AA}" type="datetimeFigureOut">
               <a:rPr lang="en-MY" smtClean="0"/>
-              <a:t>1/10/2026</a:t>
+              <a:t>5/10/2026</a:t>
             </a:fld>
             <a:endParaRPr lang="en-MY"/>
           </a:p>
@@ -2530,7 +2530,7 @@
           <a:p>
             <a:fld id="{4449257F-037A-47B5-A07B-A73CC606E6AA}" type="datetimeFigureOut">
               <a:rPr lang="en-MY" smtClean="0"/>
-              <a:t>1/10/2026</a:t>
+              <a:t>5/10/2026</a:t>
             </a:fld>
             <a:endParaRPr lang="en-MY"/>
           </a:p>
@@ -2843,7 +2843,7 @@
           <a:p>
             <a:fld id="{4449257F-037A-47B5-A07B-A73CC606E6AA}" type="datetimeFigureOut">
               <a:rPr lang="en-MY" smtClean="0"/>
-              <a:t>1/10/2026</a:t>
+              <a:t>5/10/2026</a:t>
             </a:fld>
             <a:endParaRPr lang="en-MY"/>
           </a:p>
@@ -3132,7 +3132,7 @@
           <a:p>
             <a:fld id="{4449257F-037A-47B5-A07B-A73CC606E6AA}" type="datetimeFigureOut">
               <a:rPr lang="en-MY" smtClean="0"/>
-              <a:t>1/10/2026</a:t>
+              <a:t>5/10/2026</a:t>
             </a:fld>
             <a:endParaRPr lang="en-MY"/>
           </a:p>
@@ -3375,7 +3375,7 @@
           <a:p>
             <a:fld id="{4449257F-037A-47B5-A07B-A73CC606E6AA}" type="datetimeFigureOut">
               <a:rPr lang="en-MY" smtClean="0"/>
-              <a:t>1/10/2026</a:t>
+              <a:t>5/10/2026</a:t>
             </a:fld>
             <a:endParaRPr lang="en-MY"/>
           </a:p>
@@ -5050,56 +5050,6 @@
           <a:chExt cx="0" cy="0"/>
         </a:xfrm>
       </p:grpSpPr>
-      <p:sp>
-        <p:nvSpPr>
-          <p:cNvPr id="2" name="Title 1">
-            <a:extLst>
-              <a:ext uri="{FF2B5EF4-FFF2-40B4-BE49-F238E27FC236}">
-                <a16:creationId xmlns:a16="http://schemas.microsoft.com/office/drawing/2014/main" id="{C134A006-6422-F159-2155-6FE7E1B787D4}"/>
-              </a:ext>
-            </a:extLst>
-          </p:cNvPr>
-          <p:cNvSpPr>
-            <a:spLocks noGrp="1"/>
-          </p:cNvSpPr>
-          <p:nvPr>
-            <p:ph type="ctrTitle"/>
-          </p:nvPr>
-        </p:nvSpPr>
-        <p:spPr/>
-        <p:txBody>
-          <a:bodyPr/>
-          <a:lstStyle/>
-          <a:p>
-            <a:endParaRPr lang="en-MY"/>
-          </a:p>
-        </p:txBody>
-      </p:sp>
-      <p:sp>
-        <p:nvSpPr>
-          <p:cNvPr id="3" name="Subtitle 2">
-            <a:extLst>
-              <a:ext uri="{FF2B5EF4-FFF2-40B4-BE49-F238E27FC236}">
-                <a16:creationId xmlns:a16="http://schemas.microsoft.com/office/drawing/2014/main" id="{F97606BC-267E-234F-6AA8-537B25A7919D}"/>
-              </a:ext>
-            </a:extLst>
-          </p:cNvPr>
-          <p:cNvSpPr>
-            <a:spLocks noGrp="1"/>
-          </p:cNvSpPr>
-          <p:nvPr>
-            <p:ph type="subTitle" idx="1"/>
-          </p:nvPr>
-        </p:nvSpPr>
-        <p:spPr/>
-        <p:txBody>
-          <a:bodyPr/>
-          <a:lstStyle/>
-          <a:p>
-            <a:endParaRPr lang="en-MY"/>
-          </a:p>
-        </p:txBody>
-      </p:sp>
       <p:pic>
         <p:nvPicPr>
           <p:cNvPr id="4" name="Picture 3">
@@ -5119,14 +5069,15 @@
         </p:nvPicPr>
         <p:blipFill>
           <a:blip r:embed="rId2"/>
+          <a:srcRect l="-2520" t="-2147" r="-730" b="-843"/>
           <a:stretch>
             <a:fillRect/>
           </a:stretch>
         </p:blipFill>
         <p:spPr>
           <a:xfrm>
-            <a:off x="660399" y="1129867"/>
-            <a:ext cx="11032067" cy="4760192"/>
+            <a:off x="115504" y="875899"/>
+            <a:ext cx="11665818" cy="5020837"/>
           </a:xfrm>
           <a:prstGeom prst="rect">
             <a:avLst/>

</xml_diff>

<commit_message>
All quota model empty
</commit_message>
<xml_diff>
--- a/Reference/briefing project.pptx
+++ b/Reference/briefing project.pptx
@@ -14,9 +14,9 @@
     <p:sldId id="263" r:id="rId5"/>
     <p:sldId id="262" r:id="rId6"/>
     <p:sldId id="258" r:id="rId7"/>
-    <p:sldId id="259" r:id="rId8"/>
+    <p:sldId id="260" r:id="rId8"/>
     <p:sldId id="264" r:id="rId9"/>
-    <p:sldId id="260" r:id="rId10"/>
+    <p:sldId id="265" r:id="rId10"/>
   </p:sldIdLst>
   <p:sldSz cx="12192000" cy="6858000"/>
   <p:notesSz cx="6858000" cy="9144000"/>
@@ -205,7 +205,7 @@
           <a:p>
             <a:fld id="{53B61C8E-81CB-4032-8EA4-7F2345ECEA2B}" type="datetimeFigureOut">
               <a:rPr lang="en-MY" smtClean="0"/>
-              <a:t>5/10/2026</a:t>
+              <a:t>7/10/2026</a:t>
             </a:fld>
             <a:endParaRPr lang="en-MY"/>
           </a:p>
@@ -706,7 +706,7 @@
           <a:p>
             <a:fld id="{4449257F-037A-47B5-A07B-A73CC606E6AA}" type="datetimeFigureOut">
               <a:rPr lang="en-MY" smtClean="0"/>
-              <a:t>5/10/2026</a:t>
+              <a:t>7/10/2026</a:t>
             </a:fld>
             <a:endParaRPr lang="en-MY"/>
           </a:p>
@@ -906,7 +906,7 @@
           <a:p>
             <a:fld id="{4449257F-037A-47B5-A07B-A73CC606E6AA}" type="datetimeFigureOut">
               <a:rPr lang="en-MY" smtClean="0"/>
-              <a:t>5/10/2026</a:t>
+              <a:t>7/10/2026</a:t>
             </a:fld>
             <a:endParaRPr lang="en-MY"/>
           </a:p>
@@ -1116,7 +1116,7 @@
           <a:p>
             <a:fld id="{4449257F-037A-47B5-A07B-A73CC606E6AA}" type="datetimeFigureOut">
               <a:rPr lang="en-MY" smtClean="0"/>
-              <a:t>5/10/2026</a:t>
+              <a:t>7/10/2026</a:t>
             </a:fld>
             <a:endParaRPr lang="en-MY"/>
           </a:p>
@@ -1316,7 +1316,7 @@
           <a:p>
             <a:fld id="{4449257F-037A-47B5-A07B-A73CC606E6AA}" type="datetimeFigureOut">
               <a:rPr lang="en-MY" smtClean="0"/>
-              <a:t>5/10/2026</a:t>
+              <a:t>7/10/2026</a:t>
             </a:fld>
             <a:endParaRPr lang="en-MY"/>
           </a:p>
@@ -1592,7 +1592,7 @@
           <a:p>
             <a:fld id="{4449257F-037A-47B5-A07B-A73CC606E6AA}" type="datetimeFigureOut">
               <a:rPr lang="en-MY" smtClean="0"/>
-              <a:t>5/10/2026</a:t>
+              <a:t>7/10/2026</a:t>
             </a:fld>
             <a:endParaRPr lang="en-MY"/>
           </a:p>
@@ -1860,7 +1860,7 @@
           <a:p>
             <a:fld id="{4449257F-037A-47B5-A07B-A73CC606E6AA}" type="datetimeFigureOut">
               <a:rPr lang="en-MY" smtClean="0"/>
-              <a:t>5/10/2026</a:t>
+              <a:t>7/10/2026</a:t>
             </a:fld>
             <a:endParaRPr lang="en-MY"/>
           </a:p>
@@ -2275,7 +2275,7 @@
           <a:p>
             <a:fld id="{4449257F-037A-47B5-A07B-A73CC606E6AA}" type="datetimeFigureOut">
               <a:rPr lang="en-MY" smtClean="0"/>
-              <a:t>5/10/2026</a:t>
+              <a:t>7/10/2026</a:t>
             </a:fld>
             <a:endParaRPr lang="en-MY"/>
           </a:p>
@@ -2417,7 +2417,7 @@
           <a:p>
             <a:fld id="{4449257F-037A-47B5-A07B-A73CC606E6AA}" type="datetimeFigureOut">
               <a:rPr lang="en-MY" smtClean="0"/>
-              <a:t>5/10/2026</a:t>
+              <a:t>7/10/2026</a:t>
             </a:fld>
             <a:endParaRPr lang="en-MY"/>
           </a:p>
@@ -2530,7 +2530,7 @@
           <a:p>
             <a:fld id="{4449257F-037A-47B5-A07B-A73CC606E6AA}" type="datetimeFigureOut">
               <a:rPr lang="en-MY" smtClean="0"/>
-              <a:t>5/10/2026</a:t>
+              <a:t>7/10/2026</a:t>
             </a:fld>
             <a:endParaRPr lang="en-MY"/>
           </a:p>
@@ -2843,7 +2843,7 @@
           <a:p>
             <a:fld id="{4449257F-037A-47B5-A07B-A73CC606E6AA}" type="datetimeFigureOut">
               <a:rPr lang="en-MY" smtClean="0"/>
-              <a:t>5/10/2026</a:t>
+              <a:t>7/10/2026</a:t>
             </a:fld>
             <a:endParaRPr lang="en-MY"/>
           </a:p>
@@ -3132,7 +3132,7 @@
           <a:p>
             <a:fld id="{4449257F-037A-47B5-A07B-A73CC606E6AA}" type="datetimeFigureOut">
               <a:rPr lang="en-MY" smtClean="0"/>
-              <a:t>5/10/2026</a:t>
+              <a:t>7/10/2026</a:t>
             </a:fld>
             <a:endParaRPr lang="en-MY"/>
           </a:p>
@@ -3375,7 +3375,7 @@
           <a:p>
             <a:fld id="{4449257F-037A-47B5-A07B-A73CC606E6AA}" type="datetimeFigureOut">
               <a:rPr lang="en-MY" smtClean="0"/>
-              <a:t>5/10/2026</a:t>
+              <a:t>7/10/2026</a:t>
             </a:fld>
             <a:endParaRPr lang="en-MY"/>
           </a:p>
@@ -4367,14 +4367,14 @@
           <p:nvPr>
             <p:extLst>
               <p:ext uri="{D42A27DB-BD31-4B8C-83A1-F6EECF244321}">
-                <p14:modId xmlns:p14="http://schemas.microsoft.com/office/powerpoint/2010/main" val="2178567685"/>
+                <p14:modId xmlns:p14="http://schemas.microsoft.com/office/powerpoint/2010/main" val="4156753649"/>
               </p:ext>
             </p:extLst>
           </p:nvPr>
         </p:nvGraphicFramePr>
         <p:xfrm>
-          <a:off x="622299" y="824441"/>
-          <a:ext cx="10683876" cy="2392680"/>
+          <a:off x="690879" y="893021"/>
+          <a:ext cx="11024871" cy="3606800"/>
         </p:xfrm>
         <a:graphic>
           <a:graphicData uri="http://schemas.openxmlformats.org/drawingml/2006/table">
@@ -4383,31 +4383,38 @@
                 <a:tableStyleId>{5C22544A-7EE6-4342-B048-85BDC9FD1C3A}</a:tableStyleId>
               </a:tblPr>
               <a:tblGrid>
-                <a:gridCol w="1339851">
+                <a:gridCol w="1272048">
                   <a:extLst>
                     <a:ext uri="{9D8B030D-6E8A-4147-A177-3AD203B41FA5}">
                       <a16:colId xmlns:a16="http://schemas.microsoft.com/office/drawing/2014/main" val="2248621125"/>
                     </a:ext>
                   </a:extLst>
                 </a:gridCol>
-                <a:gridCol w="1638300">
+                <a:gridCol w="1676074">
+                  <a:extLst>
+                    <a:ext uri="{9D8B030D-6E8A-4147-A177-3AD203B41FA5}">
+                      <a16:colId xmlns:a16="http://schemas.microsoft.com/office/drawing/2014/main" val="272835093"/>
+                    </a:ext>
+                  </a:extLst>
+                </a:gridCol>
+                <a:gridCol w="2077593">
                   <a:extLst>
                     <a:ext uri="{9D8B030D-6E8A-4147-A177-3AD203B41FA5}">
                       <a16:colId xmlns:a16="http://schemas.microsoft.com/office/drawing/2014/main" val="3636599589"/>
                     </a:ext>
                   </a:extLst>
                 </a:gridCol>
-                <a:gridCol w="2266950">
+                <a:gridCol w="2999578">
                   <a:extLst>
                     <a:ext uri="{9D8B030D-6E8A-4147-A177-3AD203B41FA5}">
-                      <a16:colId xmlns:a16="http://schemas.microsoft.com/office/drawing/2014/main" val="4132384581"/>
+                      <a16:colId xmlns:a16="http://schemas.microsoft.com/office/drawing/2014/main" val="1897485437"/>
                     </a:ext>
                   </a:extLst>
                 </a:gridCol>
-                <a:gridCol w="5438775">
+                <a:gridCol w="2999578">
                   <a:extLst>
                     <a:ext uri="{9D8B030D-6E8A-4147-A177-3AD203B41FA5}">
-                      <a16:colId xmlns:a16="http://schemas.microsoft.com/office/drawing/2014/main" val="1897485437"/>
+                      <a16:colId xmlns:a16="http://schemas.microsoft.com/office/drawing/2014/main" val="1294375521"/>
                     </a:ext>
                   </a:extLst>
                 </a:gridCol>
@@ -4418,6 +4425,7 @@
                     <a:bodyPr/>
                     <a:lstStyle/>
                     <a:p>
+                      <a:pPr algn="ctr"/>
                       <a:r>
                         <a:rPr lang="en-US" dirty="0"/>
                         <a:t>MODEL</a:t>
@@ -4432,6 +4440,22 @@
                     <a:bodyPr/>
                     <a:lstStyle/>
                     <a:p>
+                      <a:pPr algn="ctr"/>
+                      <a:r>
+                        <a:rPr lang="en-US" dirty="0"/>
+                        <a:t>SOURCE</a:t>
+                      </a:r>
+                      <a:endParaRPr lang="en-MY" dirty="0"/>
+                    </a:p>
+                  </a:txBody>
+                  <a:tcPr/>
+                </a:tc>
+                <a:tc>
+                  <a:txBody>
+                    <a:bodyPr/>
+                    <a:lstStyle/>
+                    <a:p>
+                      <a:pPr algn="ctr"/>
                       <a:r>
                         <a:rPr lang="en-US" dirty="0"/>
                         <a:t>CURRENT VERISON</a:t>
@@ -4446,9 +4470,10 @@
                     <a:bodyPr/>
                     <a:lstStyle/>
                     <a:p>
+                      <a:pPr algn="ctr"/>
                       <a:r>
                         <a:rPr lang="en-US" dirty="0"/>
-                        <a:t>ACCESIBLE VERSION</a:t>
+                        <a:t>SOURCE</a:t>
                       </a:r>
                       <a:endParaRPr lang="en-MY" dirty="0"/>
                     </a:p>
@@ -4460,9 +4485,10 @@
                     <a:bodyPr/>
                     <a:lstStyle/>
                     <a:p>
+                      <a:pPr algn="ctr"/>
                       <a:r>
                         <a:rPr lang="en-US" dirty="0"/>
-                        <a:t>SOURCE</a:t>
+                        <a:t>COMMENT</a:t>
                       </a:r>
                       <a:endParaRPr lang="en-MY" dirty="0"/>
                     </a:p>
@@ -4476,7 +4502,7 @@
                 </a:extLst>
               </a:tr>
               <a:tr h="370840">
-                <a:tc>
+                <a:tc rowSpan="4">
                   <a:txBody>
                     <a:bodyPr/>
                     <a:lstStyle/>
@@ -4496,16 +4522,8 @@
                     <a:lstStyle/>
                     <a:p>
                       <a:r>
-                        <a:rPr lang="en-MY" sz="1800" b="0" i="0" kern="1200" dirty="0">
-                          <a:solidFill>
-                            <a:schemeClr val="dk1"/>
-                          </a:solidFill>
-                          <a:effectLst/>
-                          <a:latin typeface="+mn-lt"/>
-                          <a:ea typeface="+mn-ea"/>
-                          <a:cs typeface="+mn-cs"/>
-                        </a:rPr>
-                        <a:t>Qwen3.7-Plus</a:t>
+                        <a:rPr lang="en-US" dirty="0" err="1"/>
+                        <a:t>OpenRouter</a:t>
                       </a:r>
                       <a:endParaRPr lang="en-MY" dirty="0"/>
                     </a:p>
@@ -4518,16 +4536,8 @@
                     <a:lstStyle/>
                     <a:p>
                       <a:r>
-                        <a:rPr lang="en-MY" sz="1800" b="0" i="0" kern="1200" dirty="0">
-                          <a:solidFill>
-                            <a:schemeClr val="dk1"/>
-                          </a:solidFill>
-                          <a:effectLst/>
-                          <a:latin typeface="+mn-lt"/>
-                          <a:ea typeface="+mn-ea"/>
-                          <a:cs typeface="+mn-cs"/>
-                        </a:rPr>
-                        <a:t>Qwen3.8-Max</a:t>
+                        <a:rPr lang="en-US" dirty="0"/>
+                        <a:t>Qwen3.8 Flash</a:t>
                       </a:r>
                       <a:endParaRPr lang="en-MY" dirty="0"/>
                     </a:p>
@@ -4544,20 +4554,23 @@
                         <a:buChar char="•"/>
                       </a:pPr>
                       <a:r>
-                        <a:rPr lang="en-US" dirty="0" err="1"/>
-                        <a:t>OpenRouter</a:t>
+                        <a:rPr lang="en-US" dirty="0"/>
+                        <a:t>Cheap and Reliable</a:t>
                       </a:r>
-                      <a:endParaRPr lang="en-US" dirty="0"/>
+                      <a:endParaRPr lang="en-MY" dirty="0"/>
                     </a:p>
+                  </a:txBody>
+                  <a:tcPr/>
+                </a:tc>
+                <a:tc>
+                  <a:txBody>
+                    <a:bodyPr/>
+                    <a:lstStyle/>
                     <a:p>
                       <a:pPr marL="285750" indent="-285750">
                         <a:buFont typeface="Arial" panose="020B0604020202020204" pitchFamily="34" charset="0"/>
                         <a:buChar char="•"/>
                       </a:pPr>
-                      <a:r>
-                        <a:rPr lang="en-US" dirty="0"/>
-                        <a:t>Alibaba Cloud – hanging in sign up</a:t>
-                      </a:r>
                       <a:endParaRPr lang="en-MY" dirty="0"/>
                     </a:p>
                   </a:txBody>
@@ -4570,15 +4583,26 @@
                 </a:extLst>
               </a:tr>
               <a:tr h="370840">
+                <a:tc vMerge="1">
+                  <a:txBody>
+                    <a:bodyPr/>
+                    <a:lstStyle/>
+                    <a:p>
+                      <a:endParaRPr lang="en-MY" dirty="0"/>
+                    </a:p>
+                  </a:txBody>
+                  <a:tcPr/>
+                </a:tc>
                 <a:tc>
                   <a:txBody>
                     <a:bodyPr/>
                     <a:lstStyle/>
                     <a:p>
                       <a:r>
-                        <a:rPr lang="en-US" dirty="0"/>
-                        <a:t>GEMINI</a:t>
+                        <a:rPr lang="en-US" dirty="0" err="1"/>
+                        <a:t>OpenRouter</a:t>
                       </a:r>
+                      <a:endParaRPr lang="en-MY" dirty="0"/>
                     </a:p>
                   </a:txBody>
                   <a:tcPr/>
@@ -4590,7 +4614,70 @@
                     <a:p>
                       <a:r>
                         <a:rPr lang="en-US" dirty="0"/>
-                        <a:t>3.6 Flash</a:t>
+                        <a:t>Qwen3.8 27B</a:t>
+                      </a:r>
+                      <a:endParaRPr lang="en-MY" dirty="0"/>
+                    </a:p>
+                  </a:txBody>
+                  <a:tcPr/>
+                </a:tc>
+                <a:tc>
+                  <a:txBody>
+                    <a:bodyPr/>
+                    <a:lstStyle/>
+                    <a:p>
+                      <a:pPr marL="285750" indent="-285750">
+                        <a:buFont typeface="Arial" panose="020B0604020202020204" pitchFamily="34" charset="0"/>
+                        <a:buChar char="•"/>
+                      </a:pPr>
+                      <a:r>
+                        <a:rPr lang="en-US" dirty="0"/>
+                        <a:t>Free but limited</a:t>
+                      </a:r>
+                      <a:endParaRPr lang="en-MY" dirty="0"/>
+                    </a:p>
+                  </a:txBody>
+                  <a:tcPr/>
+                </a:tc>
+                <a:tc>
+                  <a:txBody>
+                    <a:bodyPr/>
+                    <a:lstStyle/>
+                    <a:p>
+                      <a:pPr marL="285750" indent="-285750">
+                        <a:buFont typeface="Arial" panose="020B0604020202020204" pitchFamily="34" charset="0"/>
+                        <a:buChar char="•"/>
+                      </a:pPr>
+                      <a:endParaRPr lang="en-MY" dirty="0"/>
+                    </a:p>
+                  </a:txBody>
+                  <a:tcPr/>
+                </a:tc>
+                <a:extLst>
+                  <a:ext uri="{0D108BD9-81ED-4DB2-BD59-A6C34878D82A}">
+                    <a16:rowId xmlns:a16="http://schemas.microsoft.com/office/drawing/2014/main" val="843360033"/>
+                  </a:ext>
+                </a:extLst>
+              </a:tr>
+              <a:tr h="370840">
+                <a:tc vMerge="1">
+                  <a:txBody>
+                    <a:bodyPr/>
+                    <a:lstStyle/>
+                    <a:p>
+                      <a:endParaRPr lang="en-MY" dirty="0"/>
+                    </a:p>
+                  </a:txBody>
+                  <a:tcPr/>
+                </a:tc>
+                <a:tc>
+                  <a:txBody>
+                    <a:bodyPr/>
+                    <a:lstStyle/>
+                    <a:p>
+                      <a:r>
+                        <a:rPr lang="en-US" dirty="0" err="1"/>
+                        <a:t>OpenRouter</a:t>
                       </a:r>
                       <a:endParaRPr lang="en-MY" dirty="0"/>
                     </a:p>
@@ -4621,7 +4708,7 @@
                       </a:pPr>
                       <a:r>
                         <a:rPr lang="en-US" dirty="0"/>
-                        <a:t>3.6 Flash</a:t>
+                        <a:t>Qwen3.8 Max</a:t>
                       </a:r>
                       <a:endParaRPr lang="en-MY" dirty="0"/>
                     </a:p>
@@ -4633,6 +4720,32 @@
                     <a:bodyPr/>
                     <a:lstStyle/>
                     <a:p>
+                      <a:pPr marL="285750" indent="-285750">
+                        <a:buFont typeface="Arial" panose="020B0604020202020204" pitchFamily="34" charset="0"/>
+                        <a:buChar char="•"/>
+                      </a:pPr>
+                      <a:r>
+                        <a:rPr lang="en-US" dirty="0"/>
+                        <a:t>Coding, Slower, </a:t>
+                      </a:r>
+                      <a:r>
+                        <a:rPr lang="en-US" dirty="0" err="1"/>
+                        <a:t>pricer</a:t>
+                      </a:r>
+                      <a:endParaRPr lang="en-MY" dirty="0"/>
+                    </a:p>
+                  </a:txBody>
+                  <a:tcPr/>
+                </a:tc>
+                <a:tc>
+                  <a:txBody>
+                    <a:bodyPr/>
+                    <a:lstStyle/>
+                    <a:p>
+                      <a:pPr marL="285750" indent="-285750">
+                        <a:buFont typeface="Arial" panose="020B0604020202020204" pitchFamily="34" charset="0"/>
+                        <a:buChar char="•"/>
+                      </a:pPr>
                       <a:endParaRPr lang="en-MY" dirty="0"/>
                     </a:p>
                   </a:txBody>
@@ -4640,19 +4753,29 @@
                 </a:tc>
                 <a:extLst>
                   <a:ext uri="{0D108BD9-81ED-4DB2-BD59-A6C34878D82A}">
-                    <a16:rowId xmlns:a16="http://schemas.microsoft.com/office/drawing/2014/main" val="2802612630"/>
+                    <a16:rowId xmlns:a16="http://schemas.microsoft.com/office/drawing/2014/main" val="3214709737"/>
                   </a:ext>
                 </a:extLst>
               </a:tr>
               <a:tr h="370840">
+                <a:tc vMerge="1">
+                  <a:txBody>
+                    <a:bodyPr/>
+                    <a:lstStyle/>
+                    <a:p>
+                      <a:endParaRPr lang="en-MY" dirty="0"/>
+                    </a:p>
+                  </a:txBody>
+                  <a:tcPr/>
+                </a:tc>
                 <a:tc>
                   <a:txBody>
                     <a:bodyPr/>
                     <a:lstStyle/>
                     <a:p>
                       <a:r>
-                        <a:rPr lang="en-US" dirty="0"/>
-                        <a:t>CHATGPT</a:t>
+                        <a:rPr lang="en-US" dirty="0" err="1"/>
+                        <a:t>OpenRouter</a:t>
                       </a:r>
                       <a:endParaRPr lang="en-MY" dirty="0"/>
                     </a:p>
@@ -4665,9 +4788,10 @@
                     <a:lstStyle/>
                     <a:p>
                       <a:r>
-                        <a:rPr lang="en-MY" dirty="0"/>
-                        <a:t>GPT-6-astra</a:t>
+                        <a:rPr lang="en-US" dirty="0"/>
+                        <a:t>Gemini 3.1 Flash</a:t>
                       </a:r>
+                      <a:endParaRPr lang="en-MY" dirty="0"/>
                     </a:p>
                   </a:txBody>
                   <a:tcPr/>
@@ -4677,10 +4801,15 @@
                     <a:bodyPr/>
                     <a:lstStyle/>
                     <a:p>
+                      <a:pPr marL="285750" indent="-285750">
+                        <a:buFont typeface="Arial" panose="020B0604020202020204" pitchFamily="34" charset="0"/>
+                        <a:buChar char="•"/>
+                      </a:pPr>
                       <a:r>
-                        <a:rPr lang="en-MY" b="0" dirty="0"/>
-                        <a:t>GPT-5.6 Luna.</a:t>
+                        <a:rPr lang="en-US" dirty="0"/>
+                        <a:t>Cheapest</a:t>
                       </a:r>
+                      <a:endParaRPr lang="en-MY" dirty="0"/>
                     </a:p>
                   </a:txBody>
                   <a:tcPr/>
@@ -4690,6 +4819,10 @@
                     <a:bodyPr/>
                     <a:lstStyle/>
                     <a:p>
+                      <a:pPr marL="285750" indent="-285750">
+                        <a:buFont typeface="Arial" panose="020B0604020202020204" pitchFamily="34" charset="0"/>
+                        <a:buChar char="•"/>
+                      </a:pPr>
                       <a:endParaRPr lang="en-MY" dirty="0"/>
                     </a:p>
                   </a:txBody>
@@ -4697,7 +4830,7 @@
                 </a:tc>
                 <a:extLst>
                   <a:ext uri="{0D108BD9-81ED-4DB2-BD59-A6C34878D82A}">
-                    <a16:rowId xmlns:a16="http://schemas.microsoft.com/office/drawing/2014/main" val="4086284599"/>
+                    <a16:rowId xmlns:a16="http://schemas.microsoft.com/office/drawing/2014/main" val="1033558764"/>
                   </a:ext>
                 </a:extLst>
               </a:tr>
@@ -4709,7 +4842,98 @@
                     <a:p>
                       <a:r>
                         <a:rPr lang="en-US" dirty="0"/>
-                        <a:t>CLAUDE</a:t>
+                        <a:t>Llama</a:t>
+                      </a:r>
+                      <a:endParaRPr lang="en-MY" dirty="0"/>
+                    </a:p>
+                  </a:txBody>
+                  <a:tcPr/>
+                </a:tc>
+                <a:tc>
+                  <a:txBody>
+                    <a:bodyPr/>
+                    <a:lstStyle/>
+                    <a:p>
+                      <a:r>
+                        <a:rPr lang="en-US" dirty="0" err="1"/>
+                        <a:t>Huggingface</a:t>
+                      </a:r>
+                      <a:endParaRPr lang="en-MY" dirty="0"/>
+                    </a:p>
+                  </a:txBody>
+                  <a:tcPr/>
+                </a:tc>
+                <a:tc>
+                  <a:txBody>
+                    <a:bodyPr/>
+                    <a:lstStyle/>
+                    <a:p>
+                      <a:r>
+                        <a:rPr lang="en-US" dirty="0"/>
+                        <a:t>Llama 3.1 8B</a:t>
+                      </a:r>
+                      <a:endParaRPr lang="en-MY" dirty="0"/>
+                    </a:p>
+                  </a:txBody>
+                  <a:tcPr/>
+                </a:tc>
+                <a:tc>
+                  <a:txBody>
+                    <a:bodyPr/>
+                    <a:lstStyle/>
+                    <a:p>
+                      <a:pPr marL="285750" indent="-285750">
+                        <a:buFont typeface="Arial" panose="020B0604020202020204" pitchFamily="34" charset="0"/>
+                        <a:buChar char="•"/>
+                      </a:pPr>
+                      <a:endParaRPr lang="en-MY" dirty="0"/>
+                    </a:p>
+                  </a:txBody>
+                  <a:tcPr/>
+                </a:tc>
+                <a:tc>
+                  <a:txBody>
+                    <a:bodyPr/>
+                    <a:lstStyle/>
+                    <a:p>
+                      <a:pPr marL="285750" indent="-285750">
+                        <a:buFont typeface="Arial" panose="020B0604020202020204" pitchFamily="34" charset="0"/>
+                        <a:buChar char="•"/>
+                      </a:pPr>
+                      <a:endParaRPr lang="en-MY" dirty="0"/>
+                    </a:p>
+                  </a:txBody>
+                  <a:tcPr/>
+                </a:tc>
+                <a:extLst>
+                  <a:ext uri="{0D108BD9-81ED-4DB2-BD59-A6C34878D82A}">
+                    <a16:rowId xmlns:a16="http://schemas.microsoft.com/office/drawing/2014/main" val="3838665083"/>
+                  </a:ext>
+                </a:extLst>
+              </a:tr>
+              <a:tr h="370840">
+                <a:tc rowSpan="2">
+                  <a:txBody>
+                    <a:bodyPr/>
+                    <a:lstStyle/>
+                    <a:p>
+                      <a:r>
+                        <a:rPr lang="en-US" dirty="0"/>
+                        <a:t>Claude</a:t>
+                      </a:r>
+                      <a:endParaRPr lang="en-MY" dirty="0"/>
+                    </a:p>
+                  </a:txBody>
+                  <a:tcPr/>
+                </a:tc>
+                <a:tc>
+                  <a:txBody>
+                    <a:bodyPr/>
+                    <a:lstStyle/>
+                    <a:p>
+                      <a:r>
+                        <a:rPr lang="en-US" dirty="0"/>
+                        <a:t>Subscription</a:t>
                       </a:r>
                       <a:endParaRPr lang="en-MY" dirty="0"/>
                     </a:p>
@@ -4735,10 +4959,159 @@
                     <a:bodyPr/>
                     <a:lstStyle/>
                     <a:p>
+                      <a:pPr marL="285750" indent="-285750">
+                        <a:buFont typeface="Arial" panose="020B0604020202020204" pitchFamily="34" charset="0"/>
+                        <a:buChar char="•"/>
+                      </a:pPr>
+                      <a:endParaRPr lang="en-MY" dirty="0"/>
+                    </a:p>
+                  </a:txBody>
+                  <a:tcPr/>
+                </a:tc>
+                <a:tc>
+                  <a:txBody>
+                    <a:bodyPr/>
+                    <a:lstStyle/>
+                    <a:p>
+                      <a:pPr marL="285750" indent="-285750">
+                        <a:buFont typeface="Arial" panose="020B0604020202020204" pitchFamily="34" charset="0"/>
+                        <a:buChar char="•"/>
+                      </a:pPr>
+                      <a:endParaRPr lang="en-MY" dirty="0"/>
+                    </a:p>
+                  </a:txBody>
+                  <a:tcPr/>
+                </a:tc>
+                <a:extLst>
+                  <a:ext uri="{0D108BD9-81ED-4DB2-BD59-A6C34878D82A}">
+                    <a16:rowId xmlns:a16="http://schemas.microsoft.com/office/drawing/2014/main" val="1309219274"/>
+                  </a:ext>
+                </a:extLst>
+              </a:tr>
+              <a:tr h="370840">
+                <a:tc vMerge="1">
+                  <a:txBody>
+                    <a:bodyPr/>
+                    <a:lstStyle/>
+                    <a:p>
+                      <a:endParaRPr lang="en-MY" dirty="0"/>
+                    </a:p>
+                  </a:txBody>
+                  <a:tcPr/>
+                </a:tc>
+                <a:tc>
+                  <a:txBody>
+                    <a:bodyPr/>
+                    <a:lstStyle/>
+                    <a:p>
                       <a:r>
                         <a:rPr lang="en-US" dirty="0"/>
-                        <a:t>Opus 5.5</a:t>
+                        <a:t>Subscription</a:t>
                       </a:r>
+                      <a:endParaRPr lang="en-MY" dirty="0"/>
+                    </a:p>
+                  </a:txBody>
+                  <a:tcPr/>
+                </a:tc>
+                <a:tc>
+                  <a:txBody>
+                    <a:bodyPr/>
+                    <a:lstStyle/>
+                    <a:p>
+                      <a:r>
+                        <a:rPr lang="en-US" dirty="0"/>
+                        <a:t>Sonnet 5</a:t>
+                      </a:r>
+                      <a:endParaRPr lang="en-MY" dirty="0"/>
+                    </a:p>
+                  </a:txBody>
+                  <a:tcPr/>
+                </a:tc>
+                <a:tc>
+                  <a:txBody>
+                    <a:bodyPr/>
+                    <a:lstStyle/>
+                    <a:p>
+                      <a:pPr marL="285750" indent="-285750">
+                        <a:buFont typeface="Arial" panose="020B0604020202020204" pitchFamily="34" charset="0"/>
+                        <a:buChar char="•"/>
+                      </a:pPr>
+                      <a:r>
+                        <a:rPr lang="en-US" dirty="0"/>
+                        <a:t>Cheaper</a:t>
+                      </a:r>
+                      <a:endParaRPr lang="en-MY" dirty="0"/>
+                    </a:p>
+                  </a:txBody>
+                  <a:tcPr/>
+                </a:tc>
+                <a:tc>
+                  <a:txBody>
+                    <a:bodyPr/>
+                    <a:lstStyle/>
+                    <a:p>
+                      <a:pPr marL="285750" indent="-285750">
+                        <a:buFont typeface="Arial" panose="020B0604020202020204" pitchFamily="34" charset="0"/>
+                        <a:buChar char="•"/>
+                      </a:pPr>
+                      <a:endParaRPr lang="en-MY" dirty="0"/>
+                    </a:p>
+                  </a:txBody>
+                  <a:tcPr/>
+                </a:tc>
+                <a:extLst>
+                  <a:ext uri="{0D108BD9-81ED-4DB2-BD59-A6C34878D82A}">
+                    <a16:rowId xmlns:a16="http://schemas.microsoft.com/office/drawing/2014/main" val="3772802459"/>
+                  </a:ext>
+                </a:extLst>
+              </a:tr>
+              <a:tr h="370840">
+                <a:tc>
+                  <a:txBody>
+                    <a:bodyPr/>
+                    <a:lstStyle/>
+                    <a:p>
+                      <a:r>
+                        <a:rPr lang="en-US" dirty="0"/>
+                        <a:t>CHATGPT</a:t>
+                      </a:r>
+                    </a:p>
+                  </a:txBody>
+                  <a:tcPr/>
+                </a:tc>
+                <a:tc>
+                  <a:txBody>
+                    <a:bodyPr/>
+                    <a:lstStyle/>
+                    <a:p>
+                      <a:r>
+                        <a:rPr lang="en-US" dirty="0" err="1"/>
+                        <a:t>OpenRouter</a:t>
+                      </a:r>
+                      <a:endParaRPr lang="en-MY" dirty="0"/>
+                    </a:p>
+                  </a:txBody>
+                  <a:tcPr/>
+                </a:tc>
+                <a:tc>
+                  <a:txBody>
+                    <a:bodyPr/>
+                    <a:lstStyle/>
+                    <a:p>
+                      <a:r>
+                        <a:rPr lang="en-US" dirty="0"/>
+                        <a:t>GPT 5.6 Luna</a:t>
+                      </a:r>
+                      <a:endParaRPr lang="en-MY" dirty="0"/>
+                    </a:p>
+                  </a:txBody>
+                  <a:tcPr/>
+                </a:tc>
+                <a:tc>
+                  <a:txBody>
+                    <a:bodyPr/>
+                    <a:lstStyle/>
+                    <a:p>
                       <a:endParaRPr lang="en-MY" dirty="0"/>
                     </a:p>
                   </a:txBody>
@@ -4756,7 +5129,7 @@
                 </a:tc>
                 <a:extLst>
                   <a:ext uri="{0D108BD9-81ED-4DB2-BD59-A6C34878D82A}">
-                    <a16:rowId xmlns:a16="http://schemas.microsoft.com/office/drawing/2014/main" val="1379532360"/>
+                    <a16:rowId xmlns:a16="http://schemas.microsoft.com/office/drawing/2014/main" val="2802612630"/>
                   </a:ext>
                 </a:extLst>
               </a:tr>
@@ -4764,6 +5137,42 @@
           </a:graphicData>
         </a:graphic>
       </p:graphicFrame>
+      <p:sp>
+        <p:nvSpPr>
+          <p:cNvPr id="2" name="TextBox 1">
+            <a:extLst>
+              <a:ext uri="{FF2B5EF4-FFF2-40B4-BE49-F238E27FC236}">
+                <a16:creationId xmlns:a16="http://schemas.microsoft.com/office/drawing/2014/main" id="{185DFFCC-89FA-6AAA-F6BF-951C88681140}"/>
+              </a:ext>
+            </a:extLst>
+          </p:cNvPr>
+          <p:cNvSpPr txBox="1"/>
+          <p:nvPr/>
+        </p:nvSpPr>
+        <p:spPr>
+          <a:xfrm>
+            <a:off x="607059" y="318371"/>
+            <a:ext cx="1854931" cy="369332"/>
+          </a:xfrm>
+          <a:prstGeom prst="rect">
+            <a:avLst/>
+          </a:prstGeom>
+          <a:noFill/>
+        </p:spPr>
+        <p:txBody>
+          <a:bodyPr wrap="none" rtlCol="0">
+            <a:spAutoFit/>
+          </a:bodyPr>
+          <a:lstStyle/>
+          <a:p>
+            <a:r>
+              <a:rPr lang="en-US" dirty="0"/>
+              <a:t>As in 07/10/2026</a:t>
+            </a:r>
+            <a:endParaRPr lang="en-MY" dirty="0"/>
+          </a:p>
+        </p:txBody>
+      </p:sp>
     </p:spTree>
     <p:extLst>
       <p:ext uri="{BB962C8B-B14F-4D97-AF65-F5344CB8AC3E}">
@@ -4778,256 +5187,6 @@
 </file>
 
 <file path=ppt/slides/slide7.xml><?xml version="1.0" encoding="utf-8"?>
-<p:sld xmlns:a="http://schemas.openxmlformats.org/drawingml/2006/main" xmlns:r="http://schemas.openxmlformats.org/officeDocument/2006/relationships" xmlns:p="http://schemas.openxmlformats.org/presentationml/2006/main">
-  <p:cSld>
-    <p:spTree>
-      <p:nvGrpSpPr>
-        <p:cNvPr id="1" name="">
-          <a:extLst>
-            <a:ext uri="{FF2B5EF4-FFF2-40B4-BE49-F238E27FC236}">
-              <a16:creationId xmlns:a16="http://schemas.microsoft.com/office/drawing/2014/main" id="{C8927E46-FEF3-B7B2-915A-22D3BCA45545}"/>
-            </a:ext>
-          </a:extLst>
-        </p:cNvPr>
-        <p:cNvGrpSpPr/>
-        <p:nvPr/>
-      </p:nvGrpSpPr>
-      <p:grpSpPr>
-        <a:xfrm>
-          <a:off x="0" y="0"/>
-          <a:ext cx="0" cy="0"/>
-          <a:chOff x="0" y="0"/>
-          <a:chExt cx="0" cy="0"/>
-        </a:xfrm>
-      </p:grpSpPr>
-      <p:pic>
-        <p:nvPicPr>
-          <p:cNvPr id="4" name="Picture 3">
-            <a:extLst>
-              <a:ext uri="{FF2B5EF4-FFF2-40B4-BE49-F238E27FC236}">
-                <a16:creationId xmlns:a16="http://schemas.microsoft.com/office/drawing/2014/main" id="{77D91245-E5C6-D447-245C-69D3709435F4}"/>
-              </a:ext>
-              <a:ext uri="{C183D7F6-B498-43B3-948B-1728B52AA6E4}">
-                <adec:decorative xmlns:adec="http://schemas.microsoft.com/office/drawing/2017/decorative" val="1"/>
-              </a:ext>
-            </a:extLst>
-          </p:cNvPr>
-          <p:cNvPicPr>
-            <a:picLocks noChangeAspect="1"/>
-          </p:cNvPicPr>
-          <p:nvPr/>
-        </p:nvPicPr>
-        <p:blipFill>
-          <a:blip r:embed="rId2"/>
-          <a:stretch>
-            <a:fillRect/>
-          </a:stretch>
-        </p:blipFill>
-        <p:spPr>
-          <a:xfrm>
-            <a:off x="200024" y="1455366"/>
-            <a:ext cx="11744325" cy="3014513"/>
-          </a:xfrm>
-          <a:prstGeom prst="rect">
-            <a:avLst/>
-          </a:prstGeom>
-        </p:spPr>
-      </p:pic>
-      <p:sp>
-        <p:nvSpPr>
-          <p:cNvPr id="5" name="Rectangle 4">
-            <a:extLst>
-              <a:ext uri="{FF2B5EF4-FFF2-40B4-BE49-F238E27FC236}">
-                <a16:creationId xmlns:a16="http://schemas.microsoft.com/office/drawing/2014/main" id="{0BD4AD33-1CDF-A3D1-127B-EEB983C0C9D8}"/>
-              </a:ext>
-            </a:extLst>
-          </p:cNvPr>
-          <p:cNvSpPr/>
-          <p:nvPr/>
-        </p:nvSpPr>
-        <p:spPr>
-          <a:xfrm>
-            <a:off x="457200" y="3429000"/>
-            <a:ext cx="609600" cy="586740"/>
-          </a:xfrm>
-          <a:prstGeom prst="rect">
-            <a:avLst/>
-          </a:prstGeom>
-          <a:solidFill>
-            <a:schemeClr val="bg1"/>
-          </a:solidFill>
-          <a:ln>
-            <a:solidFill>
-              <a:schemeClr val="bg1">
-                <a:lumMod val="95000"/>
-              </a:schemeClr>
-            </a:solidFill>
-          </a:ln>
-        </p:spPr>
-        <p:style>
-          <a:lnRef idx="2">
-            <a:schemeClr val="accent1">
-              <a:shade val="15000"/>
-            </a:schemeClr>
-          </a:lnRef>
-          <a:fillRef idx="1">
-            <a:schemeClr val="accent1"/>
-          </a:fillRef>
-          <a:effectRef idx="0">
-            <a:schemeClr val="accent1"/>
-          </a:effectRef>
-          <a:fontRef idx="minor">
-            <a:schemeClr val="lt1"/>
-          </a:fontRef>
-        </p:style>
-        <p:txBody>
-          <a:bodyPr rtlCol="0" anchor="ctr"/>
-          <a:lstStyle/>
-          <a:p>
-            <a:pPr algn="ctr"/>
-            <a:endParaRPr lang="en-MY"/>
-          </a:p>
-        </p:txBody>
-      </p:sp>
-    </p:spTree>
-    <p:extLst>
-      <p:ext uri="{BB962C8B-B14F-4D97-AF65-F5344CB8AC3E}">
-        <p14:creationId xmlns:p14="http://schemas.microsoft.com/office/powerpoint/2010/main" val="572400045"/>
-      </p:ext>
-    </p:extLst>
-  </p:cSld>
-  <p:clrMapOvr>
-    <a:masterClrMapping/>
-  </p:clrMapOvr>
-</p:sld>
-</file>
-
-<file path=ppt/slides/slide8.xml><?xml version="1.0" encoding="utf-8"?>
-<p:sld xmlns:a="http://schemas.openxmlformats.org/drawingml/2006/main" xmlns:r="http://schemas.openxmlformats.org/officeDocument/2006/relationships" xmlns:p="http://schemas.openxmlformats.org/presentationml/2006/main">
-  <p:cSld>
-    <p:spTree>
-      <p:nvGrpSpPr>
-        <p:cNvPr id="1" name="">
-          <a:extLst>
-            <a:ext uri="{FF2B5EF4-FFF2-40B4-BE49-F238E27FC236}">
-              <a16:creationId xmlns:a16="http://schemas.microsoft.com/office/drawing/2014/main" id="{D3FDFF93-8F9C-9945-0605-D960B71FEDE4}"/>
-            </a:ext>
-          </a:extLst>
-        </p:cNvPr>
-        <p:cNvGrpSpPr/>
-        <p:nvPr/>
-      </p:nvGrpSpPr>
-      <p:grpSpPr>
-        <a:xfrm>
-          <a:off x="0" y="0"/>
-          <a:ext cx="0" cy="0"/>
-          <a:chOff x="0" y="0"/>
-          <a:chExt cx="0" cy="0"/>
-        </a:xfrm>
-      </p:grpSpPr>
-      <p:sp>
-        <p:nvSpPr>
-          <p:cNvPr id="5" name="Rectangle 4">
-            <a:extLst>
-              <a:ext uri="{FF2B5EF4-FFF2-40B4-BE49-F238E27FC236}">
-                <a16:creationId xmlns:a16="http://schemas.microsoft.com/office/drawing/2014/main" id="{6D56EE7D-8DA0-36B8-ED99-B0613A929CF9}"/>
-              </a:ext>
-            </a:extLst>
-          </p:cNvPr>
-          <p:cNvSpPr/>
-          <p:nvPr/>
-        </p:nvSpPr>
-        <p:spPr>
-          <a:xfrm>
-            <a:off x="457200" y="3429000"/>
-            <a:ext cx="609600" cy="586740"/>
-          </a:xfrm>
-          <a:prstGeom prst="rect">
-            <a:avLst/>
-          </a:prstGeom>
-          <a:solidFill>
-            <a:schemeClr val="bg1"/>
-          </a:solidFill>
-          <a:ln>
-            <a:solidFill>
-              <a:schemeClr val="bg1">
-                <a:lumMod val="95000"/>
-              </a:schemeClr>
-            </a:solidFill>
-          </a:ln>
-        </p:spPr>
-        <p:style>
-          <a:lnRef idx="2">
-            <a:schemeClr val="accent1">
-              <a:shade val="15000"/>
-            </a:schemeClr>
-          </a:lnRef>
-          <a:fillRef idx="1">
-            <a:schemeClr val="accent1"/>
-          </a:fillRef>
-          <a:effectRef idx="0">
-            <a:schemeClr val="accent1"/>
-          </a:effectRef>
-          <a:fontRef idx="minor">
-            <a:schemeClr val="lt1"/>
-          </a:fontRef>
-        </p:style>
-        <p:txBody>
-          <a:bodyPr rtlCol="0" anchor="ctr"/>
-          <a:lstStyle/>
-          <a:p>
-            <a:pPr algn="ctr"/>
-            <a:endParaRPr lang="en-MY"/>
-          </a:p>
-        </p:txBody>
-      </p:sp>
-      <p:pic>
-        <p:nvPicPr>
-          <p:cNvPr id="2" name="Picture 1">
-            <a:extLst>
-              <a:ext uri="{FF2B5EF4-FFF2-40B4-BE49-F238E27FC236}">
-                <a16:creationId xmlns:a16="http://schemas.microsoft.com/office/drawing/2014/main" id="{CCD9954F-2A7E-9589-0DC3-CF923F0FDA33}"/>
-              </a:ext>
-              <a:ext uri="{C183D7F6-B498-43B3-948B-1728B52AA6E4}">
-                <adec:decorative xmlns:adec="http://schemas.microsoft.com/office/drawing/2017/decorative" val="1"/>
-              </a:ext>
-            </a:extLst>
-          </p:cNvPr>
-          <p:cNvPicPr>
-            <a:picLocks noChangeAspect="1"/>
-          </p:cNvPicPr>
-          <p:nvPr/>
-        </p:nvPicPr>
-        <p:blipFill>
-          <a:blip r:embed="rId2"/>
-          <a:stretch>
-            <a:fillRect/>
-          </a:stretch>
-        </p:blipFill>
-        <p:spPr>
-          <a:xfrm>
-            <a:off x="761999" y="886389"/>
-            <a:ext cx="10825879" cy="3825311"/>
-          </a:xfrm>
-          <a:prstGeom prst="rect">
-            <a:avLst/>
-          </a:prstGeom>
-        </p:spPr>
-      </p:pic>
-    </p:spTree>
-    <p:extLst>
-      <p:ext uri="{BB962C8B-B14F-4D97-AF65-F5344CB8AC3E}">
-        <p14:creationId xmlns:p14="http://schemas.microsoft.com/office/powerpoint/2010/main" val="227469368"/>
-      </p:ext>
-    </p:extLst>
-  </p:cSld>
-  <p:clrMapOvr>
-    <a:masterClrMapping/>
-  </p:clrMapOvr>
-</p:sld>
-</file>
-
-<file path=ppt/slides/slide9.xml><?xml version="1.0" encoding="utf-8"?>
 <p:sld xmlns:a="http://schemas.openxmlformats.org/drawingml/2006/main" xmlns:r="http://schemas.openxmlformats.org/officeDocument/2006/relationships" xmlns:p="http://schemas.openxmlformats.org/presentationml/2006/main">
   <p:cSld>
     <p:spTree>
@@ -5088,6 +5247,646 @@
     <p:extLst>
       <p:ext uri="{BB962C8B-B14F-4D97-AF65-F5344CB8AC3E}">
         <p14:creationId xmlns:p14="http://schemas.microsoft.com/office/powerpoint/2010/main" val="1594390262"/>
+      </p:ext>
+    </p:extLst>
+  </p:cSld>
+  <p:clrMapOvr>
+    <a:masterClrMapping/>
+  </p:clrMapOvr>
+</p:sld>
+</file>
+
+<file path=ppt/slides/slide8.xml><?xml version="1.0" encoding="utf-8"?>
+<p:sld xmlns:a="http://schemas.openxmlformats.org/drawingml/2006/main" xmlns:r="http://schemas.openxmlformats.org/officeDocument/2006/relationships" xmlns:p="http://schemas.openxmlformats.org/presentationml/2006/main">
+  <p:cSld>
+    <p:spTree>
+      <p:nvGrpSpPr>
+        <p:cNvPr id="1" name="">
+          <a:extLst>
+            <a:ext uri="{FF2B5EF4-FFF2-40B4-BE49-F238E27FC236}">
+              <a16:creationId xmlns:a16="http://schemas.microsoft.com/office/drawing/2014/main" id="{27D3FB82-6BC6-D5FC-8940-ED3705B4CB9E}"/>
+            </a:ext>
+          </a:extLst>
+        </p:cNvPr>
+        <p:cNvGrpSpPr/>
+        <p:nvPr/>
+      </p:nvGrpSpPr>
+      <p:grpSpPr>
+        <a:xfrm>
+          <a:off x="0" y="0"/>
+          <a:ext cx="0" cy="0"/>
+          <a:chOff x="0" y="0"/>
+          <a:chExt cx="0" cy="0"/>
+        </a:xfrm>
+      </p:grpSpPr>
+      <p:pic>
+        <p:nvPicPr>
+          <p:cNvPr id="3" name="Picture 2">
+            <a:extLst>
+              <a:ext uri="{FF2B5EF4-FFF2-40B4-BE49-F238E27FC236}">
+                <a16:creationId xmlns:a16="http://schemas.microsoft.com/office/drawing/2014/main" id="{3468174C-3912-3650-1529-DEF000909108}"/>
+              </a:ext>
+            </a:extLst>
+          </p:cNvPr>
+          <p:cNvPicPr>
+            <a:picLocks noChangeAspect="1"/>
+          </p:cNvPicPr>
+          <p:nvPr/>
+        </p:nvPicPr>
+        <p:blipFill>
+          <a:blip r:embed="rId2"/>
+          <a:stretch>
+            <a:fillRect/>
+          </a:stretch>
+        </p:blipFill>
+        <p:spPr>
+          <a:xfrm>
+            <a:off x="350394" y="747426"/>
+            <a:ext cx="6010161" cy="2567274"/>
+          </a:xfrm>
+          <a:prstGeom prst="rect">
+            <a:avLst/>
+          </a:prstGeom>
+        </p:spPr>
+      </p:pic>
+      <p:sp>
+        <p:nvSpPr>
+          <p:cNvPr id="5" name="Rectangle 4">
+            <a:extLst>
+              <a:ext uri="{FF2B5EF4-FFF2-40B4-BE49-F238E27FC236}">
+                <a16:creationId xmlns:a16="http://schemas.microsoft.com/office/drawing/2014/main" id="{73E73E2B-9DFB-E289-5DFB-0BC4F7B9D9F8}"/>
+              </a:ext>
+            </a:extLst>
+          </p:cNvPr>
+          <p:cNvSpPr/>
+          <p:nvPr/>
+        </p:nvSpPr>
+        <p:spPr>
+          <a:xfrm>
+            <a:off x="485775" y="1400175"/>
+            <a:ext cx="409575" cy="1485900"/>
+          </a:xfrm>
+          <a:prstGeom prst="rect">
+            <a:avLst/>
+          </a:prstGeom>
+          <a:noFill/>
+          <a:ln w="76200">
+            <a:solidFill>
+              <a:srgbClr val="FF0000"/>
+            </a:solidFill>
+          </a:ln>
+        </p:spPr>
+        <p:style>
+          <a:lnRef idx="2">
+            <a:schemeClr val="accent1">
+              <a:shade val="15000"/>
+            </a:schemeClr>
+          </a:lnRef>
+          <a:fillRef idx="1">
+            <a:schemeClr val="accent1"/>
+          </a:fillRef>
+          <a:effectRef idx="0">
+            <a:schemeClr val="accent1"/>
+          </a:effectRef>
+          <a:fontRef idx="minor">
+            <a:schemeClr val="lt1"/>
+          </a:fontRef>
+        </p:style>
+        <p:txBody>
+          <a:bodyPr rtlCol="0" anchor="ctr"/>
+          <a:lstStyle/>
+          <a:p>
+            <a:pPr algn="ctr"/>
+            <a:endParaRPr lang="en-MY"/>
+          </a:p>
+        </p:txBody>
+      </p:sp>
+      <p:sp>
+        <p:nvSpPr>
+          <p:cNvPr id="6" name="Rectangle 5">
+            <a:extLst>
+              <a:ext uri="{FF2B5EF4-FFF2-40B4-BE49-F238E27FC236}">
+                <a16:creationId xmlns:a16="http://schemas.microsoft.com/office/drawing/2014/main" id="{1D3A46C8-8598-26B0-4AF2-3FB0493DA675}"/>
+              </a:ext>
+            </a:extLst>
+          </p:cNvPr>
+          <p:cNvSpPr/>
+          <p:nvPr/>
+        </p:nvSpPr>
+        <p:spPr>
+          <a:xfrm>
+            <a:off x="1642829" y="162651"/>
+            <a:ext cx="3116558" cy="584775"/>
+          </a:xfrm>
+          <a:prstGeom prst="rect">
+            <a:avLst/>
+          </a:prstGeom>
+          <a:noFill/>
+        </p:spPr>
+        <p:txBody>
+          <a:bodyPr wrap="none" lIns="91440" tIns="45720" rIns="91440" bIns="45720">
+            <a:spAutoFit/>
+          </a:bodyPr>
+          <a:lstStyle/>
+          <a:p>
+            <a:pPr algn="ctr"/>
+            <a:r>
+              <a:rPr lang="en-US" sz="3200" b="0" cap="none" spc="0" dirty="0">
+                <a:ln w="0"/>
+                <a:solidFill>
+                  <a:schemeClr val="tx1"/>
+                </a:solidFill>
+                <a:effectLst>
+                  <a:outerShdw blurRad="38100" dist="19050" dir="2700000" algn="tl" rotWithShape="0">
+                    <a:schemeClr val="dk1">
+                      <a:alpha val="40000"/>
+                    </a:schemeClr>
+                  </a:outerShdw>
+                </a:effectLst>
+              </a:rPr>
+              <a:t>Claude Sonnet 5</a:t>
+            </a:r>
+          </a:p>
+        </p:txBody>
+      </p:sp>
+      <p:pic>
+        <p:nvPicPr>
+          <p:cNvPr id="8" name="Picture 7">
+            <a:extLst>
+              <a:ext uri="{FF2B5EF4-FFF2-40B4-BE49-F238E27FC236}">
+                <a16:creationId xmlns:a16="http://schemas.microsoft.com/office/drawing/2014/main" id="{FCD1C296-E367-4E95-33FE-F317638DAD8D}"/>
+              </a:ext>
+            </a:extLst>
+          </p:cNvPr>
+          <p:cNvPicPr>
+            <a:picLocks noChangeAspect="1"/>
+          </p:cNvPicPr>
+          <p:nvPr/>
+        </p:nvPicPr>
+        <p:blipFill>
+          <a:blip r:embed="rId3"/>
+          <a:stretch>
+            <a:fillRect/>
+          </a:stretch>
+        </p:blipFill>
+        <p:spPr>
+          <a:xfrm>
+            <a:off x="6733522" y="747426"/>
+            <a:ext cx="4972703" cy="2547118"/>
+          </a:xfrm>
+          <a:prstGeom prst="rect">
+            <a:avLst/>
+          </a:prstGeom>
+        </p:spPr>
+      </p:pic>
+      <p:sp>
+        <p:nvSpPr>
+          <p:cNvPr id="10" name="Rectangle 9">
+            <a:extLst>
+              <a:ext uri="{FF2B5EF4-FFF2-40B4-BE49-F238E27FC236}">
+                <a16:creationId xmlns:a16="http://schemas.microsoft.com/office/drawing/2014/main" id="{A7B231C9-6D34-7757-7E35-A71A4E12C277}"/>
+              </a:ext>
+            </a:extLst>
+          </p:cNvPr>
+          <p:cNvSpPr/>
+          <p:nvPr/>
+        </p:nvSpPr>
+        <p:spPr>
+          <a:xfrm>
+            <a:off x="8366823" y="162651"/>
+            <a:ext cx="1860574" cy="584775"/>
+          </a:xfrm>
+          <a:prstGeom prst="rect">
+            <a:avLst/>
+          </a:prstGeom>
+          <a:noFill/>
+        </p:spPr>
+        <p:txBody>
+          <a:bodyPr wrap="none" lIns="91440" tIns="45720" rIns="91440" bIns="45720">
+            <a:spAutoFit/>
+          </a:bodyPr>
+          <a:lstStyle/>
+          <a:p>
+            <a:pPr algn="ctr"/>
+            <a:r>
+              <a:rPr lang="en-US" sz="3200" b="0" cap="none" spc="0" dirty="0">
+                <a:ln w="0"/>
+                <a:solidFill>
+                  <a:schemeClr val="tx1"/>
+                </a:solidFill>
+                <a:effectLst>
+                  <a:outerShdw blurRad="38100" dist="19050" dir="2700000" algn="tl" rotWithShape="0">
+                    <a:schemeClr val="dk1">
+                      <a:alpha val="40000"/>
+                    </a:schemeClr>
+                  </a:outerShdw>
+                </a:effectLst>
+              </a:rPr>
+              <a:t>Qwen 3.8</a:t>
+            </a:r>
+          </a:p>
+        </p:txBody>
+      </p:sp>
+      <p:sp>
+        <p:nvSpPr>
+          <p:cNvPr id="12" name="Rectangle 11">
+            <a:extLst>
+              <a:ext uri="{FF2B5EF4-FFF2-40B4-BE49-F238E27FC236}">
+                <a16:creationId xmlns:a16="http://schemas.microsoft.com/office/drawing/2014/main" id="{FD1EFBD3-5C3A-1B95-E4F2-B98825611D58}"/>
+              </a:ext>
+            </a:extLst>
+          </p:cNvPr>
+          <p:cNvSpPr/>
+          <p:nvPr/>
+        </p:nvSpPr>
+        <p:spPr>
+          <a:xfrm>
+            <a:off x="6733522" y="1288113"/>
+            <a:ext cx="409575" cy="1485900"/>
+          </a:xfrm>
+          <a:prstGeom prst="rect">
+            <a:avLst/>
+          </a:prstGeom>
+          <a:noFill/>
+          <a:ln w="76200">
+            <a:solidFill>
+              <a:srgbClr val="FF0000"/>
+            </a:solidFill>
+          </a:ln>
+        </p:spPr>
+        <p:style>
+          <a:lnRef idx="2">
+            <a:schemeClr val="accent1">
+              <a:shade val="15000"/>
+            </a:schemeClr>
+          </a:lnRef>
+          <a:fillRef idx="1">
+            <a:schemeClr val="accent1"/>
+          </a:fillRef>
+          <a:effectRef idx="0">
+            <a:schemeClr val="accent1"/>
+          </a:effectRef>
+          <a:fontRef idx="minor">
+            <a:schemeClr val="lt1"/>
+          </a:fontRef>
+        </p:style>
+        <p:txBody>
+          <a:bodyPr rtlCol="0" anchor="ctr"/>
+          <a:lstStyle/>
+          <a:p>
+            <a:pPr algn="ctr"/>
+            <a:endParaRPr lang="en-MY"/>
+          </a:p>
+        </p:txBody>
+      </p:sp>
+      <p:sp>
+        <p:nvSpPr>
+          <p:cNvPr id="13" name="TextBox 12">
+            <a:extLst>
+              <a:ext uri="{FF2B5EF4-FFF2-40B4-BE49-F238E27FC236}">
+                <a16:creationId xmlns:a16="http://schemas.microsoft.com/office/drawing/2014/main" id="{C4375A12-4EDB-C772-8208-E1E4D9D37733}"/>
+              </a:ext>
+            </a:extLst>
+          </p:cNvPr>
+          <p:cNvSpPr txBox="1"/>
+          <p:nvPr/>
+        </p:nvSpPr>
+        <p:spPr>
+          <a:xfrm>
+            <a:off x="8062765" y="3771900"/>
+            <a:ext cx="2468689" cy="369332"/>
+          </a:xfrm>
+          <a:prstGeom prst="rect">
+            <a:avLst/>
+          </a:prstGeom>
+          <a:noFill/>
+        </p:spPr>
+        <p:txBody>
+          <a:bodyPr wrap="none" rtlCol="0">
+            <a:spAutoFit/>
+          </a:bodyPr>
+          <a:lstStyle/>
+          <a:p>
+            <a:r>
+              <a:rPr lang="en-US" dirty="0"/>
+              <a:t>112.3s with 4025 token</a:t>
+            </a:r>
+            <a:endParaRPr lang="en-MY" dirty="0"/>
+          </a:p>
+        </p:txBody>
+      </p:sp>
+      <p:sp>
+        <p:nvSpPr>
+          <p:cNvPr id="15" name="TextBox 14">
+            <a:extLst>
+              <a:ext uri="{FF2B5EF4-FFF2-40B4-BE49-F238E27FC236}">
+                <a16:creationId xmlns:a16="http://schemas.microsoft.com/office/drawing/2014/main" id="{45E20E7C-F0D8-7A5F-0C7E-E89072A95996}"/>
+              </a:ext>
+            </a:extLst>
+          </p:cNvPr>
+          <p:cNvSpPr txBox="1"/>
+          <p:nvPr/>
+        </p:nvSpPr>
+        <p:spPr>
+          <a:xfrm>
+            <a:off x="2028479" y="3358635"/>
+            <a:ext cx="2345257" cy="369332"/>
+          </a:xfrm>
+          <a:prstGeom prst="rect">
+            <a:avLst/>
+          </a:prstGeom>
+          <a:noFill/>
+        </p:spPr>
+        <p:txBody>
+          <a:bodyPr wrap="none" rtlCol="0">
+            <a:spAutoFit/>
+          </a:bodyPr>
+          <a:lstStyle/>
+          <a:p>
+            <a:r>
+              <a:rPr lang="en-US" dirty="0"/>
+              <a:t>76.2s with 6849 token</a:t>
+            </a:r>
+            <a:endParaRPr lang="en-MY" dirty="0"/>
+          </a:p>
+        </p:txBody>
+      </p:sp>
+      <p:sp>
+        <p:nvSpPr>
+          <p:cNvPr id="17" name="TextBox 16">
+            <a:extLst>
+              <a:ext uri="{FF2B5EF4-FFF2-40B4-BE49-F238E27FC236}">
+                <a16:creationId xmlns:a16="http://schemas.microsoft.com/office/drawing/2014/main" id="{212C6922-07C3-9E4A-7D17-0B2FC3CE4A0B}"/>
+              </a:ext>
+            </a:extLst>
+          </p:cNvPr>
+          <p:cNvSpPr txBox="1"/>
+          <p:nvPr/>
+        </p:nvSpPr>
+        <p:spPr>
+          <a:xfrm>
+            <a:off x="8180585" y="4433922"/>
+            <a:ext cx="2233047" cy="369332"/>
+          </a:xfrm>
+          <a:prstGeom prst="rect">
+            <a:avLst/>
+          </a:prstGeom>
+          <a:noFill/>
+        </p:spPr>
+        <p:txBody>
+          <a:bodyPr wrap="none" rtlCol="0">
+            <a:spAutoFit/>
+          </a:bodyPr>
+          <a:lstStyle/>
+          <a:p>
+            <a:r>
+              <a:rPr lang="en-US" dirty="0"/>
+              <a:t>78.3 with 3792 token</a:t>
+            </a:r>
+            <a:endParaRPr lang="en-MY" dirty="0"/>
+          </a:p>
+        </p:txBody>
+      </p:sp>
+      <p:sp>
+        <p:nvSpPr>
+          <p:cNvPr id="19" name="TextBox 18">
+            <a:extLst>
+              <a:ext uri="{FF2B5EF4-FFF2-40B4-BE49-F238E27FC236}">
+                <a16:creationId xmlns:a16="http://schemas.microsoft.com/office/drawing/2014/main" id="{AD65B5AD-5C2E-67B1-F9CE-40F875E25068}"/>
+              </a:ext>
+            </a:extLst>
+          </p:cNvPr>
+          <p:cNvSpPr txBox="1"/>
+          <p:nvPr/>
+        </p:nvSpPr>
+        <p:spPr>
+          <a:xfrm>
+            <a:off x="2414130" y="6326017"/>
+            <a:ext cx="2345257" cy="369332"/>
+          </a:xfrm>
+          <a:prstGeom prst="rect">
+            <a:avLst/>
+          </a:prstGeom>
+          <a:noFill/>
+        </p:spPr>
+        <p:txBody>
+          <a:bodyPr wrap="none" rtlCol="0">
+            <a:spAutoFit/>
+          </a:bodyPr>
+          <a:lstStyle/>
+          <a:p>
+            <a:r>
+              <a:rPr lang="en-US" dirty="0"/>
+              <a:t>94.5s with 5965 token</a:t>
+            </a:r>
+            <a:endParaRPr lang="en-MY" dirty="0"/>
+          </a:p>
+        </p:txBody>
+      </p:sp>
+      <p:pic>
+        <p:nvPicPr>
+          <p:cNvPr id="21" name="Picture 20">
+            <a:extLst>
+              <a:ext uri="{FF2B5EF4-FFF2-40B4-BE49-F238E27FC236}">
+                <a16:creationId xmlns:a16="http://schemas.microsoft.com/office/drawing/2014/main" id="{BE266960-D5D8-2124-9E4A-61D662AD6557}"/>
+              </a:ext>
+            </a:extLst>
+          </p:cNvPr>
+          <p:cNvPicPr>
+            <a:picLocks noChangeAspect="1"/>
+          </p:cNvPicPr>
+          <p:nvPr/>
+        </p:nvPicPr>
+        <p:blipFill>
+          <a:blip r:embed="rId4"/>
+          <a:stretch>
+            <a:fillRect/>
+          </a:stretch>
+        </p:blipFill>
+        <p:spPr>
+          <a:xfrm>
+            <a:off x="814392" y="3899475"/>
+            <a:ext cx="5281608" cy="2123477"/>
+          </a:xfrm>
+          <a:prstGeom prst="rect">
+            <a:avLst/>
+          </a:prstGeom>
+        </p:spPr>
+      </p:pic>
+      <p:sp>
+        <p:nvSpPr>
+          <p:cNvPr id="23" name="Rectangle 22">
+            <a:extLst>
+              <a:ext uri="{FF2B5EF4-FFF2-40B4-BE49-F238E27FC236}">
+                <a16:creationId xmlns:a16="http://schemas.microsoft.com/office/drawing/2014/main" id="{791008E0-2BF6-F998-7962-BDA051632F36}"/>
+              </a:ext>
+            </a:extLst>
+          </p:cNvPr>
+          <p:cNvSpPr/>
+          <p:nvPr/>
+        </p:nvSpPr>
+        <p:spPr>
+          <a:xfrm>
+            <a:off x="814392" y="4295775"/>
+            <a:ext cx="409575" cy="1485900"/>
+          </a:xfrm>
+          <a:prstGeom prst="rect">
+            <a:avLst/>
+          </a:prstGeom>
+          <a:noFill/>
+          <a:ln w="76200">
+            <a:solidFill>
+              <a:srgbClr val="FF0000"/>
+            </a:solidFill>
+          </a:ln>
+        </p:spPr>
+        <p:style>
+          <a:lnRef idx="2">
+            <a:schemeClr val="accent1">
+              <a:shade val="15000"/>
+            </a:schemeClr>
+          </a:lnRef>
+          <a:fillRef idx="1">
+            <a:schemeClr val="accent1"/>
+          </a:fillRef>
+          <a:effectRef idx="0">
+            <a:schemeClr val="accent1"/>
+          </a:effectRef>
+          <a:fontRef idx="minor">
+            <a:schemeClr val="lt1"/>
+          </a:fontRef>
+        </p:style>
+        <p:txBody>
+          <a:bodyPr rtlCol="0" anchor="ctr"/>
+          <a:lstStyle/>
+          <a:p>
+            <a:pPr algn="ctr"/>
+            <a:endParaRPr lang="en-MY"/>
+          </a:p>
+        </p:txBody>
+      </p:sp>
+    </p:spTree>
+    <p:extLst>
+      <p:ext uri="{BB962C8B-B14F-4D97-AF65-F5344CB8AC3E}">
+        <p14:creationId xmlns:p14="http://schemas.microsoft.com/office/powerpoint/2010/main" val="3680740682"/>
+      </p:ext>
+    </p:extLst>
+  </p:cSld>
+  <p:clrMapOvr>
+    <a:masterClrMapping/>
+  </p:clrMapOvr>
+</p:sld>
+</file>
+
+<file path=ppt/slides/slide9.xml><?xml version="1.0" encoding="utf-8"?>
+<p:sld xmlns:a="http://schemas.openxmlformats.org/drawingml/2006/main" xmlns:r="http://schemas.openxmlformats.org/officeDocument/2006/relationships" xmlns:p="http://schemas.openxmlformats.org/presentationml/2006/main">
+  <p:cSld>
+    <p:spTree>
+      <p:nvGrpSpPr>
+        <p:cNvPr id="1" name=""/>
+        <p:cNvGrpSpPr/>
+        <p:nvPr/>
+      </p:nvGrpSpPr>
+      <p:grpSpPr>
+        <a:xfrm>
+          <a:off x="0" y="0"/>
+          <a:ext cx="0" cy="0"/>
+          <a:chOff x="0" y="0"/>
+          <a:chExt cx="0" cy="0"/>
+        </a:xfrm>
+      </p:grpSpPr>
+      <p:pic>
+        <p:nvPicPr>
+          <p:cNvPr id="5" name="Picture 4">
+            <a:extLst>
+              <a:ext uri="{FF2B5EF4-FFF2-40B4-BE49-F238E27FC236}">
+                <a16:creationId xmlns:a16="http://schemas.microsoft.com/office/drawing/2014/main" id="{CE86D122-665A-1204-703D-FF94B43B3207}"/>
+              </a:ext>
+            </a:extLst>
+          </p:cNvPr>
+          <p:cNvPicPr>
+            <a:picLocks noChangeAspect="1"/>
+          </p:cNvPicPr>
+          <p:nvPr/>
+        </p:nvPicPr>
+        <p:blipFill>
+          <a:blip r:embed="rId2"/>
+          <a:stretch>
+            <a:fillRect/>
+          </a:stretch>
+        </p:blipFill>
+        <p:spPr>
+          <a:xfrm>
+            <a:off x="2371725" y="460871"/>
+            <a:ext cx="8025262" cy="4120654"/>
+          </a:xfrm>
+          <a:prstGeom prst="rect">
+            <a:avLst/>
+          </a:prstGeom>
+        </p:spPr>
+      </p:pic>
+      <p:sp>
+        <p:nvSpPr>
+          <p:cNvPr id="7" name="Rectangle 6">
+            <a:extLst>
+              <a:ext uri="{FF2B5EF4-FFF2-40B4-BE49-F238E27FC236}">
+                <a16:creationId xmlns:a16="http://schemas.microsoft.com/office/drawing/2014/main" id="{91FD3543-D30A-2D21-058B-CB0164D45589}"/>
+              </a:ext>
+            </a:extLst>
+          </p:cNvPr>
+          <p:cNvSpPr/>
+          <p:nvPr/>
+        </p:nvSpPr>
+        <p:spPr>
+          <a:xfrm>
+            <a:off x="422042" y="4868001"/>
+            <a:ext cx="11347915" cy="584775"/>
+          </a:xfrm>
+          <a:prstGeom prst="rect">
+            <a:avLst/>
+          </a:prstGeom>
+          <a:noFill/>
+        </p:spPr>
+        <p:txBody>
+          <a:bodyPr wrap="none" lIns="91440" tIns="45720" rIns="91440" bIns="45720">
+            <a:spAutoFit/>
+          </a:bodyPr>
+          <a:lstStyle/>
+          <a:p>
+            <a:pPr algn="ctr"/>
+            <a:r>
+              <a:rPr lang="en-US" sz="3200" dirty="0">
+                <a:ln w="0"/>
+                <a:effectLst>
+                  <a:outerShdw blurRad="38100" dist="19050" dir="2700000" algn="tl" rotWithShape="0">
+                    <a:schemeClr val="dk1">
+                      <a:alpha val="40000"/>
+                    </a:schemeClr>
+                  </a:outerShdw>
+                </a:effectLst>
+              </a:rPr>
+              <a:t>Attention : Need to rename the “New Instance” into the variable</a:t>
+            </a:r>
+            <a:endParaRPr lang="en-US" sz="3200" b="0" cap="none" spc="0" dirty="0">
+              <a:ln w="0"/>
+              <a:solidFill>
+                <a:schemeClr val="tx1"/>
+              </a:solidFill>
+              <a:effectLst>
+                <a:outerShdw blurRad="38100" dist="19050" dir="2700000" algn="tl" rotWithShape="0">
+                  <a:schemeClr val="dk1">
+                    <a:alpha val="40000"/>
+                  </a:schemeClr>
+                </a:outerShdw>
+              </a:effectLst>
+            </a:endParaRPr>
+          </a:p>
+        </p:txBody>
+      </p:sp>
+    </p:spTree>
+    <p:extLst>
+      <p:ext uri="{BB962C8B-B14F-4D97-AF65-F5344CB8AC3E}">
+        <p14:creationId xmlns:p14="http://schemas.microsoft.com/office/powerpoint/2010/main" val="3804746096"/>
       </p:ext>
     </p:extLst>
   </p:cSld>

</xml_diff>

<commit_message>
Insert Groq api key in slide
</commit_message>
<xml_diff>
--- a/Reference/briefing project.pptx
+++ b/Reference/briefing project.pptx
@@ -205,7 +205,7 @@
           <a:p>
             <a:fld id="{53B61C8E-81CB-4032-8EA4-7F2345ECEA2B}" type="datetimeFigureOut">
               <a:rPr lang="en-MY" smtClean="0"/>
-              <a:t>7/10/2026</a:t>
+              <a:t>9/10/2026</a:t>
             </a:fld>
             <a:endParaRPr lang="en-MY"/>
           </a:p>
@@ -706,7 +706,7 @@
           <a:p>
             <a:fld id="{4449257F-037A-47B5-A07B-A73CC606E6AA}" type="datetimeFigureOut">
               <a:rPr lang="en-MY" smtClean="0"/>
-              <a:t>7/10/2026</a:t>
+              <a:t>9/10/2026</a:t>
             </a:fld>
             <a:endParaRPr lang="en-MY"/>
           </a:p>
@@ -906,7 +906,7 @@
           <a:p>
             <a:fld id="{4449257F-037A-47B5-A07B-A73CC606E6AA}" type="datetimeFigureOut">
               <a:rPr lang="en-MY" smtClean="0"/>
-              <a:t>7/10/2026</a:t>
+              <a:t>9/10/2026</a:t>
             </a:fld>
             <a:endParaRPr lang="en-MY"/>
           </a:p>
@@ -1116,7 +1116,7 @@
           <a:p>
             <a:fld id="{4449257F-037A-47B5-A07B-A73CC606E6AA}" type="datetimeFigureOut">
               <a:rPr lang="en-MY" smtClean="0"/>
-              <a:t>7/10/2026</a:t>
+              <a:t>9/10/2026</a:t>
             </a:fld>
             <a:endParaRPr lang="en-MY"/>
           </a:p>
@@ -1316,7 +1316,7 @@
           <a:p>
             <a:fld id="{4449257F-037A-47B5-A07B-A73CC606E6AA}" type="datetimeFigureOut">
               <a:rPr lang="en-MY" smtClean="0"/>
-              <a:t>7/10/2026</a:t>
+              <a:t>9/10/2026</a:t>
             </a:fld>
             <a:endParaRPr lang="en-MY"/>
           </a:p>
@@ -1592,7 +1592,7 @@
           <a:p>
             <a:fld id="{4449257F-037A-47B5-A07B-A73CC606E6AA}" type="datetimeFigureOut">
               <a:rPr lang="en-MY" smtClean="0"/>
-              <a:t>7/10/2026</a:t>
+              <a:t>9/10/2026</a:t>
             </a:fld>
             <a:endParaRPr lang="en-MY"/>
           </a:p>
@@ -1860,7 +1860,7 @@
           <a:p>
             <a:fld id="{4449257F-037A-47B5-A07B-A73CC606E6AA}" type="datetimeFigureOut">
               <a:rPr lang="en-MY" smtClean="0"/>
-              <a:t>7/10/2026</a:t>
+              <a:t>9/10/2026</a:t>
             </a:fld>
             <a:endParaRPr lang="en-MY"/>
           </a:p>
@@ -2275,7 +2275,7 @@
           <a:p>
             <a:fld id="{4449257F-037A-47B5-A07B-A73CC606E6AA}" type="datetimeFigureOut">
               <a:rPr lang="en-MY" smtClean="0"/>
-              <a:t>7/10/2026</a:t>
+              <a:t>9/10/2026</a:t>
             </a:fld>
             <a:endParaRPr lang="en-MY"/>
           </a:p>
@@ -2417,7 +2417,7 @@
           <a:p>
             <a:fld id="{4449257F-037A-47B5-A07B-A73CC606E6AA}" type="datetimeFigureOut">
               <a:rPr lang="en-MY" smtClean="0"/>
-              <a:t>7/10/2026</a:t>
+              <a:t>9/10/2026</a:t>
             </a:fld>
             <a:endParaRPr lang="en-MY"/>
           </a:p>
@@ -2530,7 +2530,7 @@
           <a:p>
             <a:fld id="{4449257F-037A-47B5-A07B-A73CC606E6AA}" type="datetimeFigureOut">
               <a:rPr lang="en-MY" smtClean="0"/>
-              <a:t>7/10/2026</a:t>
+              <a:t>9/10/2026</a:t>
             </a:fld>
             <a:endParaRPr lang="en-MY"/>
           </a:p>
@@ -2843,7 +2843,7 @@
           <a:p>
             <a:fld id="{4449257F-037A-47B5-A07B-A73CC606E6AA}" type="datetimeFigureOut">
               <a:rPr lang="en-MY" smtClean="0"/>
-              <a:t>7/10/2026</a:t>
+              <a:t>9/10/2026</a:t>
             </a:fld>
             <a:endParaRPr lang="en-MY"/>
           </a:p>
@@ -3132,7 +3132,7 @@
           <a:p>
             <a:fld id="{4449257F-037A-47B5-A07B-A73CC606E6AA}" type="datetimeFigureOut">
               <a:rPr lang="en-MY" smtClean="0"/>
-              <a:t>7/10/2026</a:t>
+              <a:t>9/10/2026</a:t>
             </a:fld>
             <a:endParaRPr lang="en-MY"/>
           </a:p>
@@ -3375,7 +3375,7 @@
           <a:p>
             <a:fld id="{4449257F-037A-47B5-A07B-A73CC606E6AA}" type="datetimeFigureOut">
               <a:rPr lang="en-MY" smtClean="0"/>
-              <a:t>7/10/2026</a:t>
+              <a:t>9/10/2026</a:t>
             </a:fld>
             <a:endParaRPr lang="en-MY"/>
           </a:p>
@@ -4367,14 +4367,14 @@
           <p:nvPr>
             <p:extLst>
               <p:ext uri="{D42A27DB-BD31-4B8C-83A1-F6EECF244321}">
-                <p14:modId xmlns:p14="http://schemas.microsoft.com/office/powerpoint/2010/main" val="4156753649"/>
+                <p14:modId xmlns:p14="http://schemas.microsoft.com/office/powerpoint/2010/main" val="953129343"/>
               </p:ext>
             </p:extLst>
           </p:nvPr>
         </p:nvGraphicFramePr>
         <p:xfrm>
           <a:off x="690879" y="893021"/>
-          <a:ext cx="11024871" cy="3606800"/>
+          <a:ext cx="11024871" cy="3876040"/>
         </p:xfrm>
         <a:graphic>
           <a:graphicData uri="http://schemas.openxmlformats.org/drawingml/2006/table">
@@ -5073,7 +5073,7 @@
                     <a:p>
                       <a:r>
                         <a:rPr lang="en-US" dirty="0"/>
-                        <a:t>CHATGPT</a:t>
+                        <a:t>CHATGP0054</a:t>
                       </a:r>
                     </a:p>
                   </a:txBody>

</xml_diff>

<commit_message>
Remove 2 models from Groq Llama due to free-tier access restrictions
</commit_message>
<xml_diff>
--- a/Reference/briefing project.pptx
+++ b/Reference/briefing project.pptx
@@ -5,7 +5,7 @@
     <p:sldMasterId id="2147483648" r:id="rId1"/>
   </p:sldMasterIdLst>
   <p:notesMasterIdLst>
-    <p:notesMasterId r:id="rId11"/>
+    <p:notesMasterId r:id="rId13"/>
   </p:notesMasterIdLst>
   <p:sldIdLst>
     <p:sldId id="256" r:id="rId2"/>
@@ -16,7 +16,9 @@
     <p:sldId id="258" r:id="rId7"/>
     <p:sldId id="260" r:id="rId8"/>
     <p:sldId id="264" r:id="rId9"/>
-    <p:sldId id="265" r:id="rId10"/>
+    <p:sldId id="267" r:id="rId10"/>
+    <p:sldId id="265" r:id="rId11"/>
+    <p:sldId id="266" r:id="rId12"/>
   </p:sldIdLst>
   <p:sldSz cx="12192000" cy="6858000"/>
   <p:notesSz cx="6858000" cy="9144000"/>
@@ -205,7 +207,7 @@
           <a:p>
             <a:fld id="{53B61C8E-81CB-4032-8EA4-7F2345ECEA2B}" type="datetimeFigureOut">
               <a:rPr lang="en-MY" smtClean="0"/>
-              <a:t>9/10/2026</a:t>
+              <a:t>15/10/2026</a:t>
             </a:fld>
             <a:endParaRPr lang="en-MY"/>
           </a:p>
@@ -706,7 +708,7 @@
           <a:p>
             <a:fld id="{4449257F-037A-47B5-A07B-A73CC606E6AA}" type="datetimeFigureOut">
               <a:rPr lang="en-MY" smtClean="0"/>
-              <a:t>9/10/2026</a:t>
+              <a:t>15/10/2026</a:t>
             </a:fld>
             <a:endParaRPr lang="en-MY"/>
           </a:p>
@@ -906,7 +908,7 @@
           <a:p>
             <a:fld id="{4449257F-037A-47B5-A07B-A73CC606E6AA}" type="datetimeFigureOut">
               <a:rPr lang="en-MY" smtClean="0"/>
-              <a:t>9/10/2026</a:t>
+              <a:t>15/10/2026</a:t>
             </a:fld>
             <a:endParaRPr lang="en-MY"/>
           </a:p>
@@ -1116,7 +1118,7 @@
           <a:p>
             <a:fld id="{4449257F-037A-47B5-A07B-A73CC606E6AA}" type="datetimeFigureOut">
               <a:rPr lang="en-MY" smtClean="0"/>
-              <a:t>9/10/2026</a:t>
+              <a:t>15/10/2026</a:t>
             </a:fld>
             <a:endParaRPr lang="en-MY"/>
           </a:p>
@@ -1316,7 +1318,7 @@
           <a:p>
             <a:fld id="{4449257F-037A-47B5-A07B-A73CC606E6AA}" type="datetimeFigureOut">
               <a:rPr lang="en-MY" smtClean="0"/>
-              <a:t>9/10/2026</a:t>
+              <a:t>15/10/2026</a:t>
             </a:fld>
             <a:endParaRPr lang="en-MY"/>
           </a:p>
@@ -1592,7 +1594,7 @@
           <a:p>
             <a:fld id="{4449257F-037A-47B5-A07B-A73CC606E6AA}" type="datetimeFigureOut">
               <a:rPr lang="en-MY" smtClean="0"/>
-              <a:t>9/10/2026</a:t>
+              <a:t>15/10/2026</a:t>
             </a:fld>
             <a:endParaRPr lang="en-MY"/>
           </a:p>
@@ -1860,7 +1862,7 @@
           <a:p>
             <a:fld id="{4449257F-037A-47B5-A07B-A73CC606E6AA}" type="datetimeFigureOut">
               <a:rPr lang="en-MY" smtClean="0"/>
-              <a:t>9/10/2026</a:t>
+              <a:t>15/10/2026</a:t>
             </a:fld>
             <a:endParaRPr lang="en-MY"/>
           </a:p>
@@ -2275,7 +2277,7 @@
           <a:p>
             <a:fld id="{4449257F-037A-47B5-A07B-A73CC606E6AA}" type="datetimeFigureOut">
               <a:rPr lang="en-MY" smtClean="0"/>
-              <a:t>9/10/2026</a:t>
+              <a:t>15/10/2026</a:t>
             </a:fld>
             <a:endParaRPr lang="en-MY"/>
           </a:p>
@@ -2417,7 +2419,7 @@
           <a:p>
             <a:fld id="{4449257F-037A-47B5-A07B-A73CC606E6AA}" type="datetimeFigureOut">
               <a:rPr lang="en-MY" smtClean="0"/>
-              <a:t>9/10/2026</a:t>
+              <a:t>15/10/2026</a:t>
             </a:fld>
             <a:endParaRPr lang="en-MY"/>
           </a:p>
@@ -2530,7 +2532,7 @@
           <a:p>
             <a:fld id="{4449257F-037A-47B5-A07B-A73CC606E6AA}" type="datetimeFigureOut">
               <a:rPr lang="en-MY" smtClean="0"/>
-              <a:t>9/10/2026</a:t>
+              <a:t>15/10/2026</a:t>
             </a:fld>
             <a:endParaRPr lang="en-MY"/>
           </a:p>
@@ -2843,7 +2845,7 @@
           <a:p>
             <a:fld id="{4449257F-037A-47B5-A07B-A73CC606E6AA}" type="datetimeFigureOut">
               <a:rPr lang="en-MY" smtClean="0"/>
-              <a:t>9/10/2026</a:t>
+              <a:t>15/10/2026</a:t>
             </a:fld>
             <a:endParaRPr lang="en-MY"/>
           </a:p>
@@ -3132,7 +3134,7 @@
           <a:p>
             <a:fld id="{4449257F-037A-47B5-A07B-A73CC606E6AA}" type="datetimeFigureOut">
               <a:rPr lang="en-MY" smtClean="0"/>
-              <a:t>9/10/2026</a:t>
+              <a:t>15/10/2026</a:t>
             </a:fld>
             <a:endParaRPr lang="en-MY"/>
           </a:p>
@@ -3375,7 +3377,7 @@
           <a:p>
             <a:fld id="{4449257F-037A-47B5-A07B-A73CC606E6AA}" type="datetimeFigureOut">
               <a:rPr lang="en-MY" smtClean="0"/>
-              <a:t>9/10/2026</a:t>
+              <a:t>15/10/2026</a:t>
             </a:fld>
             <a:endParaRPr lang="en-MY"/>
           </a:p>
@@ -3854,6 +3856,1093 @@
     <p:extLst>
       <p:ext uri="{BB962C8B-B14F-4D97-AF65-F5344CB8AC3E}">
         <p14:creationId xmlns:p14="http://schemas.microsoft.com/office/powerpoint/2010/main" val="2359966502"/>
+      </p:ext>
+    </p:extLst>
+  </p:cSld>
+  <p:clrMapOvr>
+    <a:masterClrMapping/>
+  </p:clrMapOvr>
+</p:sld>
+</file>
+
+<file path=ppt/slides/slide10.xml><?xml version="1.0" encoding="utf-8"?>
+<p:sld xmlns:a="http://schemas.openxmlformats.org/drawingml/2006/main" xmlns:r="http://schemas.openxmlformats.org/officeDocument/2006/relationships" xmlns:p="http://schemas.openxmlformats.org/presentationml/2006/main">
+  <p:cSld>
+    <p:spTree>
+      <p:nvGrpSpPr>
+        <p:cNvPr id="1" name=""/>
+        <p:cNvGrpSpPr/>
+        <p:nvPr/>
+      </p:nvGrpSpPr>
+      <p:grpSpPr>
+        <a:xfrm>
+          <a:off x="0" y="0"/>
+          <a:ext cx="0" cy="0"/>
+          <a:chOff x="0" y="0"/>
+          <a:chExt cx="0" cy="0"/>
+        </a:xfrm>
+      </p:grpSpPr>
+      <p:pic>
+        <p:nvPicPr>
+          <p:cNvPr id="5" name="Picture 4">
+            <a:extLst>
+              <a:ext uri="{FF2B5EF4-FFF2-40B4-BE49-F238E27FC236}">
+                <a16:creationId xmlns:a16="http://schemas.microsoft.com/office/drawing/2014/main" id="{CE86D122-665A-1204-703D-FF94B43B3207}"/>
+              </a:ext>
+            </a:extLst>
+          </p:cNvPr>
+          <p:cNvPicPr>
+            <a:picLocks noChangeAspect="1"/>
+          </p:cNvPicPr>
+          <p:nvPr/>
+        </p:nvPicPr>
+        <p:blipFill>
+          <a:blip r:embed="rId2"/>
+          <a:stretch>
+            <a:fillRect/>
+          </a:stretch>
+        </p:blipFill>
+        <p:spPr>
+          <a:xfrm>
+            <a:off x="2343150" y="1213346"/>
+            <a:ext cx="8025262" cy="4120654"/>
+          </a:xfrm>
+          <a:prstGeom prst="rect">
+            <a:avLst/>
+          </a:prstGeom>
+        </p:spPr>
+      </p:pic>
+      <p:sp>
+        <p:nvSpPr>
+          <p:cNvPr id="7" name="Rectangle 6">
+            <a:extLst>
+              <a:ext uri="{FF2B5EF4-FFF2-40B4-BE49-F238E27FC236}">
+                <a16:creationId xmlns:a16="http://schemas.microsoft.com/office/drawing/2014/main" id="{91FD3543-D30A-2D21-058B-CB0164D45589}"/>
+              </a:ext>
+            </a:extLst>
+          </p:cNvPr>
+          <p:cNvSpPr/>
+          <p:nvPr/>
+        </p:nvSpPr>
+        <p:spPr>
+          <a:xfrm>
+            <a:off x="422042" y="5410926"/>
+            <a:ext cx="11347915" cy="584775"/>
+          </a:xfrm>
+          <a:prstGeom prst="rect">
+            <a:avLst/>
+          </a:prstGeom>
+          <a:noFill/>
+        </p:spPr>
+        <p:txBody>
+          <a:bodyPr wrap="none" lIns="91440" tIns="45720" rIns="91440" bIns="45720">
+            <a:spAutoFit/>
+          </a:bodyPr>
+          <a:lstStyle/>
+          <a:p>
+            <a:pPr algn="ctr"/>
+            <a:r>
+              <a:rPr lang="en-US" sz="3200" dirty="0">
+                <a:ln w="0"/>
+                <a:effectLst>
+                  <a:outerShdw blurRad="38100" dist="19050" dir="2700000" algn="tl" rotWithShape="0">
+                    <a:schemeClr val="dk1">
+                      <a:alpha val="40000"/>
+                    </a:schemeClr>
+                  </a:outerShdw>
+                </a:effectLst>
+              </a:rPr>
+              <a:t>Attention : Need to rename the “New Instance” into the variable</a:t>
+            </a:r>
+            <a:endParaRPr lang="en-US" sz="3200" b="0" cap="none" spc="0" dirty="0">
+              <a:ln w="0"/>
+              <a:solidFill>
+                <a:schemeClr val="tx1"/>
+              </a:solidFill>
+              <a:effectLst>
+                <a:outerShdw blurRad="38100" dist="19050" dir="2700000" algn="tl" rotWithShape="0">
+                  <a:schemeClr val="dk1">
+                    <a:alpha val="40000"/>
+                  </a:schemeClr>
+                </a:outerShdw>
+              </a:effectLst>
+            </a:endParaRPr>
+          </a:p>
+        </p:txBody>
+      </p:sp>
+      <p:sp>
+        <p:nvSpPr>
+          <p:cNvPr id="3" name="TextBox 2">
+            <a:extLst>
+              <a:ext uri="{FF2B5EF4-FFF2-40B4-BE49-F238E27FC236}">
+                <a16:creationId xmlns:a16="http://schemas.microsoft.com/office/drawing/2014/main" id="{1B3D4504-ADAB-FF63-A05E-D48CD20BD35A}"/>
+              </a:ext>
+            </a:extLst>
+          </p:cNvPr>
+          <p:cNvSpPr txBox="1"/>
+          <p:nvPr/>
+        </p:nvSpPr>
+        <p:spPr>
+          <a:xfrm>
+            <a:off x="4465068" y="277524"/>
+            <a:ext cx="3781425" cy="584775"/>
+          </a:xfrm>
+          <a:prstGeom prst="rect">
+            <a:avLst/>
+          </a:prstGeom>
+          <a:noFill/>
+        </p:spPr>
+        <p:txBody>
+          <a:bodyPr wrap="square">
+            <a:spAutoFit/>
+          </a:bodyPr>
+          <a:lstStyle/>
+          <a:p>
+            <a:r>
+              <a:rPr lang="en-US" sz="3200" dirty="0">
+                <a:ln w="0"/>
+                <a:effectLst>
+                  <a:outerShdw blurRad="38100" dist="19050" dir="2700000" algn="tl" rotWithShape="0">
+                    <a:schemeClr val="dk1">
+                      <a:alpha val="40000"/>
+                    </a:schemeClr>
+                  </a:outerShdw>
+                </a:effectLst>
+              </a:rPr>
+              <a:t>Issue and Attention</a:t>
+            </a:r>
+            <a:endParaRPr lang="en-MY" dirty="0"/>
+          </a:p>
+        </p:txBody>
+      </p:sp>
+    </p:spTree>
+    <p:extLst>
+      <p:ext uri="{BB962C8B-B14F-4D97-AF65-F5344CB8AC3E}">
+        <p14:creationId xmlns:p14="http://schemas.microsoft.com/office/powerpoint/2010/main" val="3804746096"/>
+      </p:ext>
+    </p:extLst>
+  </p:cSld>
+  <p:clrMapOvr>
+    <a:masterClrMapping/>
+  </p:clrMapOvr>
+</p:sld>
+</file>
+
+<file path=ppt/slides/slide11.xml><?xml version="1.0" encoding="utf-8"?>
+<p:sld xmlns:a="http://schemas.openxmlformats.org/drawingml/2006/main" xmlns:r="http://schemas.openxmlformats.org/officeDocument/2006/relationships" xmlns:p="http://schemas.openxmlformats.org/presentationml/2006/main">
+  <p:cSld>
+    <p:spTree>
+      <p:nvGrpSpPr>
+        <p:cNvPr id="1" name="">
+          <a:extLst>
+            <a:ext uri="{FF2B5EF4-FFF2-40B4-BE49-F238E27FC236}">
+              <a16:creationId xmlns:a16="http://schemas.microsoft.com/office/drawing/2014/main" id="{B60765EB-3049-5AEB-5F04-49A7245D3A2A}"/>
+            </a:ext>
+          </a:extLst>
+        </p:cNvPr>
+        <p:cNvGrpSpPr/>
+        <p:nvPr/>
+      </p:nvGrpSpPr>
+      <p:grpSpPr>
+        <a:xfrm>
+          <a:off x="0" y="0"/>
+          <a:ext cx="0" cy="0"/>
+          <a:chOff x="0" y="0"/>
+          <a:chExt cx="0" cy="0"/>
+        </a:xfrm>
+      </p:grpSpPr>
+      <p:sp>
+        <p:nvSpPr>
+          <p:cNvPr id="7" name="Rectangle 6">
+            <a:extLst>
+              <a:ext uri="{FF2B5EF4-FFF2-40B4-BE49-F238E27FC236}">
+                <a16:creationId xmlns:a16="http://schemas.microsoft.com/office/drawing/2014/main" id="{E05FB92E-922B-D312-58C4-F741ED466021}"/>
+              </a:ext>
+            </a:extLst>
+          </p:cNvPr>
+          <p:cNvSpPr/>
+          <p:nvPr/>
+        </p:nvSpPr>
+        <p:spPr>
+          <a:xfrm>
+            <a:off x="406344" y="1410426"/>
+            <a:ext cx="1587614" cy="892552"/>
+          </a:xfrm>
+          <a:prstGeom prst="rect">
+            <a:avLst/>
+          </a:prstGeom>
+          <a:noFill/>
+          <a:ln>
+            <a:solidFill>
+              <a:schemeClr val="accent1"/>
+            </a:solidFill>
+          </a:ln>
+        </p:spPr>
+        <p:txBody>
+          <a:bodyPr wrap="none" lIns="91440" tIns="45720" rIns="91440" bIns="45720">
+            <a:spAutoFit/>
+          </a:bodyPr>
+          <a:lstStyle/>
+          <a:p>
+            <a:pPr algn="ctr"/>
+            <a:r>
+              <a:rPr lang="en-US" sz="2000" dirty="0">
+                <a:ln w="0"/>
+                <a:effectLst>
+                  <a:outerShdw blurRad="38100" dist="19050" dir="2700000" algn="tl" rotWithShape="0">
+                    <a:schemeClr val="dk1">
+                      <a:alpha val="40000"/>
+                    </a:schemeClr>
+                  </a:outerShdw>
+                </a:effectLst>
+              </a:rPr>
+              <a:t>Open Router</a:t>
+            </a:r>
+          </a:p>
+          <a:p>
+            <a:pPr algn="ctr"/>
+            <a:r>
+              <a:rPr lang="en-US" sz="1600" b="0" cap="none" spc="0" dirty="0">
+                <a:ln w="0"/>
+                <a:solidFill>
+                  <a:schemeClr val="tx1"/>
+                </a:solidFill>
+                <a:effectLst>
+                  <a:outerShdw blurRad="38100" dist="19050" dir="2700000" algn="tl" rotWithShape="0">
+                    <a:schemeClr val="dk1">
+                      <a:alpha val="40000"/>
+                    </a:schemeClr>
+                  </a:outerShdw>
+                </a:effectLst>
+              </a:rPr>
+              <a:t>(22/09/2026)</a:t>
+            </a:r>
+          </a:p>
+          <a:p>
+            <a:pPr algn="ctr"/>
+            <a:r>
+              <a:rPr lang="en-US" sz="1600" dirty="0">
+                <a:ln w="0"/>
+                <a:effectLst>
+                  <a:outerShdw blurRad="38100" dist="19050" dir="2700000" algn="tl" rotWithShape="0">
+                    <a:schemeClr val="dk1">
+                      <a:alpha val="40000"/>
+                    </a:schemeClr>
+                  </a:outerShdw>
+                </a:effectLst>
+              </a:rPr>
+              <a:t>September</a:t>
+            </a:r>
+            <a:endParaRPr lang="en-US" sz="1600" b="0" cap="none" spc="0" dirty="0">
+              <a:ln w="0"/>
+              <a:solidFill>
+                <a:schemeClr val="tx1"/>
+              </a:solidFill>
+              <a:effectLst>
+                <a:outerShdw blurRad="38100" dist="19050" dir="2700000" algn="tl" rotWithShape="0">
+                  <a:schemeClr val="dk1">
+                    <a:alpha val="40000"/>
+                  </a:schemeClr>
+                </a:outerShdw>
+              </a:effectLst>
+            </a:endParaRPr>
+          </a:p>
+        </p:txBody>
+      </p:sp>
+      <p:sp>
+        <p:nvSpPr>
+          <p:cNvPr id="3" name="TextBox 2">
+            <a:extLst>
+              <a:ext uri="{FF2B5EF4-FFF2-40B4-BE49-F238E27FC236}">
+                <a16:creationId xmlns:a16="http://schemas.microsoft.com/office/drawing/2014/main" id="{18614AE2-F531-8D7A-7073-766D4D8C439C}"/>
+              </a:ext>
+            </a:extLst>
+          </p:cNvPr>
+          <p:cNvSpPr txBox="1"/>
+          <p:nvPr/>
+        </p:nvSpPr>
+        <p:spPr>
+          <a:xfrm>
+            <a:off x="4465068" y="277524"/>
+            <a:ext cx="3781425" cy="584775"/>
+          </a:xfrm>
+          <a:prstGeom prst="rect">
+            <a:avLst/>
+          </a:prstGeom>
+          <a:noFill/>
+        </p:spPr>
+        <p:txBody>
+          <a:bodyPr wrap="square">
+            <a:spAutoFit/>
+          </a:bodyPr>
+          <a:lstStyle/>
+          <a:p>
+            <a:r>
+              <a:rPr lang="en-US" sz="3200" dirty="0">
+                <a:ln w="0"/>
+                <a:effectLst>
+                  <a:outerShdw blurRad="38100" dist="19050" dir="2700000" algn="tl" rotWithShape="0">
+                    <a:schemeClr val="dk1">
+                      <a:alpha val="40000"/>
+                    </a:schemeClr>
+                  </a:outerShdw>
+                </a:effectLst>
+              </a:rPr>
+              <a:t>Project Movement</a:t>
+            </a:r>
+            <a:endParaRPr lang="en-MY" dirty="0"/>
+          </a:p>
+        </p:txBody>
+      </p:sp>
+      <p:sp>
+        <p:nvSpPr>
+          <p:cNvPr id="4" name="Rectangle 3">
+            <a:extLst>
+              <a:ext uri="{FF2B5EF4-FFF2-40B4-BE49-F238E27FC236}">
+                <a16:creationId xmlns:a16="http://schemas.microsoft.com/office/drawing/2014/main" id="{EC149E04-521F-597F-7A48-CC1065EB68F7}"/>
+              </a:ext>
+            </a:extLst>
+          </p:cNvPr>
+          <p:cNvSpPr/>
+          <p:nvPr/>
+        </p:nvSpPr>
+        <p:spPr>
+          <a:xfrm>
+            <a:off x="2857005" y="1410426"/>
+            <a:ext cx="2577949" cy="892552"/>
+          </a:xfrm>
+          <a:prstGeom prst="rect">
+            <a:avLst/>
+          </a:prstGeom>
+          <a:noFill/>
+          <a:ln>
+            <a:solidFill>
+              <a:schemeClr val="accent1"/>
+            </a:solidFill>
+          </a:ln>
+        </p:spPr>
+        <p:txBody>
+          <a:bodyPr wrap="none" lIns="91440" tIns="45720" rIns="91440" bIns="45720">
+            <a:spAutoFit/>
+          </a:bodyPr>
+          <a:lstStyle/>
+          <a:p>
+            <a:pPr algn="ctr"/>
+            <a:r>
+              <a:rPr lang="en-US" sz="2000" dirty="0">
+                <a:ln w="0"/>
+                <a:effectLst>
+                  <a:outerShdw blurRad="38100" dist="19050" dir="2700000" algn="tl" rotWithShape="0">
+                    <a:schemeClr val="dk1">
+                      <a:alpha val="40000"/>
+                    </a:schemeClr>
+                  </a:outerShdw>
+                </a:effectLst>
+              </a:rPr>
+              <a:t>Subscribe API Claude</a:t>
+            </a:r>
+          </a:p>
+          <a:p>
+            <a:pPr algn="ctr"/>
+            <a:r>
+              <a:rPr lang="en-US" sz="1600" b="0" cap="none" spc="0" dirty="0">
+                <a:ln w="0"/>
+                <a:solidFill>
+                  <a:schemeClr val="tx1"/>
+                </a:solidFill>
+                <a:effectLst>
+                  <a:outerShdw blurRad="38100" dist="19050" dir="2700000" algn="tl" rotWithShape="0">
+                    <a:schemeClr val="dk1">
+                      <a:alpha val="40000"/>
+                    </a:schemeClr>
+                  </a:outerShdw>
+                </a:effectLst>
+              </a:rPr>
+              <a:t>(29/09/2026)</a:t>
+            </a:r>
+          </a:p>
+          <a:p>
+            <a:pPr algn="ctr"/>
+            <a:r>
+              <a:rPr lang="en-US" sz="1600" dirty="0">
+                <a:ln w="0"/>
+                <a:effectLst>
+                  <a:outerShdw blurRad="38100" dist="19050" dir="2700000" algn="tl" rotWithShape="0">
+                    <a:schemeClr val="dk1">
+                      <a:alpha val="40000"/>
+                    </a:schemeClr>
+                  </a:outerShdw>
+                </a:effectLst>
+              </a:rPr>
+              <a:t>September</a:t>
+            </a:r>
+            <a:endParaRPr lang="en-US" sz="1600" b="0" cap="none" spc="0" dirty="0">
+              <a:ln w="0"/>
+              <a:solidFill>
+                <a:schemeClr val="tx1"/>
+              </a:solidFill>
+              <a:effectLst>
+                <a:outerShdw blurRad="38100" dist="19050" dir="2700000" algn="tl" rotWithShape="0">
+                  <a:schemeClr val="dk1">
+                    <a:alpha val="40000"/>
+                  </a:schemeClr>
+                </a:outerShdw>
+              </a:effectLst>
+            </a:endParaRPr>
+          </a:p>
+        </p:txBody>
+      </p:sp>
+      <p:sp>
+        <p:nvSpPr>
+          <p:cNvPr id="8" name="Rectangle 7">
+            <a:extLst>
+              <a:ext uri="{FF2B5EF4-FFF2-40B4-BE49-F238E27FC236}">
+                <a16:creationId xmlns:a16="http://schemas.microsoft.com/office/drawing/2014/main" id="{288CA388-17E5-3E65-695C-DBC6DFB62D2F}"/>
+              </a:ext>
+            </a:extLst>
+          </p:cNvPr>
+          <p:cNvSpPr/>
+          <p:nvPr/>
+        </p:nvSpPr>
+        <p:spPr>
+          <a:xfrm>
+            <a:off x="9053486" y="1410426"/>
+            <a:ext cx="1316386" cy="892552"/>
+          </a:xfrm>
+          <a:prstGeom prst="rect">
+            <a:avLst/>
+          </a:prstGeom>
+          <a:noFill/>
+          <a:ln>
+            <a:solidFill>
+              <a:schemeClr val="accent1"/>
+            </a:solidFill>
+          </a:ln>
+        </p:spPr>
+        <p:txBody>
+          <a:bodyPr wrap="none" lIns="91440" tIns="45720" rIns="91440" bIns="45720">
+            <a:spAutoFit/>
+          </a:bodyPr>
+          <a:lstStyle/>
+          <a:p>
+            <a:pPr algn="ctr"/>
+            <a:r>
+              <a:rPr lang="en-US" sz="2000" dirty="0" err="1">
+                <a:ln w="0"/>
+                <a:effectLst>
+                  <a:outerShdw blurRad="38100" dist="19050" dir="2700000" algn="tl" rotWithShape="0">
+                    <a:schemeClr val="dk1">
+                      <a:alpha val="40000"/>
+                    </a:schemeClr>
+                  </a:outerShdw>
+                </a:effectLst>
+              </a:rPr>
+              <a:t>Groq</a:t>
+            </a:r>
+            <a:endParaRPr lang="en-US" sz="2000" dirty="0">
+              <a:ln w="0"/>
+              <a:effectLst>
+                <a:outerShdw blurRad="38100" dist="19050" dir="2700000" algn="tl" rotWithShape="0">
+                  <a:schemeClr val="dk1">
+                    <a:alpha val="40000"/>
+                  </a:schemeClr>
+                </a:outerShdw>
+              </a:effectLst>
+            </a:endParaRPr>
+          </a:p>
+          <a:p>
+            <a:pPr algn="ctr"/>
+            <a:r>
+              <a:rPr lang="en-US" sz="1600" b="0" cap="none" spc="0" dirty="0">
+                <a:ln w="0"/>
+                <a:solidFill>
+                  <a:schemeClr val="tx1"/>
+                </a:solidFill>
+                <a:effectLst>
+                  <a:outerShdw blurRad="38100" dist="19050" dir="2700000" algn="tl" rotWithShape="0">
+                    <a:schemeClr val="dk1">
+                      <a:alpha val="40000"/>
+                    </a:schemeClr>
+                  </a:outerShdw>
+                </a:effectLst>
+              </a:rPr>
+              <a:t>(29/09/2026)</a:t>
+            </a:r>
+          </a:p>
+          <a:p>
+            <a:pPr algn="ctr"/>
+            <a:r>
+              <a:rPr lang="en-US" sz="1600" dirty="0">
+                <a:ln w="0"/>
+                <a:effectLst>
+                  <a:outerShdw blurRad="38100" dist="19050" dir="2700000" algn="tl" rotWithShape="0">
+                    <a:schemeClr val="dk1">
+                      <a:alpha val="40000"/>
+                    </a:schemeClr>
+                  </a:outerShdw>
+                </a:effectLst>
+              </a:rPr>
+              <a:t>September</a:t>
+            </a:r>
+            <a:endParaRPr lang="en-US" sz="1600" b="0" cap="none" spc="0" dirty="0">
+              <a:ln w="0"/>
+              <a:solidFill>
+                <a:schemeClr val="tx1"/>
+              </a:solidFill>
+              <a:effectLst>
+                <a:outerShdw blurRad="38100" dist="19050" dir="2700000" algn="tl" rotWithShape="0">
+                  <a:schemeClr val="dk1">
+                    <a:alpha val="40000"/>
+                  </a:schemeClr>
+                </a:outerShdw>
+              </a:effectLst>
+            </a:endParaRPr>
+          </a:p>
+        </p:txBody>
+      </p:sp>
+      <p:sp>
+        <p:nvSpPr>
+          <p:cNvPr id="10" name="Rectangle 9">
+            <a:extLst>
+              <a:ext uri="{FF2B5EF4-FFF2-40B4-BE49-F238E27FC236}">
+                <a16:creationId xmlns:a16="http://schemas.microsoft.com/office/drawing/2014/main" id="{27C01C71-9952-0B37-B381-EC1C961E4DC9}"/>
+              </a:ext>
+            </a:extLst>
+          </p:cNvPr>
+          <p:cNvSpPr/>
+          <p:nvPr/>
+        </p:nvSpPr>
+        <p:spPr>
+          <a:xfrm>
+            <a:off x="6335043" y="1410426"/>
+            <a:ext cx="1622624" cy="892552"/>
+          </a:xfrm>
+          <a:prstGeom prst="rect">
+            <a:avLst/>
+          </a:prstGeom>
+          <a:noFill/>
+          <a:ln>
+            <a:solidFill>
+              <a:schemeClr val="accent1"/>
+            </a:solidFill>
+          </a:ln>
+        </p:spPr>
+        <p:txBody>
+          <a:bodyPr wrap="none" lIns="91440" tIns="45720" rIns="91440" bIns="45720">
+            <a:spAutoFit/>
+          </a:bodyPr>
+          <a:lstStyle/>
+          <a:p>
+            <a:pPr algn="ctr"/>
+            <a:r>
+              <a:rPr lang="en-US" sz="2000" dirty="0" err="1">
+                <a:ln w="0"/>
+                <a:effectLst>
+                  <a:outerShdw blurRad="38100" dist="19050" dir="2700000" algn="tl" rotWithShape="0">
+                    <a:schemeClr val="dk1">
+                      <a:alpha val="40000"/>
+                    </a:schemeClr>
+                  </a:outerShdw>
+                </a:effectLst>
+              </a:rPr>
+              <a:t>HuggingFace</a:t>
+            </a:r>
+            <a:endParaRPr lang="en-US" sz="2000" dirty="0">
+              <a:ln w="0"/>
+              <a:effectLst>
+                <a:outerShdw blurRad="38100" dist="19050" dir="2700000" algn="tl" rotWithShape="0">
+                  <a:schemeClr val="dk1">
+                    <a:alpha val="40000"/>
+                  </a:schemeClr>
+                </a:outerShdw>
+              </a:effectLst>
+            </a:endParaRPr>
+          </a:p>
+          <a:p>
+            <a:pPr algn="ctr"/>
+            <a:r>
+              <a:rPr lang="en-US" sz="1600" b="0" cap="none" spc="0" dirty="0">
+                <a:ln w="0"/>
+                <a:solidFill>
+                  <a:schemeClr val="tx1"/>
+                </a:solidFill>
+                <a:effectLst>
+                  <a:outerShdw blurRad="38100" dist="19050" dir="2700000" algn="tl" rotWithShape="0">
+                    <a:schemeClr val="dk1">
+                      <a:alpha val="40000"/>
+                    </a:schemeClr>
+                  </a:outerShdw>
+                </a:effectLst>
+              </a:rPr>
+              <a:t>(29/09/2026)</a:t>
+            </a:r>
+          </a:p>
+          <a:p>
+            <a:pPr algn="ctr"/>
+            <a:r>
+              <a:rPr lang="en-US" sz="1600" dirty="0">
+                <a:ln w="0"/>
+                <a:effectLst>
+                  <a:outerShdw blurRad="38100" dist="19050" dir="2700000" algn="tl" rotWithShape="0">
+                    <a:schemeClr val="dk1">
+                      <a:alpha val="40000"/>
+                    </a:schemeClr>
+                  </a:outerShdw>
+                </a:effectLst>
+              </a:rPr>
+              <a:t>September</a:t>
+            </a:r>
+            <a:endParaRPr lang="en-US" sz="1600" b="0" cap="none" spc="0" dirty="0">
+              <a:ln w="0"/>
+              <a:solidFill>
+                <a:schemeClr val="tx1"/>
+              </a:solidFill>
+              <a:effectLst>
+                <a:outerShdw blurRad="38100" dist="19050" dir="2700000" algn="tl" rotWithShape="0">
+                  <a:schemeClr val="dk1">
+                    <a:alpha val="40000"/>
+                  </a:schemeClr>
+                </a:outerShdw>
+              </a:effectLst>
+            </a:endParaRPr>
+          </a:p>
+        </p:txBody>
+      </p:sp>
+      <p:sp>
+        <p:nvSpPr>
+          <p:cNvPr id="12" name="Rectangle 11">
+            <a:extLst>
+              <a:ext uri="{FF2B5EF4-FFF2-40B4-BE49-F238E27FC236}">
+                <a16:creationId xmlns:a16="http://schemas.microsoft.com/office/drawing/2014/main" id="{E532FD0C-F2F7-D990-31FB-B47CD996AC76}"/>
+              </a:ext>
+            </a:extLst>
+          </p:cNvPr>
+          <p:cNvSpPr/>
+          <p:nvPr/>
+        </p:nvSpPr>
+        <p:spPr>
+          <a:xfrm>
+            <a:off x="534456" y="3540519"/>
+            <a:ext cx="1331390" cy="1200329"/>
+          </a:xfrm>
+          <a:prstGeom prst="rect">
+            <a:avLst/>
+          </a:prstGeom>
+          <a:noFill/>
+          <a:ln>
+            <a:solidFill>
+              <a:schemeClr val="accent1"/>
+            </a:solidFill>
+          </a:ln>
+        </p:spPr>
+        <p:txBody>
+          <a:bodyPr wrap="none" lIns="91440" tIns="45720" rIns="91440" bIns="45720">
+            <a:spAutoFit/>
+          </a:bodyPr>
+          <a:lstStyle/>
+          <a:p>
+            <a:pPr algn="ctr"/>
+            <a:r>
+              <a:rPr lang="en-US" sz="2000" dirty="0">
+                <a:ln w="0"/>
+                <a:effectLst>
+                  <a:outerShdw blurRad="38100" dist="19050" dir="2700000" algn="tl" rotWithShape="0">
+                    <a:schemeClr val="dk1">
+                      <a:alpha val="40000"/>
+                    </a:schemeClr>
+                  </a:outerShdw>
+                </a:effectLst>
+              </a:rPr>
+              <a:t>Token has </a:t>
+            </a:r>
+          </a:p>
+          <a:p>
+            <a:pPr algn="ctr"/>
+            <a:r>
+              <a:rPr lang="en-US" sz="2000" dirty="0">
+                <a:ln w="0"/>
+                <a:effectLst>
+                  <a:outerShdw blurRad="38100" dist="19050" dir="2700000" algn="tl" rotWithShape="0">
+                    <a:schemeClr val="dk1">
+                      <a:alpha val="40000"/>
+                    </a:schemeClr>
+                  </a:outerShdw>
+                </a:effectLst>
+              </a:rPr>
+              <a:t>Run out</a:t>
+            </a:r>
+          </a:p>
+          <a:p>
+            <a:pPr algn="ctr"/>
+            <a:r>
+              <a:rPr lang="en-US" sz="1600" b="0" cap="none" spc="0" dirty="0">
+                <a:ln w="0"/>
+                <a:solidFill>
+                  <a:schemeClr val="tx1"/>
+                </a:solidFill>
+                <a:effectLst>
+                  <a:outerShdw blurRad="38100" dist="19050" dir="2700000" algn="tl" rotWithShape="0">
+                    <a:schemeClr val="dk1">
+                      <a:alpha val="40000"/>
+                    </a:schemeClr>
+                  </a:outerShdw>
+                </a:effectLst>
+              </a:rPr>
+              <a:t>(08/10/2026)</a:t>
+            </a:r>
+          </a:p>
+          <a:p>
+            <a:pPr algn="ctr"/>
+            <a:r>
+              <a:rPr lang="en-US" sz="1600" dirty="0">
+                <a:ln w="0"/>
+                <a:effectLst>
+                  <a:outerShdw blurRad="38100" dist="19050" dir="2700000" algn="tl" rotWithShape="0">
+                    <a:schemeClr val="dk1">
+                      <a:alpha val="40000"/>
+                    </a:schemeClr>
+                  </a:outerShdw>
+                </a:effectLst>
+              </a:rPr>
+              <a:t>October</a:t>
+            </a:r>
+          </a:p>
+        </p:txBody>
+      </p:sp>
+      <p:cxnSp>
+        <p:nvCxnSpPr>
+          <p:cNvPr id="14" name="Straight Arrow Connector 13">
+            <a:extLst>
+              <a:ext uri="{FF2B5EF4-FFF2-40B4-BE49-F238E27FC236}">
+                <a16:creationId xmlns:a16="http://schemas.microsoft.com/office/drawing/2014/main" id="{038FAF7D-C850-A23A-6B1B-C49C6664F8DE}"/>
+              </a:ext>
+            </a:extLst>
+          </p:cNvPr>
+          <p:cNvCxnSpPr>
+            <a:stCxn id="7" idx="2"/>
+            <a:endCxn id="12" idx="0"/>
+          </p:cNvCxnSpPr>
+          <p:nvPr/>
+        </p:nvCxnSpPr>
+        <p:spPr>
+          <a:xfrm>
+            <a:off x="1200151" y="2302978"/>
+            <a:ext cx="0" cy="1237541"/>
+          </a:xfrm>
+          <a:prstGeom prst="straightConnector1">
+            <a:avLst/>
+          </a:prstGeom>
+          <a:ln w="57150">
+            <a:tailEnd type="triangle"/>
+          </a:ln>
+        </p:spPr>
+        <p:style>
+          <a:lnRef idx="2">
+            <a:schemeClr val="accent1"/>
+          </a:lnRef>
+          <a:fillRef idx="0">
+            <a:schemeClr val="accent1"/>
+          </a:fillRef>
+          <a:effectRef idx="1">
+            <a:schemeClr val="accent1"/>
+          </a:effectRef>
+          <a:fontRef idx="minor">
+            <a:schemeClr val="tx1"/>
+          </a:fontRef>
+        </p:style>
+      </p:cxnSp>
+      <p:sp>
+        <p:nvSpPr>
+          <p:cNvPr id="17" name="Rectangle 16">
+            <a:extLst>
+              <a:ext uri="{FF2B5EF4-FFF2-40B4-BE49-F238E27FC236}">
+                <a16:creationId xmlns:a16="http://schemas.microsoft.com/office/drawing/2014/main" id="{5F27A6BE-D60A-9260-14CD-474732C32809}"/>
+              </a:ext>
+            </a:extLst>
+          </p:cNvPr>
+          <p:cNvSpPr/>
+          <p:nvPr/>
+        </p:nvSpPr>
+        <p:spPr>
+          <a:xfrm>
+            <a:off x="3480284" y="3540519"/>
+            <a:ext cx="1331390" cy="1200329"/>
+          </a:xfrm>
+          <a:prstGeom prst="rect">
+            <a:avLst/>
+          </a:prstGeom>
+          <a:noFill/>
+          <a:ln>
+            <a:solidFill>
+              <a:schemeClr val="accent1"/>
+            </a:solidFill>
+          </a:ln>
+        </p:spPr>
+        <p:txBody>
+          <a:bodyPr wrap="none" lIns="91440" tIns="45720" rIns="91440" bIns="45720">
+            <a:spAutoFit/>
+          </a:bodyPr>
+          <a:lstStyle/>
+          <a:p>
+            <a:pPr algn="ctr"/>
+            <a:r>
+              <a:rPr lang="en-US" sz="2000" dirty="0">
+                <a:ln w="0"/>
+                <a:effectLst>
+                  <a:outerShdw blurRad="38100" dist="19050" dir="2700000" algn="tl" rotWithShape="0">
+                    <a:schemeClr val="dk1">
+                      <a:alpha val="40000"/>
+                    </a:schemeClr>
+                  </a:outerShdw>
+                </a:effectLst>
+              </a:rPr>
+              <a:t>Token has </a:t>
+            </a:r>
+          </a:p>
+          <a:p>
+            <a:pPr algn="ctr"/>
+            <a:r>
+              <a:rPr lang="en-US" sz="2000" dirty="0">
+                <a:ln w="0"/>
+                <a:effectLst>
+                  <a:outerShdw blurRad="38100" dist="19050" dir="2700000" algn="tl" rotWithShape="0">
+                    <a:schemeClr val="dk1">
+                      <a:alpha val="40000"/>
+                    </a:schemeClr>
+                  </a:outerShdw>
+                </a:effectLst>
+              </a:rPr>
+              <a:t>Run out</a:t>
+            </a:r>
+          </a:p>
+          <a:p>
+            <a:pPr algn="ctr"/>
+            <a:r>
+              <a:rPr lang="en-US" sz="1600" b="0" cap="none" spc="0" dirty="0">
+                <a:ln w="0"/>
+                <a:solidFill>
+                  <a:schemeClr val="tx1"/>
+                </a:solidFill>
+                <a:effectLst>
+                  <a:outerShdw blurRad="38100" dist="19050" dir="2700000" algn="tl" rotWithShape="0">
+                    <a:schemeClr val="dk1">
+                      <a:alpha val="40000"/>
+                    </a:schemeClr>
+                  </a:outerShdw>
+                </a:effectLst>
+              </a:rPr>
+              <a:t>(08/10/2026)</a:t>
+            </a:r>
+          </a:p>
+          <a:p>
+            <a:pPr algn="ctr"/>
+            <a:r>
+              <a:rPr lang="en-US" sz="1600" dirty="0">
+                <a:ln w="0"/>
+                <a:effectLst>
+                  <a:outerShdw blurRad="38100" dist="19050" dir="2700000" algn="tl" rotWithShape="0">
+                    <a:schemeClr val="dk1">
+                      <a:alpha val="40000"/>
+                    </a:schemeClr>
+                  </a:outerShdw>
+                </a:effectLst>
+              </a:rPr>
+              <a:t>October</a:t>
+            </a:r>
+          </a:p>
+        </p:txBody>
+      </p:sp>
+      <p:cxnSp>
+        <p:nvCxnSpPr>
+          <p:cNvPr id="18" name="Straight Arrow Connector 17">
+            <a:extLst>
+              <a:ext uri="{FF2B5EF4-FFF2-40B4-BE49-F238E27FC236}">
+                <a16:creationId xmlns:a16="http://schemas.microsoft.com/office/drawing/2014/main" id="{E6E7E152-1DD7-3A6A-7FCA-DB518B702A71}"/>
+              </a:ext>
+            </a:extLst>
+          </p:cNvPr>
+          <p:cNvCxnSpPr>
+            <a:cxnSpLocks/>
+            <a:stCxn id="4" idx="2"/>
+            <a:endCxn id="17" idx="0"/>
+          </p:cNvCxnSpPr>
+          <p:nvPr/>
+        </p:nvCxnSpPr>
+        <p:spPr>
+          <a:xfrm flipH="1">
+            <a:off x="4145979" y="2302978"/>
+            <a:ext cx="1" cy="1237541"/>
+          </a:xfrm>
+          <a:prstGeom prst="straightConnector1">
+            <a:avLst/>
+          </a:prstGeom>
+          <a:ln w="57150">
+            <a:tailEnd type="triangle"/>
+          </a:ln>
+        </p:spPr>
+        <p:style>
+          <a:lnRef idx="2">
+            <a:schemeClr val="accent1"/>
+          </a:lnRef>
+          <a:fillRef idx="0">
+            <a:schemeClr val="accent1"/>
+          </a:fillRef>
+          <a:effectRef idx="1">
+            <a:schemeClr val="accent1"/>
+          </a:effectRef>
+          <a:fontRef idx="minor">
+            <a:schemeClr val="tx1"/>
+          </a:fontRef>
+        </p:style>
+      </p:cxnSp>
+      <p:sp>
+        <p:nvSpPr>
+          <p:cNvPr id="22" name="Rectangle 21">
+            <a:extLst>
+              <a:ext uri="{FF2B5EF4-FFF2-40B4-BE49-F238E27FC236}">
+                <a16:creationId xmlns:a16="http://schemas.microsoft.com/office/drawing/2014/main" id="{7588F2B3-40D2-5965-78F4-D4FABA6B0CB9}"/>
+              </a:ext>
+            </a:extLst>
+          </p:cNvPr>
+          <p:cNvSpPr/>
+          <p:nvPr/>
+        </p:nvSpPr>
+        <p:spPr>
+          <a:xfrm>
+            <a:off x="6480660" y="3429000"/>
+            <a:ext cx="1331390" cy="1200329"/>
+          </a:xfrm>
+          <a:prstGeom prst="rect">
+            <a:avLst/>
+          </a:prstGeom>
+          <a:noFill/>
+          <a:ln>
+            <a:solidFill>
+              <a:schemeClr val="accent1"/>
+            </a:solidFill>
+          </a:ln>
+        </p:spPr>
+        <p:txBody>
+          <a:bodyPr wrap="none" lIns="91440" tIns="45720" rIns="91440" bIns="45720">
+            <a:spAutoFit/>
+          </a:bodyPr>
+          <a:lstStyle/>
+          <a:p>
+            <a:pPr algn="ctr"/>
+            <a:r>
+              <a:rPr lang="en-US" sz="2000" dirty="0">
+                <a:ln w="0"/>
+                <a:effectLst>
+                  <a:outerShdw blurRad="38100" dist="19050" dir="2700000" algn="tl" rotWithShape="0">
+                    <a:schemeClr val="dk1">
+                      <a:alpha val="40000"/>
+                    </a:schemeClr>
+                  </a:outerShdw>
+                </a:effectLst>
+              </a:rPr>
+              <a:t>Token has </a:t>
+            </a:r>
+          </a:p>
+          <a:p>
+            <a:pPr algn="ctr"/>
+            <a:r>
+              <a:rPr lang="en-US" sz="2000" dirty="0">
+                <a:ln w="0"/>
+                <a:effectLst>
+                  <a:outerShdw blurRad="38100" dist="19050" dir="2700000" algn="tl" rotWithShape="0">
+                    <a:schemeClr val="dk1">
+                      <a:alpha val="40000"/>
+                    </a:schemeClr>
+                  </a:outerShdw>
+                </a:effectLst>
+              </a:rPr>
+              <a:t>Run out</a:t>
+            </a:r>
+          </a:p>
+          <a:p>
+            <a:pPr algn="ctr"/>
+            <a:r>
+              <a:rPr lang="en-US" sz="1600" b="0" cap="none" spc="0" dirty="0">
+                <a:ln w="0"/>
+                <a:solidFill>
+                  <a:schemeClr val="tx1"/>
+                </a:solidFill>
+                <a:effectLst>
+                  <a:outerShdw blurRad="38100" dist="19050" dir="2700000" algn="tl" rotWithShape="0">
+                    <a:schemeClr val="dk1">
+                      <a:alpha val="40000"/>
+                    </a:schemeClr>
+                  </a:outerShdw>
+                </a:effectLst>
+              </a:rPr>
+              <a:t>(08/10/2026)</a:t>
+            </a:r>
+          </a:p>
+          <a:p>
+            <a:pPr algn="ctr"/>
+            <a:r>
+              <a:rPr lang="en-US" sz="1600" dirty="0">
+                <a:ln w="0"/>
+                <a:effectLst>
+                  <a:outerShdw blurRad="38100" dist="19050" dir="2700000" algn="tl" rotWithShape="0">
+                    <a:schemeClr val="dk1">
+                      <a:alpha val="40000"/>
+                    </a:schemeClr>
+                  </a:outerShdw>
+                </a:effectLst>
+              </a:rPr>
+              <a:t>October</a:t>
+            </a:r>
+          </a:p>
+        </p:txBody>
+      </p:sp>
+      <p:cxnSp>
+        <p:nvCxnSpPr>
+          <p:cNvPr id="23" name="Straight Arrow Connector 22">
+            <a:extLst>
+              <a:ext uri="{FF2B5EF4-FFF2-40B4-BE49-F238E27FC236}">
+                <a16:creationId xmlns:a16="http://schemas.microsoft.com/office/drawing/2014/main" id="{E8D616AE-1AE9-752C-8157-D43113601A8B}"/>
+              </a:ext>
+            </a:extLst>
+          </p:cNvPr>
+          <p:cNvCxnSpPr>
+            <a:cxnSpLocks/>
+            <a:stCxn id="10" idx="2"/>
+            <a:endCxn id="22" idx="0"/>
+          </p:cNvCxnSpPr>
+          <p:nvPr/>
+        </p:nvCxnSpPr>
+        <p:spPr>
+          <a:xfrm>
+            <a:off x="7146355" y="2302978"/>
+            <a:ext cx="0" cy="1126022"/>
+          </a:xfrm>
+          <a:prstGeom prst="straightConnector1">
+            <a:avLst/>
+          </a:prstGeom>
+          <a:ln w="57150">
+            <a:tailEnd type="triangle"/>
+          </a:ln>
+        </p:spPr>
+        <p:style>
+          <a:lnRef idx="2">
+            <a:schemeClr val="accent1"/>
+          </a:lnRef>
+          <a:fillRef idx="0">
+            <a:schemeClr val="accent1"/>
+          </a:fillRef>
+          <a:effectRef idx="1">
+            <a:schemeClr val="accent1"/>
+          </a:effectRef>
+          <a:fontRef idx="minor">
+            <a:schemeClr val="tx1"/>
+          </a:fontRef>
+        </p:style>
+      </p:cxnSp>
+    </p:spTree>
+    <p:extLst>
+      <p:ext uri="{BB962C8B-B14F-4D97-AF65-F5344CB8AC3E}">
+        <p14:creationId xmlns:p14="http://schemas.microsoft.com/office/powerpoint/2010/main" val="2465909157"/>
       </p:ext>
     </p:extLst>
   </p:cSld>
@@ -5301,8 +6390,8 @@
         </p:blipFill>
         <p:spPr>
           <a:xfrm>
-            <a:off x="350394" y="747426"/>
-            <a:ext cx="6010161" cy="2567274"/>
+            <a:off x="1129654" y="1402570"/>
+            <a:ext cx="4597732" cy="1963947"/>
           </a:xfrm>
           <a:prstGeom prst="rect">
             <a:avLst/>
@@ -5323,8 +6412,8 @@
         </p:nvSpPr>
         <p:spPr>
           <a:xfrm>
-            <a:off x="485775" y="1400175"/>
-            <a:ext cx="409575" cy="1485900"/>
+            <a:off x="1189692" y="1864235"/>
+            <a:ext cx="356542" cy="1228725"/>
           </a:xfrm>
           <a:prstGeom prst="rect">
             <a:avLst/>
@@ -5375,8 +6464,8 @@
         </p:nvSpPr>
         <p:spPr>
           <a:xfrm>
-            <a:off x="1642829" y="162651"/>
-            <a:ext cx="3116558" cy="584775"/>
+            <a:off x="1395062" y="940905"/>
+            <a:ext cx="4166459" cy="461665"/>
           </a:xfrm>
           <a:prstGeom prst="rect">
             <a:avLst/>
@@ -5384,14 +6473,14 @@
           <a:noFill/>
         </p:spPr>
         <p:txBody>
-          <a:bodyPr wrap="none" lIns="91440" tIns="45720" rIns="91440" bIns="45720">
+          <a:bodyPr wrap="square" lIns="91440" tIns="45720" rIns="91440" bIns="45720">
             <a:spAutoFit/>
           </a:bodyPr>
           <a:lstStyle/>
           <a:p>
             <a:pPr algn="ctr"/>
             <a:r>
-              <a:rPr lang="en-US" sz="3200" b="0" cap="none" spc="0" dirty="0">
+              <a:rPr lang="en-US" sz="2400" b="0" cap="none" spc="0" dirty="0">
                 <a:ln w="0"/>
                 <a:solidFill>
                   <a:schemeClr val="tx1"/>
@@ -5431,8 +6520,8 @@
         </p:blipFill>
         <p:spPr>
           <a:xfrm>
-            <a:off x="6733522" y="747426"/>
-            <a:ext cx="4972703" cy="2547118"/>
+            <a:off x="7324368" y="1441812"/>
+            <a:ext cx="4328824" cy="2217310"/>
           </a:xfrm>
           <a:prstGeom prst="rect">
             <a:avLst/>
@@ -5453,8 +6542,8 @@
         </p:nvSpPr>
         <p:spPr>
           <a:xfrm>
-            <a:off x="8366823" y="162651"/>
-            <a:ext cx="1860574" cy="584775"/>
+            <a:off x="7920186" y="1024234"/>
+            <a:ext cx="2315297" cy="461665"/>
           </a:xfrm>
           <a:prstGeom prst="rect">
             <a:avLst/>
@@ -5462,14 +6551,14 @@
           <a:noFill/>
         </p:spPr>
         <p:txBody>
-          <a:bodyPr wrap="none" lIns="91440" tIns="45720" rIns="91440" bIns="45720">
+          <a:bodyPr wrap="square" lIns="91440" tIns="45720" rIns="91440" bIns="45720">
             <a:spAutoFit/>
           </a:bodyPr>
           <a:lstStyle/>
           <a:p>
             <a:pPr algn="ctr"/>
             <a:r>
-              <a:rPr lang="en-US" sz="3200" b="0" cap="none" spc="0" dirty="0">
+              <a:rPr lang="en-US" sz="2400" b="0" cap="none" spc="0" dirty="0">
                 <a:ln w="0"/>
                 <a:solidFill>
                   <a:schemeClr val="tx1"/>
@@ -5489,10 +6578,184 @@
       </p:sp>
       <p:sp>
         <p:nvSpPr>
-          <p:cNvPr id="12" name="Rectangle 11">
-            <a:extLst>
-              <a:ext uri="{FF2B5EF4-FFF2-40B4-BE49-F238E27FC236}">
-                <a16:creationId xmlns:a16="http://schemas.microsoft.com/office/drawing/2014/main" id="{FD1EFBD3-5C3A-1B95-E4F2-B98825611D58}"/>
+          <p:cNvPr id="13" name="TextBox 12">
+            <a:extLst>
+              <a:ext uri="{FF2B5EF4-FFF2-40B4-BE49-F238E27FC236}">
+                <a16:creationId xmlns:a16="http://schemas.microsoft.com/office/drawing/2014/main" id="{C4375A12-4EDB-C772-8208-E1E4D9D37733}"/>
+              </a:ext>
+            </a:extLst>
+          </p:cNvPr>
+          <p:cNvSpPr txBox="1"/>
+          <p:nvPr/>
+        </p:nvSpPr>
+        <p:spPr>
+          <a:xfrm>
+            <a:off x="8323150" y="3630618"/>
+            <a:ext cx="2603083" cy="369332"/>
+          </a:xfrm>
+          <a:prstGeom prst="rect">
+            <a:avLst/>
+          </a:prstGeom>
+          <a:noFill/>
+        </p:spPr>
+        <p:txBody>
+          <a:bodyPr wrap="square" rtlCol="0">
+            <a:spAutoFit/>
+          </a:bodyPr>
+          <a:lstStyle/>
+          <a:p>
+            <a:r>
+              <a:rPr lang="en-US" dirty="0"/>
+              <a:t>112.3s with 4025 token</a:t>
+            </a:r>
+            <a:endParaRPr lang="en-MY" dirty="0"/>
+          </a:p>
+        </p:txBody>
+      </p:sp>
+      <p:sp>
+        <p:nvSpPr>
+          <p:cNvPr id="15" name="TextBox 14">
+            <a:extLst>
+              <a:ext uri="{FF2B5EF4-FFF2-40B4-BE49-F238E27FC236}">
+                <a16:creationId xmlns:a16="http://schemas.microsoft.com/office/drawing/2014/main" id="{45E20E7C-F0D8-7A5F-0C7E-E89072A95996}"/>
+              </a:ext>
+            </a:extLst>
+          </p:cNvPr>
+          <p:cNvSpPr txBox="1"/>
+          <p:nvPr/>
+        </p:nvSpPr>
+        <p:spPr>
+          <a:xfrm>
+            <a:off x="2345617" y="3445952"/>
+            <a:ext cx="2785951" cy="369332"/>
+          </a:xfrm>
+          <a:prstGeom prst="rect">
+            <a:avLst/>
+          </a:prstGeom>
+          <a:noFill/>
+        </p:spPr>
+        <p:txBody>
+          <a:bodyPr wrap="square" rtlCol="0">
+            <a:spAutoFit/>
+          </a:bodyPr>
+          <a:lstStyle/>
+          <a:p>
+            <a:r>
+              <a:rPr lang="en-US" dirty="0"/>
+              <a:t>76.2s with 6849 token</a:t>
+            </a:r>
+            <a:endParaRPr lang="en-MY" dirty="0"/>
+          </a:p>
+        </p:txBody>
+      </p:sp>
+      <p:sp>
+        <p:nvSpPr>
+          <p:cNvPr id="17" name="TextBox 16">
+            <a:extLst>
+              <a:ext uri="{FF2B5EF4-FFF2-40B4-BE49-F238E27FC236}">
+                <a16:creationId xmlns:a16="http://schemas.microsoft.com/office/drawing/2014/main" id="{212C6922-07C3-9E4A-7D17-0B2FC3CE4A0B}"/>
+              </a:ext>
+            </a:extLst>
+          </p:cNvPr>
+          <p:cNvSpPr txBox="1"/>
+          <p:nvPr/>
+        </p:nvSpPr>
+        <p:spPr>
+          <a:xfrm>
+            <a:off x="7080875" y="5296892"/>
+            <a:ext cx="2603083" cy="369332"/>
+          </a:xfrm>
+          <a:prstGeom prst="rect">
+            <a:avLst/>
+          </a:prstGeom>
+          <a:noFill/>
+        </p:spPr>
+        <p:txBody>
+          <a:bodyPr wrap="square" rtlCol="0">
+            <a:spAutoFit/>
+          </a:bodyPr>
+          <a:lstStyle/>
+          <a:p>
+            <a:r>
+              <a:rPr lang="en-US" dirty="0"/>
+              <a:t>78.3 with 3792 token</a:t>
+            </a:r>
+            <a:endParaRPr lang="en-MY" dirty="0"/>
+          </a:p>
+        </p:txBody>
+      </p:sp>
+      <p:sp>
+        <p:nvSpPr>
+          <p:cNvPr id="19" name="TextBox 18">
+            <a:extLst>
+              <a:ext uri="{FF2B5EF4-FFF2-40B4-BE49-F238E27FC236}">
+                <a16:creationId xmlns:a16="http://schemas.microsoft.com/office/drawing/2014/main" id="{AD65B5AD-5C2E-67B1-F9CE-40F875E25068}"/>
+              </a:ext>
+            </a:extLst>
+          </p:cNvPr>
+          <p:cNvSpPr txBox="1"/>
+          <p:nvPr/>
+        </p:nvSpPr>
+        <p:spPr>
+          <a:xfrm>
+            <a:off x="2717800" y="6211669"/>
+            <a:ext cx="2041587" cy="646331"/>
+          </a:xfrm>
+          <a:prstGeom prst="rect">
+            <a:avLst/>
+          </a:prstGeom>
+          <a:noFill/>
+        </p:spPr>
+        <p:txBody>
+          <a:bodyPr wrap="square" rtlCol="0">
+            <a:spAutoFit/>
+          </a:bodyPr>
+          <a:lstStyle/>
+          <a:p>
+            <a:r>
+              <a:rPr lang="en-US" dirty="0"/>
+              <a:t>94.5s with 5965 token</a:t>
+            </a:r>
+            <a:endParaRPr lang="en-MY" dirty="0"/>
+          </a:p>
+        </p:txBody>
+      </p:sp>
+      <p:pic>
+        <p:nvPicPr>
+          <p:cNvPr id="21" name="Picture 20">
+            <a:extLst>
+              <a:ext uri="{FF2B5EF4-FFF2-40B4-BE49-F238E27FC236}">
+                <a16:creationId xmlns:a16="http://schemas.microsoft.com/office/drawing/2014/main" id="{BE266960-D5D8-2124-9E4A-61D662AD6557}"/>
+              </a:ext>
+            </a:extLst>
+          </p:cNvPr>
+          <p:cNvPicPr>
+            <a:picLocks noChangeAspect="1"/>
+          </p:cNvPicPr>
+          <p:nvPr/>
+        </p:nvPicPr>
+        <p:blipFill>
+          <a:blip r:embed="rId4"/>
+          <a:stretch>
+            <a:fillRect/>
+          </a:stretch>
+        </p:blipFill>
+        <p:spPr>
+          <a:xfrm>
+            <a:off x="1498268" y="4204276"/>
+            <a:ext cx="4597732" cy="1848524"/>
+          </a:xfrm>
+          <a:prstGeom prst="rect">
+            <a:avLst/>
+          </a:prstGeom>
+        </p:spPr>
+      </p:pic>
+      <p:sp>
+        <p:nvSpPr>
+          <p:cNvPr id="4" name="Rectangle 3">
+            <a:extLst>
+              <a:ext uri="{FF2B5EF4-FFF2-40B4-BE49-F238E27FC236}">
+                <a16:creationId xmlns:a16="http://schemas.microsoft.com/office/drawing/2014/main" id="{D92E8C59-AF86-5364-54A3-771CA7966E9C}"/>
               </a:ext>
             </a:extLst>
           </p:cNvPr>
@@ -5501,8 +6764,56 @@
         </p:nvSpPr>
         <p:spPr>
           <a:xfrm>
-            <a:off x="6733522" y="1288113"/>
-            <a:ext cx="409575" cy="1485900"/>
+            <a:off x="4215958" y="51650"/>
+            <a:ext cx="4166459" cy="707886"/>
+          </a:xfrm>
+          <a:prstGeom prst="rect">
+            <a:avLst/>
+          </a:prstGeom>
+          <a:noFill/>
+        </p:spPr>
+        <p:txBody>
+          <a:bodyPr wrap="square" lIns="91440" tIns="45720" rIns="91440" bIns="45720">
+            <a:spAutoFit/>
+          </a:bodyPr>
+          <a:lstStyle/>
+          <a:p>
+            <a:pPr algn="ctr"/>
+            <a:r>
+              <a:rPr lang="en-US" sz="4000" b="0" cap="none" spc="0" dirty="0">
+                <a:ln w="0"/>
+                <a:solidFill>
+                  <a:schemeClr val="tx1"/>
+                </a:solidFill>
+                <a:effectLst>
+                  <a:outerShdw blurRad="38100" dist="19050" dir="2700000" algn="tl" rotWithShape="0">
+                    <a:schemeClr val="dk1">
+                      <a:alpha val="40000"/>
+                    </a:schemeClr>
+                  </a:outerShdw>
+                </a:effectLst>
+              </a:rPr>
+              <a:t>OPEN ROUTER</a:t>
+            </a:r>
+          </a:p>
+        </p:txBody>
+      </p:sp>
+      <p:sp>
+        <p:nvSpPr>
+          <p:cNvPr id="9" name="Rectangle 8">
+            <a:extLst>
+              <a:ext uri="{FF2B5EF4-FFF2-40B4-BE49-F238E27FC236}">
+                <a16:creationId xmlns:a16="http://schemas.microsoft.com/office/drawing/2014/main" id="{4CE86C4F-EAC3-AE8C-1CBC-AA6C44B859B1}"/>
+              </a:ext>
+            </a:extLst>
+          </p:cNvPr>
+          <p:cNvSpPr/>
+          <p:nvPr/>
+        </p:nvSpPr>
+        <p:spPr>
+          <a:xfrm>
+            <a:off x="1429996" y="4682530"/>
+            <a:ext cx="356542" cy="1228725"/>
           </a:xfrm>
           <a:prstGeom prst="rect">
             <a:avLst/>
@@ -5541,194 +6852,20 @@
       </p:sp>
       <p:sp>
         <p:nvSpPr>
-          <p:cNvPr id="13" name="TextBox 12">
-            <a:extLst>
-              <a:ext uri="{FF2B5EF4-FFF2-40B4-BE49-F238E27FC236}">
-                <a16:creationId xmlns:a16="http://schemas.microsoft.com/office/drawing/2014/main" id="{C4375A12-4EDB-C772-8208-E1E4D9D37733}"/>
-              </a:ext>
-            </a:extLst>
-          </p:cNvPr>
-          <p:cNvSpPr txBox="1"/>
+          <p:cNvPr id="14" name="Rectangle 13">
+            <a:extLst>
+              <a:ext uri="{FF2B5EF4-FFF2-40B4-BE49-F238E27FC236}">
+                <a16:creationId xmlns:a16="http://schemas.microsoft.com/office/drawing/2014/main" id="{CEB3DD18-84AD-172D-AB4B-D55F174ABABB}"/>
+              </a:ext>
+            </a:extLst>
+          </p:cNvPr>
+          <p:cNvSpPr/>
           <p:nvPr/>
         </p:nvSpPr>
         <p:spPr>
           <a:xfrm>
-            <a:off x="8062765" y="3771900"/>
-            <a:ext cx="2468689" cy="369332"/>
-          </a:xfrm>
-          <a:prstGeom prst="rect">
-            <a:avLst/>
-          </a:prstGeom>
-          <a:noFill/>
-        </p:spPr>
-        <p:txBody>
-          <a:bodyPr wrap="none" rtlCol="0">
-            <a:spAutoFit/>
-          </a:bodyPr>
-          <a:lstStyle/>
-          <a:p>
-            <a:r>
-              <a:rPr lang="en-US" dirty="0"/>
-              <a:t>112.3s with 4025 token</a:t>
-            </a:r>
-            <a:endParaRPr lang="en-MY" dirty="0"/>
-          </a:p>
-        </p:txBody>
-      </p:sp>
-      <p:sp>
-        <p:nvSpPr>
-          <p:cNvPr id="15" name="TextBox 14">
-            <a:extLst>
-              <a:ext uri="{FF2B5EF4-FFF2-40B4-BE49-F238E27FC236}">
-                <a16:creationId xmlns:a16="http://schemas.microsoft.com/office/drawing/2014/main" id="{45E20E7C-F0D8-7A5F-0C7E-E89072A95996}"/>
-              </a:ext>
-            </a:extLst>
-          </p:cNvPr>
-          <p:cNvSpPr txBox="1"/>
-          <p:nvPr/>
-        </p:nvSpPr>
-        <p:spPr>
-          <a:xfrm>
-            <a:off x="2028479" y="3358635"/>
-            <a:ext cx="2345257" cy="369332"/>
-          </a:xfrm>
-          <a:prstGeom prst="rect">
-            <a:avLst/>
-          </a:prstGeom>
-          <a:noFill/>
-        </p:spPr>
-        <p:txBody>
-          <a:bodyPr wrap="none" rtlCol="0">
-            <a:spAutoFit/>
-          </a:bodyPr>
-          <a:lstStyle/>
-          <a:p>
-            <a:r>
-              <a:rPr lang="en-US" dirty="0"/>
-              <a:t>76.2s with 6849 token</a:t>
-            </a:r>
-            <a:endParaRPr lang="en-MY" dirty="0"/>
-          </a:p>
-        </p:txBody>
-      </p:sp>
-      <p:sp>
-        <p:nvSpPr>
-          <p:cNvPr id="17" name="TextBox 16">
-            <a:extLst>
-              <a:ext uri="{FF2B5EF4-FFF2-40B4-BE49-F238E27FC236}">
-                <a16:creationId xmlns:a16="http://schemas.microsoft.com/office/drawing/2014/main" id="{212C6922-07C3-9E4A-7D17-0B2FC3CE4A0B}"/>
-              </a:ext>
-            </a:extLst>
-          </p:cNvPr>
-          <p:cNvSpPr txBox="1"/>
-          <p:nvPr/>
-        </p:nvSpPr>
-        <p:spPr>
-          <a:xfrm>
-            <a:off x="8180585" y="4433922"/>
-            <a:ext cx="2233047" cy="369332"/>
-          </a:xfrm>
-          <a:prstGeom prst="rect">
-            <a:avLst/>
-          </a:prstGeom>
-          <a:noFill/>
-        </p:spPr>
-        <p:txBody>
-          <a:bodyPr wrap="none" rtlCol="0">
-            <a:spAutoFit/>
-          </a:bodyPr>
-          <a:lstStyle/>
-          <a:p>
-            <a:r>
-              <a:rPr lang="en-US" dirty="0"/>
-              <a:t>78.3 with 3792 token</a:t>
-            </a:r>
-            <a:endParaRPr lang="en-MY" dirty="0"/>
-          </a:p>
-        </p:txBody>
-      </p:sp>
-      <p:sp>
-        <p:nvSpPr>
-          <p:cNvPr id="19" name="TextBox 18">
-            <a:extLst>
-              <a:ext uri="{FF2B5EF4-FFF2-40B4-BE49-F238E27FC236}">
-                <a16:creationId xmlns:a16="http://schemas.microsoft.com/office/drawing/2014/main" id="{AD65B5AD-5C2E-67B1-F9CE-40F875E25068}"/>
-              </a:ext>
-            </a:extLst>
-          </p:cNvPr>
-          <p:cNvSpPr txBox="1"/>
-          <p:nvPr/>
-        </p:nvSpPr>
-        <p:spPr>
-          <a:xfrm>
-            <a:off x="2414130" y="6326017"/>
-            <a:ext cx="2345257" cy="369332"/>
-          </a:xfrm>
-          <a:prstGeom prst="rect">
-            <a:avLst/>
-          </a:prstGeom>
-          <a:noFill/>
-        </p:spPr>
-        <p:txBody>
-          <a:bodyPr wrap="none" rtlCol="0">
-            <a:spAutoFit/>
-          </a:bodyPr>
-          <a:lstStyle/>
-          <a:p>
-            <a:r>
-              <a:rPr lang="en-US" dirty="0"/>
-              <a:t>94.5s with 5965 token</a:t>
-            </a:r>
-            <a:endParaRPr lang="en-MY" dirty="0"/>
-          </a:p>
-        </p:txBody>
-      </p:sp>
-      <p:pic>
-        <p:nvPicPr>
-          <p:cNvPr id="21" name="Picture 20">
-            <a:extLst>
-              <a:ext uri="{FF2B5EF4-FFF2-40B4-BE49-F238E27FC236}">
-                <a16:creationId xmlns:a16="http://schemas.microsoft.com/office/drawing/2014/main" id="{BE266960-D5D8-2124-9E4A-61D662AD6557}"/>
-              </a:ext>
-            </a:extLst>
-          </p:cNvPr>
-          <p:cNvPicPr>
-            <a:picLocks noChangeAspect="1"/>
-          </p:cNvPicPr>
-          <p:nvPr/>
-        </p:nvPicPr>
-        <p:blipFill>
-          <a:blip r:embed="rId4"/>
-          <a:stretch>
-            <a:fillRect/>
-          </a:stretch>
-        </p:blipFill>
-        <p:spPr>
-          <a:xfrm>
-            <a:off x="814392" y="3899475"/>
-            <a:ext cx="5281608" cy="2123477"/>
-          </a:xfrm>
-          <a:prstGeom prst="rect">
-            <a:avLst/>
-          </a:prstGeom>
-        </p:spPr>
-      </p:pic>
-      <p:sp>
-        <p:nvSpPr>
-          <p:cNvPr id="23" name="Rectangle 22">
-            <a:extLst>
-              <a:ext uri="{FF2B5EF4-FFF2-40B4-BE49-F238E27FC236}">
-                <a16:creationId xmlns:a16="http://schemas.microsoft.com/office/drawing/2014/main" id="{791008E0-2BF6-F998-7962-BDA051632F36}"/>
-              </a:ext>
-            </a:extLst>
-          </p:cNvPr>
-          <p:cNvSpPr/>
-          <p:nvPr/>
-        </p:nvSpPr>
-        <p:spPr>
-          <a:xfrm>
-            <a:off x="814392" y="4295775"/>
-            <a:ext cx="409575" cy="1485900"/>
+            <a:off x="7278516" y="1936104"/>
+            <a:ext cx="356542" cy="1228725"/>
           </a:xfrm>
           <a:prstGeom prst="rect">
             <a:avLst/>
@@ -5783,7 +6920,13 @@
   <p:cSld>
     <p:spTree>
       <p:nvGrpSpPr>
-        <p:cNvPr id="1" name=""/>
+        <p:cNvPr id="1" name="">
+          <a:extLst>
+            <a:ext uri="{FF2B5EF4-FFF2-40B4-BE49-F238E27FC236}">
+              <a16:creationId xmlns:a16="http://schemas.microsoft.com/office/drawing/2014/main" id="{F15AE510-5D9D-948E-0956-130040369A75}"/>
+            </a:ext>
+          </a:extLst>
+        </p:cNvPr>
         <p:cNvGrpSpPr/>
         <p:nvPr/>
       </p:nvGrpSpPr>
@@ -5795,12 +6938,166 @@
           <a:chExt cx="0" cy="0"/>
         </a:xfrm>
       </p:grpSpPr>
+      <p:sp>
+        <p:nvSpPr>
+          <p:cNvPr id="6" name="Rectangle 5">
+            <a:extLst>
+              <a:ext uri="{FF2B5EF4-FFF2-40B4-BE49-F238E27FC236}">
+                <a16:creationId xmlns:a16="http://schemas.microsoft.com/office/drawing/2014/main" id="{47AF6895-1C2A-3D3A-484A-1FC55CEEAEBE}"/>
+              </a:ext>
+            </a:extLst>
+          </p:cNvPr>
+          <p:cNvSpPr/>
+          <p:nvPr/>
+        </p:nvSpPr>
+        <p:spPr>
+          <a:xfrm>
+            <a:off x="782296" y="343535"/>
+            <a:ext cx="4166459" cy="461665"/>
+          </a:xfrm>
+          <a:prstGeom prst="rect">
+            <a:avLst/>
+          </a:prstGeom>
+          <a:noFill/>
+        </p:spPr>
+        <p:txBody>
+          <a:bodyPr wrap="square" lIns="91440" tIns="45720" rIns="91440" bIns="45720">
+            <a:spAutoFit/>
+          </a:bodyPr>
+          <a:lstStyle/>
+          <a:p>
+            <a:pPr algn="ctr"/>
+            <a:r>
+              <a:rPr lang="en-US" sz="2400" dirty="0">
+                <a:ln w="0"/>
+                <a:effectLst>
+                  <a:outerShdw blurRad="38100" dist="19050" dir="2700000" algn="tl" rotWithShape="0">
+                    <a:schemeClr val="dk1">
+                      <a:alpha val="40000"/>
+                    </a:schemeClr>
+                  </a:outerShdw>
+                </a:effectLst>
+              </a:rPr>
+              <a:t>GPT-OOS 20B (free fastest)</a:t>
+            </a:r>
+          </a:p>
+        </p:txBody>
+      </p:sp>
+      <p:sp>
+        <p:nvSpPr>
+          <p:cNvPr id="10" name="Rectangle 9">
+            <a:extLst>
+              <a:ext uri="{FF2B5EF4-FFF2-40B4-BE49-F238E27FC236}">
+                <a16:creationId xmlns:a16="http://schemas.microsoft.com/office/drawing/2014/main" id="{B1BE19F2-9914-A6CA-B5F0-8C108826FBB2}"/>
+              </a:ext>
+            </a:extLst>
+          </p:cNvPr>
+          <p:cNvSpPr/>
+          <p:nvPr/>
+        </p:nvSpPr>
+        <p:spPr>
+          <a:xfrm>
+            <a:off x="7834461" y="320703"/>
+            <a:ext cx="2315297" cy="461665"/>
+          </a:xfrm>
+          <a:prstGeom prst="rect">
+            <a:avLst/>
+          </a:prstGeom>
+          <a:noFill/>
+        </p:spPr>
+        <p:txBody>
+          <a:bodyPr wrap="square" lIns="91440" tIns="45720" rIns="91440" bIns="45720">
+            <a:spAutoFit/>
+          </a:bodyPr>
+          <a:lstStyle/>
+          <a:p>
+            <a:pPr algn="ctr"/>
+            <a:r>
+              <a:rPr lang="en-US" sz="2400" b="0" cap="none" spc="0" dirty="0">
+                <a:ln w="0"/>
+                <a:solidFill>
+                  <a:schemeClr val="tx1"/>
+                </a:solidFill>
+                <a:effectLst>
+                  <a:outerShdw blurRad="38100" dist="19050" dir="2700000" algn="tl" rotWithShape="0">
+                    <a:schemeClr val="dk1">
+                      <a:alpha val="40000"/>
+                    </a:schemeClr>
+                  </a:outerShdw>
+                </a:effectLst>
+              </a:rPr>
+              <a:t>GPT-OOS 120B</a:t>
+            </a:r>
+          </a:p>
+        </p:txBody>
+      </p:sp>
+      <p:sp>
+        <p:nvSpPr>
+          <p:cNvPr id="4" name="Rectangle 3">
+            <a:extLst>
+              <a:ext uri="{FF2B5EF4-FFF2-40B4-BE49-F238E27FC236}">
+                <a16:creationId xmlns:a16="http://schemas.microsoft.com/office/drawing/2014/main" id="{468ED54B-6E92-D5C2-1593-A9F29EEAD06F}"/>
+              </a:ext>
+            </a:extLst>
+          </p:cNvPr>
+          <p:cNvSpPr/>
+          <p:nvPr/>
+        </p:nvSpPr>
+        <p:spPr>
+          <a:xfrm>
+            <a:off x="4480543" y="112050"/>
+            <a:ext cx="2927792" cy="707886"/>
+          </a:xfrm>
+          <a:prstGeom prst="rect">
+            <a:avLst/>
+          </a:prstGeom>
+          <a:noFill/>
+        </p:spPr>
+        <p:txBody>
+          <a:bodyPr wrap="square" lIns="91440" tIns="45720" rIns="91440" bIns="45720">
+            <a:spAutoFit/>
+          </a:bodyPr>
+          <a:lstStyle/>
+          <a:p>
+            <a:pPr algn="ctr"/>
+            <a:r>
+              <a:rPr lang="en-US" sz="4000" b="0" cap="none" spc="0" dirty="0" err="1">
+                <a:ln w="0"/>
+                <a:solidFill>
+                  <a:schemeClr val="tx1"/>
+                </a:solidFill>
+                <a:effectLst>
+                  <a:outerShdw blurRad="38100" dist="19050" dir="2700000" algn="tl" rotWithShape="0">
+                    <a:schemeClr val="dk1">
+                      <a:alpha val="40000"/>
+                    </a:schemeClr>
+                  </a:outerShdw>
+                </a:effectLst>
+              </a:rPr>
+              <a:t>Groq</a:t>
+            </a:r>
+            <a:endParaRPr lang="en-US" sz="4000" b="0" cap="none" spc="0" dirty="0">
+              <a:ln w="0"/>
+              <a:solidFill>
+                <a:schemeClr val="tx1"/>
+              </a:solidFill>
+              <a:effectLst>
+                <a:outerShdw blurRad="38100" dist="19050" dir="2700000" algn="tl" rotWithShape="0">
+                  <a:schemeClr val="dk1">
+                    <a:alpha val="40000"/>
+                  </a:schemeClr>
+                </a:outerShdw>
+              </a:effectLst>
+            </a:endParaRPr>
+          </a:p>
+        </p:txBody>
+      </p:sp>
       <p:pic>
         <p:nvPicPr>
-          <p:cNvPr id="5" name="Picture 4">
-            <a:extLst>
-              <a:ext uri="{FF2B5EF4-FFF2-40B4-BE49-F238E27FC236}">
-                <a16:creationId xmlns:a16="http://schemas.microsoft.com/office/drawing/2014/main" id="{CE86D122-665A-1204-703D-FF94B43B3207}"/>
+          <p:cNvPr id="11" name="Picture 10">
+            <a:extLst>
+              <a:ext uri="{FF2B5EF4-FFF2-40B4-BE49-F238E27FC236}">
+                <a16:creationId xmlns:a16="http://schemas.microsoft.com/office/drawing/2014/main" id="{F5E878C4-7ECB-8492-CA78-AE7237CAA3B5}"/>
               </a:ext>
             </a:extLst>
           </p:cNvPr>
@@ -5817,8 +7114,8 @@
         </p:blipFill>
         <p:spPr>
           <a:xfrm>
-            <a:off x="2371725" y="460871"/>
-            <a:ext cx="8025262" cy="4120654"/>
+            <a:off x="6695748" y="823875"/>
+            <a:ext cx="4592721" cy="2240569"/>
           </a:xfrm>
           <a:prstGeom prst="rect">
             <a:avLst/>
@@ -5827,10 +7124,10 @@
       </p:pic>
       <p:sp>
         <p:nvSpPr>
-          <p:cNvPr id="7" name="Rectangle 6">
-            <a:extLst>
-              <a:ext uri="{FF2B5EF4-FFF2-40B4-BE49-F238E27FC236}">
-                <a16:creationId xmlns:a16="http://schemas.microsoft.com/office/drawing/2014/main" id="{91FD3543-D30A-2D21-058B-CB0164D45589}"/>
+          <p:cNvPr id="14" name="Rectangle 13">
+            <a:extLst>
+              <a:ext uri="{FF2B5EF4-FFF2-40B4-BE49-F238E27FC236}">
+                <a16:creationId xmlns:a16="http://schemas.microsoft.com/office/drawing/2014/main" id="{2F89320E-CA82-C0E1-BCFE-5E74143B3A0E}"/>
               </a:ext>
             </a:extLst>
           </p:cNvPr>
@@ -5839,8 +7136,226 @@
         </p:nvSpPr>
         <p:spPr>
           <a:xfrm>
-            <a:off x="422042" y="4868001"/>
-            <a:ext cx="11347915" cy="584775"/>
+            <a:off x="6963586" y="1287658"/>
+            <a:ext cx="284939" cy="1103117"/>
+          </a:xfrm>
+          <a:prstGeom prst="rect">
+            <a:avLst/>
+          </a:prstGeom>
+          <a:noFill/>
+          <a:ln w="76200">
+            <a:solidFill>
+              <a:srgbClr val="FF0000"/>
+            </a:solidFill>
+          </a:ln>
+        </p:spPr>
+        <p:style>
+          <a:lnRef idx="2">
+            <a:schemeClr val="accent1">
+              <a:shade val="15000"/>
+            </a:schemeClr>
+          </a:lnRef>
+          <a:fillRef idx="1">
+            <a:schemeClr val="accent1"/>
+          </a:fillRef>
+          <a:effectRef idx="0">
+            <a:schemeClr val="accent1"/>
+          </a:effectRef>
+          <a:fontRef idx="minor">
+            <a:schemeClr val="lt1"/>
+          </a:fontRef>
+        </p:style>
+        <p:txBody>
+          <a:bodyPr rtlCol="0" anchor="ctr"/>
+          <a:lstStyle/>
+          <a:p>
+            <a:pPr algn="ctr"/>
+            <a:endParaRPr lang="en-MY"/>
+          </a:p>
+        </p:txBody>
+      </p:sp>
+      <p:pic>
+        <p:nvPicPr>
+          <p:cNvPr id="16" name="Picture 15">
+            <a:extLst>
+              <a:ext uri="{FF2B5EF4-FFF2-40B4-BE49-F238E27FC236}">
+                <a16:creationId xmlns:a16="http://schemas.microsoft.com/office/drawing/2014/main" id="{8045F728-77BE-F33A-4ED6-738D9B8A7B6C}"/>
+              </a:ext>
+            </a:extLst>
+          </p:cNvPr>
+          <p:cNvPicPr>
+            <a:picLocks noChangeAspect="1"/>
+          </p:cNvPicPr>
+          <p:nvPr/>
+        </p:nvPicPr>
+        <p:blipFill>
+          <a:blip r:embed="rId3"/>
+          <a:srcRect r="3854" b="3412"/>
+          <a:stretch>
+            <a:fillRect/>
+          </a:stretch>
+        </p:blipFill>
+        <p:spPr>
+          <a:xfrm>
+            <a:off x="479034" y="813078"/>
+            <a:ext cx="4469721" cy="2419620"/>
+          </a:xfrm>
+          <a:prstGeom prst="rect">
+            <a:avLst/>
+          </a:prstGeom>
+        </p:spPr>
+      </p:pic>
+      <p:sp>
+        <p:nvSpPr>
+          <p:cNvPr id="23" name="Rectangle 22">
+            <a:extLst>
+              <a:ext uri="{FF2B5EF4-FFF2-40B4-BE49-F238E27FC236}">
+                <a16:creationId xmlns:a16="http://schemas.microsoft.com/office/drawing/2014/main" id="{794308C7-BAC5-1D1E-9F52-5A6404010C94}"/>
+              </a:ext>
+            </a:extLst>
+          </p:cNvPr>
+          <p:cNvSpPr/>
+          <p:nvPr/>
+        </p:nvSpPr>
+        <p:spPr>
+          <a:xfrm>
+            <a:off x="1627272" y="1609725"/>
+            <a:ext cx="258678" cy="876300"/>
+          </a:xfrm>
+          <a:prstGeom prst="rect">
+            <a:avLst/>
+          </a:prstGeom>
+          <a:noFill/>
+          <a:ln w="76200">
+            <a:solidFill>
+              <a:srgbClr val="FF0000"/>
+            </a:solidFill>
+          </a:ln>
+        </p:spPr>
+        <p:style>
+          <a:lnRef idx="2">
+            <a:schemeClr val="accent1">
+              <a:shade val="15000"/>
+            </a:schemeClr>
+          </a:lnRef>
+          <a:fillRef idx="1">
+            <a:schemeClr val="accent1"/>
+          </a:fillRef>
+          <a:effectRef idx="0">
+            <a:schemeClr val="accent1"/>
+          </a:effectRef>
+          <a:fontRef idx="minor">
+            <a:schemeClr val="lt1"/>
+          </a:fontRef>
+        </p:style>
+        <p:txBody>
+          <a:bodyPr rtlCol="0" anchor="ctr"/>
+          <a:lstStyle/>
+          <a:p>
+            <a:pPr algn="ctr"/>
+            <a:endParaRPr lang="en-MY"/>
+          </a:p>
+        </p:txBody>
+      </p:sp>
+      <p:pic>
+        <p:nvPicPr>
+          <p:cNvPr id="25" name="Picture 24">
+            <a:extLst>
+              <a:ext uri="{FF2B5EF4-FFF2-40B4-BE49-F238E27FC236}">
+                <a16:creationId xmlns:a16="http://schemas.microsoft.com/office/drawing/2014/main" id="{E3C9A848-003A-9E23-B94C-4EFD4ACFCEEE}"/>
+              </a:ext>
+            </a:extLst>
+          </p:cNvPr>
+          <p:cNvPicPr>
+            <a:picLocks noChangeAspect="1"/>
+          </p:cNvPicPr>
+          <p:nvPr/>
+        </p:nvPicPr>
+        <p:blipFill>
+          <a:blip r:embed="rId4"/>
+          <a:srcRect t="12522" b="753"/>
+          <a:stretch>
+            <a:fillRect/>
+          </a:stretch>
+        </p:blipFill>
+        <p:spPr>
+          <a:xfrm>
+            <a:off x="479034" y="4045859"/>
+            <a:ext cx="4731141" cy="2555350"/>
+          </a:xfrm>
+          <a:prstGeom prst="rect">
+            <a:avLst/>
+          </a:prstGeom>
+        </p:spPr>
+      </p:pic>
+      <p:sp>
+        <p:nvSpPr>
+          <p:cNvPr id="27" name="Rectangle 26">
+            <a:extLst>
+              <a:ext uri="{FF2B5EF4-FFF2-40B4-BE49-F238E27FC236}">
+                <a16:creationId xmlns:a16="http://schemas.microsoft.com/office/drawing/2014/main" id="{CBEE6E88-8073-8B49-F90B-EAAB384067FD}"/>
+              </a:ext>
+            </a:extLst>
+          </p:cNvPr>
+          <p:cNvSpPr/>
+          <p:nvPr/>
+        </p:nvSpPr>
+        <p:spPr>
+          <a:xfrm>
+            <a:off x="1718511" y="4849238"/>
+            <a:ext cx="287655" cy="948591"/>
+          </a:xfrm>
+          <a:prstGeom prst="rect">
+            <a:avLst/>
+          </a:prstGeom>
+          <a:noFill/>
+          <a:ln w="76200">
+            <a:solidFill>
+              <a:srgbClr val="FF0000"/>
+            </a:solidFill>
+          </a:ln>
+        </p:spPr>
+        <p:style>
+          <a:lnRef idx="2">
+            <a:schemeClr val="accent1">
+              <a:shade val="15000"/>
+            </a:schemeClr>
+          </a:lnRef>
+          <a:fillRef idx="1">
+            <a:schemeClr val="accent1"/>
+          </a:fillRef>
+          <a:effectRef idx="0">
+            <a:schemeClr val="accent1"/>
+          </a:effectRef>
+          <a:fontRef idx="minor">
+            <a:schemeClr val="lt1"/>
+          </a:fontRef>
+        </p:style>
+        <p:txBody>
+          <a:bodyPr rtlCol="0" anchor="ctr"/>
+          <a:lstStyle/>
+          <a:p>
+            <a:pPr algn="ctr"/>
+            <a:endParaRPr lang="en-MY"/>
+          </a:p>
+        </p:txBody>
+      </p:sp>
+      <p:sp>
+        <p:nvSpPr>
+          <p:cNvPr id="29" name="Rectangle 28">
+            <a:extLst>
+              <a:ext uri="{FF2B5EF4-FFF2-40B4-BE49-F238E27FC236}">
+                <a16:creationId xmlns:a16="http://schemas.microsoft.com/office/drawing/2014/main" id="{52D08781-DE70-81CD-3E2B-0FB5985FD630}"/>
+              </a:ext>
+            </a:extLst>
+          </p:cNvPr>
+          <p:cNvSpPr/>
+          <p:nvPr/>
+        </p:nvSpPr>
+        <p:spPr>
+          <a:xfrm>
+            <a:off x="630664" y="3538530"/>
+            <a:ext cx="4166459" cy="461665"/>
           </a:xfrm>
           <a:prstGeom prst="rect">
             <a:avLst/>
@@ -5848,14 +7363,14 @@
           <a:noFill/>
         </p:spPr>
         <p:txBody>
-          <a:bodyPr wrap="none" lIns="91440" tIns="45720" rIns="91440" bIns="45720">
+          <a:bodyPr wrap="square" lIns="91440" tIns="45720" rIns="91440" bIns="45720">
             <a:spAutoFit/>
           </a:bodyPr>
           <a:lstStyle/>
           <a:p>
             <a:pPr algn="ctr"/>
             <a:r>
-              <a:rPr lang="en-US" sz="3200" dirty="0">
+              <a:rPr lang="en-US" sz="2400" dirty="0">
                 <a:ln w="0"/>
                 <a:effectLst>
                   <a:outerShdw blurRad="38100" dist="19050" dir="2700000" algn="tl" rotWithShape="0">
@@ -5865,28 +7380,15 @@
                   </a:outerShdw>
                 </a:effectLst>
               </a:rPr>
-              <a:t>Attention : Need to rename the “New Instance” into the variable</a:t>
-            </a:r>
-            <a:endParaRPr lang="en-US" sz="3200" b="0" cap="none" spc="0" dirty="0">
-              <a:ln w="0"/>
-              <a:solidFill>
-                <a:schemeClr val="tx1"/>
-              </a:solidFill>
-              <a:effectLst>
-                <a:outerShdw blurRad="38100" dist="19050" dir="2700000" algn="tl" rotWithShape="0">
-                  <a:schemeClr val="dk1">
-                    <a:alpha val="40000"/>
-                  </a:schemeClr>
-                </a:outerShdw>
-              </a:effectLst>
-            </a:endParaRPr>
+              <a:t>Qwen 3.8 27B (free)</a:t>
+            </a:r>
           </a:p>
         </p:txBody>
       </p:sp>
     </p:spTree>
     <p:extLst>
       <p:ext uri="{BB962C8B-B14F-4D97-AF65-F5344CB8AC3E}">
-        <p14:creationId xmlns:p14="http://schemas.microsoft.com/office/powerpoint/2010/main" val="3804746096"/>
+        <p14:creationId xmlns:p14="http://schemas.microsoft.com/office/powerpoint/2010/main" val="2030876090"/>
       </p:ext>
     </p:extLst>
   </p:cSld>

</xml_diff>

<commit_message>
Update XenAnalyticsTrans Timeline Project - integrate pseudocode
</commit_message>
<xml_diff>
--- a/Reference/briefing project.pptx
+++ b/Reference/briefing project.pptx
@@ -207,7 +207,7 @@
           <a:p>
             <a:fld id="{53B61C8E-81CB-4032-8EA4-7F2345ECEA2B}" type="datetimeFigureOut">
               <a:rPr lang="en-MY" smtClean="0"/>
-              <a:t>15/10/2026</a:t>
+              <a:t>19/10/2026</a:t>
             </a:fld>
             <a:endParaRPr lang="en-MY"/>
           </a:p>
@@ -708,7 +708,7 @@
           <a:p>
             <a:fld id="{4449257F-037A-47B5-A07B-A73CC606E6AA}" type="datetimeFigureOut">
               <a:rPr lang="en-MY" smtClean="0"/>
-              <a:t>15/10/2026</a:t>
+              <a:t>19/10/2026</a:t>
             </a:fld>
             <a:endParaRPr lang="en-MY"/>
           </a:p>
@@ -908,7 +908,7 @@
           <a:p>
             <a:fld id="{4449257F-037A-47B5-A07B-A73CC606E6AA}" type="datetimeFigureOut">
               <a:rPr lang="en-MY" smtClean="0"/>
-              <a:t>15/10/2026</a:t>
+              <a:t>19/10/2026</a:t>
             </a:fld>
             <a:endParaRPr lang="en-MY"/>
           </a:p>
@@ -1118,7 +1118,7 @@
           <a:p>
             <a:fld id="{4449257F-037A-47B5-A07B-A73CC606E6AA}" type="datetimeFigureOut">
               <a:rPr lang="en-MY" smtClean="0"/>
-              <a:t>15/10/2026</a:t>
+              <a:t>19/10/2026</a:t>
             </a:fld>
             <a:endParaRPr lang="en-MY"/>
           </a:p>
@@ -1318,7 +1318,7 @@
           <a:p>
             <a:fld id="{4449257F-037A-47B5-A07B-A73CC606E6AA}" type="datetimeFigureOut">
               <a:rPr lang="en-MY" smtClean="0"/>
-              <a:t>15/10/2026</a:t>
+              <a:t>19/10/2026</a:t>
             </a:fld>
             <a:endParaRPr lang="en-MY"/>
           </a:p>
@@ -1594,7 +1594,7 @@
           <a:p>
             <a:fld id="{4449257F-037A-47B5-A07B-A73CC606E6AA}" type="datetimeFigureOut">
               <a:rPr lang="en-MY" smtClean="0"/>
-              <a:t>15/10/2026</a:t>
+              <a:t>19/10/2026</a:t>
             </a:fld>
             <a:endParaRPr lang="en-MY"/>
           </a:p>
@@ -1862,7 +1862,7 @@
           <a:p>
             <a:fld id="{4449257F-037A-47B5-A07B-A73CC606E6AA}" type="datetimeFigureOut">
               <a:rPr lang="en-MY" smtClean="0"/>
-              <a:t>15/10/2026</a:t>
+              <a:t>19/10/2026</a:t>
             </a:fld>
             <a:endParaRPr lang="en-MY"/>
           </a:p>
@@ -2277,7 +2277,7 @@
           <a:p>
             <a:fld id="{4449257F-037A-47B5-A07B-A73CC606E6AA}" type="datetimeFigureOut">
               <a:rPr lang="en-MY" smtClean="0"/>
-              <a:t>15/10/2026</a:t>
+              <a:t>19/10/2026</a:t>
             </a:fld>
             <a:endParaRPr lang="en-MY"/>
           </a:p>
@@ -2419,7 +2419,7 @@
           <a:p>
             <a:fld id="{4449257F-037A-47B5-A07B-A73CC606E6AA}" type="datetimeFigureOut">
               <a:rPr lang="en-MY" smtClean="0"/>
-              <a:t>15/10/2026</a:t>
+              <a:t>19/10/2026</a:t>
             </a:fld>
             <a:endParaRPr lang="en-MY"/>
           </a:p>
@@ -2532,7 +2532,7 @@
           <a:p>
             <a:fld id="{4449257F-037A-47B5-A07B-A73CC606E6AA}" type="datetimeFigureOut">
               <a:rPr lang="en-MY" smtClean="0"/>
-              <a:t>15/10/2026</a:t>
+              <a:t>19/10/2026</a:t>
             </a:fld>
             <a:endParaRPr lang="en-MY"/>
           </a:p>
@@ -2845,7 +2845,7 @@
           <a:p>
             <a:fld id="{4449257F-037A-47B5-A07B-A73CC606E6AA}" type="datetimeFigureOut">
               <a:rPr lang="en-MY" smtClean="0"/>
-              <a:t>15/10/2026</a:t>
+              <a:t>19/10/2026</a:t>
             </a:fld>
             <a:endParaRPr lang="en-MY"/>
           </a:p>
@@ -3134,7 +3134,7 @@
           <a:p>
             <a:fld id="{4449257F-037A-47B5-A07B-A73CC606E6AA}" type="datetimeFigureOut">
               <a:rPr lang="en-MY" smtClean="0"/>
-              <a:t>15/10/2026</a:t>
+              <a:t>19/10/2026</a:t>
             </a:fld>
             <a:endParaRPr lang="en-MY"/>
           </a:p>
@@ -3377,7 +3377,7 @@
           <a:p>
             <a:fld id="{4449257F-037A-47B5-A07B-A73CC606E6AA}" type="datetimeFigureOut">
               <a:rPr lang="en-MY" smtClean="0"/>
-              <a:t>15/10/2026</a:t>
+              <a:t>19/10/2026</a:t>
             </a:fld>
             <a:endParaRPr lang="en-MY"/>
           </a:p>

</xml_diff>